<commit_message>
Add deeper POI analysis and final course materials
</commit_message>
<xml_diff>
--- a/docs/deliverables/答辩PPT.pptx
+++ b/docs/deliverables/答辩PPT.pptx
@@ -2,24 +2,25 @@
 <file path=ppt/presentation.xml><?xml version="1.0" encoding="utf-8"?>
 <p:presentation xmlns:p="http://schemas.openxmlformats.org/presentationml/2006/main">
   <p:sldMasterIdLst>
-    <p:sldMasterId xmlns:r="http://schemas.openxmlformats.org/officeDocument/2006/relationships" id="2147483648" r:id="R4ebbfb9a0f5146bd"/>
+    <p:sldMasterId xmlns:r="http://schemas.openxmlformats.org/officeDocument/2006/relationships" id="2147483648" r:id="R40f896700acc4e61"/>
   </p:sldMasterIdLst>
   <p:notesMasterIdLst>
-    <p:notesMasterId xmlns:r="http://schemas.openxmlformats.org/officeDocument/2006/relationships" r:id="R6f0e535fb56d4483"/>
+    <p:notesMasterId xmlns:r="http://schemas.openxmlformats.org/officeDocument/2006/relationships" r:id="R2af34e3726a84060"/>
   </p:notesMasterIdLst>
   <p:sldIdLst>
-    <p:sldId xmlns:r="http://schemas.openxmlformats.org/officeDocument/2006/relationships" id="256" r:id="Rff65f41490384a00"/>
-    <p:sldId xmlns:r="http://schemas.openxmlformats.org/officeDocument/2006/relationships" id="257" r:id="Re9eb3197e23f4bd2"/>
-    <p:sldId xmlns:r="http://schemas.openxmlformats.org/officeDocument/2006/relationships" id="258" r:id="R2a914d4b6ac6412e"/>
-    <p:sldId xmlns:r="http://schemas.openxmlformats.org/officeDocument/2006/relationships" id="259" r:id="R3ee9ec4d68024755"/>
-    <p:sldId xmlns:r="http://schemas.openxmlformats.org/officeDocument/2006/relationships" id="260" r:id="R5094837335004dbf"/>
-    <p:sldId xmlns:r="http://schemas.openxmlformats.org/officeDocument/2006/relationships" id="261" r:id="R7a140f18e71c434c"/>
-    <p:sldId xmlns:r="http://schemas.openxmlformats.org/officeDocument/2006/relationships" id="262" r:id="R919c571f162b434a"/>
-    <p:sldId xmlns:r="http://schemas.openxmlformats.org/officeDocument/2006/relationships" id="263" r:id="R1ceb2f37c46a44e1"/>
-    <p:sldId xmlns:r="http://schemas.openxmlformats.org/officeDocument/2006/relationships" id="264" r:id="R1693e1ddc1ad4301"/>
-    <p:sldId xmlns:r="http://schemas.openxmlformats.org/officeDocument/2006/relationships" id="265" r:id="R7c86399e70724931"/>
-    <p:sldId xmlns:r="http://schemas.openxmlformats.org/officeDocument/2006/relationships" id="266" r:id="R16a967daecf44cc8"/>
-    <p:sldId xmlns:r="http://schemas.openxmlformats.org/officeDocument/2006/relationships" id="267" r:id="Rac2fa19ba7ab4c35"/>
+    <p:sldId xmlns:r="http://schemas.openxmlformats.org/officeDocument/2006/relationships" id="256" r:id="Re3f12dc57d6a4c46"/>
+    <p:sldId xmlns:r="http://schemas.openxmlformats.org/officeDocument/2006/relationships" id="257" r:id="R0d675881f0144bc6"/>
+    <p:sldId xmlns:r="http://schemas.openxmlformats.org/officeDocument/2006/relationships" id="258" r:id="Ree22fbb4ff1449a1"/>
+    <p:sldId xmlns:r="http://schemas.openxmlformats.org/officeDocument/2006/relationships" id="259" r:id="Rf33e7cc616de4035"/>
+    <p:sldId xmlns:r="http://schemas.openxmlformats.org/officeDocument/2006/relationships" id="260" r:id="R0e854307787a4172"/>
+    <p:sldId xmlns:r="http://schemas.openxmlformats.org/officeDocument/2006/relationships" id="261" r:id="Ra4eefc04f0c94bc5"/>
+    <p:sldId xmlns:r="http://schemas.openxmlformats.org/officeDocument/2006/relationships" id="262" r:id="Re5052901339c4c44"/>
+    <p:sldId xmlns:r="http://schemas.openxmlformats.org/officeDocument/2006/relationships" id="263" r:id="Rcb1da62a4bba4e87"/>
+    <p:sldId xmlns:r="http://schemas.openxmlformats.org/officeDocument/2006/relationships" id="264" r:id="R152eb4ce25cb45b8"/>
+    <p:sldId xmlns:r="http://schemas.openxmlformats.org/officeDocument/2006/relationships" id="265" r:id="R4d7c45df992146c5"/>
+    <p:sldId xmlns:r="http://schemas.openxmlformats.org/officeDocument/2006/relationships" id="266" r:id="R8174203732cc4cc3"/>
+    <p:sldId xmlns:r="http://schemas.openxmlformats.org/officeDocument/2006/relationships" id="267" r:id="Rd7587a7c67304f6c"/>
+    <p:sldId xmlns:r="http://schemas.openxmlformats.org/officeDocument/2006/relationships" id="268" r:id="R95d9733cff9743a0"/>
   </p:sldIdLst>
   <p:sldSz cx="12192000" cy="6858000"/>
   <p:notesSz cx="6858000" cy="9144000"/>
@@ -548,7 +549,7 @@
           <a:lstStyle xmlns:a="http://schemas.openxmlformats.org/drawingml/2006/main"/>
           <a:p xmlns:a="http://schemas.openxmlformats.org/drawingml/2006/main">
             <a:r>
-              <a:t>预留约60秒现场演示：先看时间规律，再进入站点空间选择站点，切换出行模式，最后展示质量和导出。不要在答辩时重新训练模型。若现场演示未能完成，可用本页真实截图解释，但不能声称异机已通过。</a:t>
+              <a:t>约45秒。每种日类型的进出34项先归一化，减少规模对分组的主导；分组1呈工作日早进晚出突出。没有土地利用外部标签，不直接命名住宅区。固定seed42、n_init10仅帮助复现，无需在用户界面调参。本项目按MetroFlow公开数据计算，2017-05-01至08-31，302站、117个有效日期。</a:t>
             </a:r>
           </a:p>
           <a:p xmlns:a="http://schemas.openxmlformats.org/drawingml/2006/main">
@@ -563,12 +564,22 @@
           </a:p>
           <a:p xmlns:a="http://schemas.openxmlformats.org/drawingml/2006/main">
             <a:r>
-              <a:t>本地实际截图：docs/screenshots/S01-overview.png</a:t>
-            </a:r>
-          </a:p>
-          <a:p xmlns:a="http://schemas.openxmlformats.org/drawingml/2006/main">
-            <a:r>
-              <a:t>本地源码：app.py</a:t>
+              <a:t>本地结果：data/processed/clusters/evaluation.csv、说明.json</a:t>
+            </a:r>
+          </a:p>
+          <a:p xmlns:a="http://schemas.openxmlformats.org/drawingml/2006/main">
+            <a:r>
+              <a:t>https://scikit-learn.org/stable/modules/clustering.html</a:t>
+            </a:r>
+          </a:p>
+          <a:p xmlns:a="http://schemas.openxmlformats.org/drawingml/2006/main">
+            <a:r>
+              <a:t>https://doi.org/10.1038/s41597-025-05416-8</a:t>
+            </a:r>
+          </a:p>
+          <a:p xmlns:a="http://schemas.openxmlformats.org/drawingml/2006/main">
+            <a:r>
+              <a:t>https://doi.org/10.6084/m9.figshare.28844942</a:t>
             </a:r>
           </a:p>
           <a:p xmlns:a="http://schemas.openxmlformats.org/drawingml/2006/main">
@@ -643,7 +654,7 @@
           <a:lstStyle xmlns:a="http://schemas.openxmlformats.org/drawingml/2006/main"/>
           <a:p xmlns:a="http://schemas.openxmlformats.org/drawingml/2006/main">
             <a:r>
-              <a:t>约35秒。说明已完成的开发测试，避免把中文空格目录测试说成真实异机。代码ZIP小于30MB，运行环境单独打包。源代码、报告、PPT、个人调研和AI附件均在总包。</a:t>
+              <a:t>预留约75秒现场演示：先看时间规律，再进入站点空间选择站点，切换出行模式，展示天气和POI关联，最后查看质量与导出。不要在答辩时重新训练模型。若现场演示未能完成，可用本页真实截图解释，但不能声称异机已通过。</a:t>
             </a:r>
           </a:p>
           <a:p xmlns:a="http://schemas.openxmlformats.org/drawingml/2006/main">
@@ -658,7 +669,12 @@
           </a:p>
           <a:p xmlns:a="http://schemas.openxmlformats.org/drawingml/2006/main">
             <a:r>
-              <a:t>本地证据：docs/测试与验收记录.md、docs/ai-process/最终自动化测试.log、dist/包大小.json</a:t>
+              <a:t>本地实际截图：docs/screenshots/S01-overview.png</a:t>
+            </a:r>
+          </a:p>
+          <a:p xmlns:a="http://schemas.openxmlformats.org/drawingml/2006/main">
+            <a:r>
+              <a:t>本地源码：app.py</a:t>
             </a:r>
           </a:p>
           <a:p xmlns:a="http://schemas.openxmlformats.org/drawingml/2006/main">
@@ -733,6 +749,96 @@
           <a:lstStyle xmlns:a="http://schemas.openxmlformats.org/drawingml/2006/main"/>
           <a:p xmlns:a="http://schemas.openxmlformats.org/drawingml/2006/main">
             <a:r>
+              <a:t>约35秒。说明已完成的开发测试，避免把中文空格目录测试说成真实异机。代码ZIP小于30MB，运行环境单独打包。源代码、报告、PPT、个人调研和AI附件均在总包。</a:t>
+            </a:r>
+          </a:p>
+          <a:p xmlns:a="http://schemas.openxmlformats.org/drawingml/2006/main">
+            <a:r>
+              <a:t/>
+            </a:r>
+          </a:p>
+          <a:p xmlns:a="http://schemas.openxmlformats.org/drawingml/2006/main">
+            <a:r>
+              <a:t>[Sources]</a:t>
+            </a:r>
+          </a:p>
+          <a:p xmlns:a="http://schemas.openxmlformats.org/drawingml/2006/main">
+            <a:r>
+              <a:t>本地证据：docs/测试与验收记录.md、docs/ai-process/最终自动化测试.log、dist/包大小.json</a:t>
+            </a:r>
+          </a:p>
+          <a:p xmlns:a="http://schemas.openxmlformats.org/drawingml/2006/main">
+            <a:r>
+              <a:t>[/Sources]</a:t>
+            </a:r>
+          </a:p>
+        </p:txBody>
+      </p:sp>
+      <p:sp>
+        <p:nvSpPr>
+          <p:cNvPr id="4" name="Slide Number Placeholder 3"/>
+          <p:cNvSpPr>
+            <a:spLocks xmlns:a="http://schemas.openxmlformats.org/drawingml/2006/main" noGrp="1"/>
+          </p:cNvSpPr>
+          <p:nvPr>
+            <p:ph type="sldNum" idx="5"/>
+          </p:nvPr>
+        </p:nvSpPr>
+        <p:spPr/>
+        <p:txBody>
+          <a:bodyPr xmlns:a="http://schemas.openxmlformats.org/drawingml/2006/main"/>
+          <a:lstStyle xmlns:a="http://schemas.openxmlformats.org/drawingml/2006/main"/>
+          <a:p xmlns:a="http://schemas.openxmlformats.org/drawingml/2006/main"/>
+        </p:txBody>
+      </p:sp>
+    </p:spTree>
+  </p:cSld>
+  <p:clrMapOvr>
+    <a:masterClrMapping xmlns:a="http://schemas.openxmlformats.org/drawingml/2006/main"/>
+  </p:clrMapOvr>
+</p:notes>
+</file>
+
+<file path=ppt/notesSlides/notesSlide13.xml><?xml version="1.0" encoding="utf-8"?>
+<p:notes xmlns:p="http://schemas.openxmlformats.org/presentationml/2006/main">
+  <p:cSld>
+    <p:spTree>
+      <p:nvGrpSpPr>
+        <p:cNvPr id="1" name=""/>
+        <p:cNvGrpSpPr/>
+        <p:nvPr/>
+      </p:nvGrpSpPr>
+      <p:grpSpPr>
+        <a:xfrm xmlns:a="http://schemas.openxmlformats.org/drawingml/2006/main"/>
+      </p:grpSpPr>
+      <p:sp>
+        <p:nvSpPr>
+          <p:cNvPr id="2" name="Slide Image Placeholder 1"/>
+          <p:cNvSpPr>
+            <a:spLocks xmlns:a="http://schemas.openxmlformats.org/drawingml/2006/main" noGrp="1"/>
+          </p:cNvSpPr>
+          <p:nvPr>
+            <p:ph type="sldImg" idx="0"/>
+          </p:nvPr>
+        </p:nvSpPr>
+        <p:spPr/>
+      </p:sp>
+      <p:sp>
+        <p:nvSpPr>
+          <p:cNvPr id="3" name="Notes Placeholder 2"/>
+          <p:cNvSpPr>
+            <a:spLocks xmlns:a="http://schemas.openxmlformats.org/drawingml/2006/main" noGrp="1"/>
+          </p:cNvSpPr>
+          <p:nvPr>
+            <p:ph type="body" idx="1"/>
+          </p:nvPr>
+        </p:nvSpPr>
+        <p:spPr/>
+        <p:txBody>
+          <a:bodyPr xmlns:a="http://schemas.openxmlformats.org/drawingml/2006/main"/>
+          <a:lstStyle xmlns:a="http://schemas.openxmlformats.org/drawingml/2006/main"/>
+          <a:p xmlns:a="http://schemas.openxmlformats.org/drawingml/2006/main">
+            <a:r>
               <a:t>约30秒收尾，之后预留问答。团队计划各25%；Codex生成程序和材料，用户确定范围并指导精简。真实人工修改和验收在发生后记录，不补造贡献。可回答：为何排除六天？为何不做预测？为何选择2组？为何进站人次不等于人数？为什么双包？</a:t>
             </a:r>
           </a:p>
@@ -1498,7 +1604,7 @@
           <a:lstStyle xmlns:a="http://schemas.openxmlformats.org/drawingml/2006/main"/>
           <a:p xmlns:a="http://schemas.openxmlformats.org/drawingml/2006/main">
             <a:r>
-              <a:t>约45秒。每种日类型的进出34项先归一化，减少规模对分组的主导；分组1呈工作日早进晚出突出。没有土地利用外部标签，不直接命名住宅区。固定seed42、n_init10仅帮助复现，无需在用户界面调参。本项目按MetroFlow公开数据计算，2017-05-01至08-31，302站、117个有效日期。</a:t>
+              <a:t>约50秒。先将地铁站WGS84坐标转换为GCJ-02，再按球面距离统计500米和1公里范围POI。用383条地铁站POI验证后，中位坐标偏差从476.3米降到15.7米。密度与客流呈中等偏强正相关；功能多样性与客流相关较弱，区间跨零。高客流站就业金融占比较高，购物占比较低，但这里只报告关联，不做因果判断。POI数据共1625290条；排除地址、通行、室内和道路附属信息后，1303199条进入功能分析。花桥、光明路位于昆山，上海POI数据覆盖不到，因此周边计数为0。</a:t>
             </a:r>
           </a:p>
           <a:p xmlns:a="http://schemas.openxmlformats.org/drawingml/2006/main">
@@ -1513,22 +1619,17 @@
           </a:p>
           <a:p xmlns:a="http://schemas.openxmlformats.org/drawingml/2006/main">
             <a:r>
-              <a:t>本地结果：data/processed/clusters/evaluation.csv、说明.json</a:t>
-            </a:r>
-          </a:p>
-          <a:p xmlns:a="http://schemas.openxmlformats.org/drawingml/2006/main">
-            <a:r>
-              <a:t>https://scikit-learn.org/stable/modules/clustering.html</a:t>
-            </a:r>
-          </a:p>
-          <a:p xmlns:a="http://schemas.openxmlformats.org/drawingml/2006/main">
-            <a:r>
-              <a:t>https://doi.org/10.1038/s41597-025-05416-8</a:t>
-            </a:r>
-          </a:p>
-          <a:p xmlns:a="http://schemas.openxmlformats.org/drawingml/2006/main">
-            <a:r>
-              <a:t>https://doi.org/10.6084/m9.figshare.28844942</a:t>
+              <a:t>本地实际截图：docs/screenshots/S12-poi-analysis-top.png</a:t>
+            </a:r>
+          </a:p>
+          <a:p xmlns:a="http://schemas.openxmlformats.org/drawingml/2006/main">
+            <a:r>
+              <a:t>本地结果：data/processed/poi_stations.parquet、poi_quality.json</a:t>
+            </a:r>
+          </a:p>
+          <a:p xmlns:a="http://schemas.openxmlformats.org/drawingml/2006/main">
+            <a:r>
+              <a:t>本地源码：src/poi_processing.py、src/analysis.py</a:t>
             </a:r>
           </a:p>
           <a:p xmlns:a="http://schemas.openxmlformats.org/drawingml/2006/main">
@@ -1601,7 +1702,7 @@
   </p:cSld>
   <p:clrMap bg1="lt1" tx1="dk1" bg2="lt2" tx2="dk2" accent1="accent1" accent2="accent2" accent3="accent3" accent4="accent4" accent5="accent5" accent6="accent6" hlink="hlink" folHlink="folHlink"/>
   <p:sldLayoutIdLst>
-    <p:sldLayoutId xmlns:r="http://schemas.openxmlformats.org/officeDocument/2006/relationships" id="2147483649" r:id="R10b457b46be745d8"/>
+    <p:sldLayoutId xmlns:r="http://schemas.openxmlformats.org/officeDocument/2006/relationships" id="2147483649" r:id="Rf96ae10bba9145fe"/>
   </p:sldLayoutIdLst>
   <p:txStyles>
     <p:titleStyle>
@@ -2129,7 +2230,7 @@
 </file>
 
 <file path=ppt/slides/charts/chart1.xml><?xml version="1.0" encoding="utf-8"?>
-<c:chartSpace xmlns:c="http://schemas.openxmlformats.org/drawingml/2006/chart">
+<c:chartSpace xmlns:c="http://schemas.openxmlformats.org/drawingml/2006/chart" xmlns:r="http://schemas.openxmlformats.org/officeDocument/2006/relationships">
   <c:lang val="en-US"/>
   <c:chart>
     <c:plotArea>
@@ -2153,27 +2254,33 @@
             </a:ln>
           </c:spPr>
           <c:cat>
-            <c:strLit>
-              <c:ptCount val="2"/>
-              <c:pt idx="0">
-                <c:v>工作日</c:v>
-              </c:pt>
-              <c:pt idx="1">
-                <c:v>非工作日</c:v>
-              </c:pt>
-            </c:strLit>
+            <c:strRef>
+              <c:f>'Chart Data'!$A$2:$A$3</c:f>
+              <c:strCache>
+                <c:ptCount val="2"/>
+                <c:pt idx="0">
+                  <c:v>工作日</c:v>
+                </c:pt>
+                <c:pt idx="1">
+                  <c:v>非工作日</c:v>
+                </c:pt>
+              </c:strCache>
+            </c:strRef>
           </c:cat>
           <c:val>
-            <c:numLit>
-              <c:formatCode>General</c:formatCode>
-              <c:ptCount val="2"/>
-              <c:pt idx="0">
-                <c:v>699.3</c:v>
-              </c:pt>
-              <c:pt idx="1">
-                <c:v>451</c:v>
-              </c:pt>
-            </c:numLit>
+            <c:numRef>
+              <c:f>'Chart Data'!$B$2:$B$3</c:f>
+              <c:numCache>
+                <c:formatCode>General</c:formatCode>
+                <c:ptCount val="2"/>
+                <c:pt idx="0">
+                  <c:v>699.3</c:v>
+                </c:pt>
+                <c:pt idx="1">
+                  <c:v>451</c:v>
+                </c:pt>
+              </c:numCache>
+            </c:numRef>
           </c:val>
         </c:ser>
         <c:dLbls>
@@ -2186,6 +2293,9 @@
                   <a:solidFill>
                     <a:srgbClr val="123442"/>
                   </a:solidFill>
+                  <a:latin typeface="Microsoft YaHei"/>
+                  <a:ea typeface="Microsoft YaHei"/>
+                  <a:cs typeface="Microsoft YaHei"/>
                 </a:defRPr>
               </a:pPr>
             </a:p>
@@ -2229,6 +2339,9 @@
                 <a:solidFill>
                   <a:srgbClr val="536C77"/>
                 </a:solidFill>
+                <a:latin typeface="Microsoft YaHei"/>
+                <a:ea typeface="Microsoft YaHei"/>
+                <a:cs typeface="Microsoft YaHei"/>
               </a:defRPr>
             </a:pPr>
           </a:p>
@@ -2272,6 +2385,9 @@
                 <a:solidFill>
                   <a:srgbClr val="536C77"/>
                 </a:solidFill>
+                <a:latin typeface="Microsoft YaHei"/>
+                <a:ea typeface="Microsoft YaHei"/>
+                <a:cs typeface="Microsoft YaHei"/>
               </a:defRPr>
             </a:pPr>
           </a:p>
@@ -2292,11 +2408,14 @@
       <a:srgbClr val="F6F8FA"/>
     </a:solidFill>
   </c:spPr>
+  <c:externalData r:id="rIdChartSnapshot1">
+    <c:autoUpdate val="0"/>
+  </c:externalData>
 </c:chartSpace>
 </file>
 
 <file path=ppt/slides/charts/chart2.xml><?xml version="1.0" encoding="utf-8"?>
-<c:chartSpace xmlns:c="http://schemas.openxmlformats.org/drawingml/2006/chart">
+<c:chartSpace xmlns:c="http://schemas.openxmlformats.org/drawingml/2006/chart" xmlns:r="http://schemas.openxmlformats.org/officeDocument/2006/relationships">
   <c:lang val="en-US"/>
   <c:chart>
     <c:plotArea>
@@ -2320,33 +2439,39 @@
             </a:ln>
           </c:spPr>
           <c:cat>
-            <c:strLit>
-              <c:ptCount val="3"/>
-              <c:pt idx="0">
-                <c:v>通勤 C</c:v>
-              </c:pt>
-              <c:pt idx="1">
-                <c:v>居家其他 HBO</c:v>
-              </c:pt>
-              <c:pt idx="2">
-                <c:v>非居家 NHB</c:v>
-              </c:pt>
-            </c:strLit>
+            <c:strRef>
+              <c:f>'Chart Data'!$A$2:$A$4</c:f>
+              <c:strCache>
+                <c:ptCount val="3"/>
+                <c:pt idx="0">
+                  <c:v>通勤 C</c:v>
+                </c:pt>
+                <c:pt idx="1">
+                  <c:v>居家其他 HBO</c:v>
+                </c:pt>
+                <c:pt idx="2">
+                  <c:v>非居家 NHB</c:v>
+                </c:pt>
+              </c:strCache>
+            </c:strRef>
           </c:cat>
           <c:val>
-            <c:numLit>
-              <c:formatCode>General</c:formatCode>
-              <c:ptCount val="3"/>
-              <c:pt idx="0">
-                <c:v>32.03</c:v>
-              </c:pt>
-              <c:pt idx="1">
-                <c:v>29.51</c:v>
-              </c:pt>
-              <c:pt idx="2">
-                <c:v>38.46</c:v>
-              </c:pt>
-            </c:numLit>
+            <c:numRef>
+              <c:f>'Chart Data'!$B$2:$B$4</c:f>
+              <c:numCache>
+                <c:formatCode>General</c:formatCode>
+                <c:ptCount val="3"/>
+                <c:pt idx="0">
+                  <c:v>32.03</c:v>
+                </c:pt>
+                <c:pt idx="1">
+                  <c:v>29.51</c:v>
+                </c:pt>
+                <c:pt idx="2">
+                  <c:v>38.46</c:v>
+                </c:pt>
+              </c:numCache>
+            </c:numRef>
           </c:val>
         </c:ser>
         <c:dLbls>
@@ -2359,6 +2484,9 @@
                   <a:solidFill>
                     <a:srgbClr val="123442"/>
                   </a:solidFill>
+                  <a:latin typeface="Microsoft YaHei"/>
+                  <a:ea typeface="Microsoft YaHei"/>
+                  <a:cs typeface="Microsoft YaHei"/>
                 </a:defRPr>
               </a:pPr>
             </a:p>
@@ -2402,6 +2530,9 @@
                 <a:solidFill>
                   <a:srgbClr val="536C77"/>
                 </a:solidFill>
+                <a:latin typeface="Microsoft YaHei"/>
+                <a:ea typeface="Microsoft YaHei"/>
+                <a:cs typeface="Microsoft YaHei"/>
               </a:defRPr>
             </a:pPr>
           </a:p>
@@ -2445,6 +2576,9 @@
                 <a:solidFill>
                   <a:srgbClr val="536C77"/>
                 </a:solidFill>
+                <a:latin typeface="Microsoft YaHei"/>
+                <a:ea typeface="Microsoft YaHei"/>
+                <a:cs typeface="Microsoft YaHei"/>
               </a:defRPr>
             </a:pPr>
           </a:p>
@@ -2465,11 +2599,14 @@
       <a:srgbClr val="F6F8FA"/>
     </a:solidFill>
   </c:spPr>
+  <c:externalData r:id="rIdChartSnapshot1">
+    <c:autoUpdate val="0"/>
+  </c:externalData>
 </c:chartSpace>
 </file>
 
 <file path=ppt/slides/charts/chart3.xml><?xml version="1.0" encoding="utf-8"?>
-<c:chartSpace xmlns:c="http://schemas.openxmlformats.org/drawingml/2006/chart">
+<c:chartSpace xmlns:c="http://schemas.openxmlformats.org/drawingml/2006/chart" xmlns:r="http://schemas.openxmlformats.org/officeDocument/2006/relationships">
   <c:lang val="en-US"/>
   <c:chart>
     <c:plotArea>
@@ -2500,6 +2637,9 @@
                         <a:solidFill>
                           <a:srgbClr val="123442"/>
                         </a:solidFill>
+                        <a:latin typeface="Microsoft YaHei"/>
+                        <a:ea typeface="Microsoft YaHei"/>
+                        <a:cs typeface="Microsoft YaHei"/>
                       </a:rPr>
                       <a:t>0.427</a:t>
                     </a:r>
@@ -2515,6 +2655,9 @@
                       <a:solidFill>
                         <a:srgbClr val="123442"/>
                       </a:solidFill>
+                      <a:latin typeface="Microsoft YaHei"/>
+                      <a:ea typeface="Microsoft YaHei"/>
+                      <a:cs typeface="Microsoft YaHei"/>
                     </a:defRPr>
                   </a:pPr>
                 </a:p>
@@ -2538,6 +2681,9 @@
                         <a:solidFill>
                           <a:srgbClr val="123442"/>
                         </a:solidFill>
+                        <a:latin typeface="Microsoft YaHei"/>
+                        <a:ea typeface="Microsoft YaHei"/>
+                        <a:cs typeface="Microsoft YaHei"/>
                       </a:rPr>
                       <a:t>0.299</a:t>
                     </a:r>
@@ -2553,6 +2699,9 @@
                       <a:solidFill>
                         <a:srgbClr val="123442"/>
                       </a:solidFill>
+                      <a:latin typeface="Microsoft YaHei"/>
+                      <a:ea typeface="Microsoft YaHei"/>
+                      <a:cs typeface="Microsoft YaHei"/>
                     </a:defRPr>
                   </a:pPr>
                 </a:p>
@@ -2576,6 +2725,9 @@
                         <a:solidFill>
                           <a:srgbClr val="123442"/>
                         </a:solidFill>
+                        <a:latin typeface="Microsoft YaHei"/>
+                        <a:ea typeface="Microsoft YaHei"/>
+                        <a:cs typeface="Microsoft YaHei"/>
                       </a:rPr>
                       <a:t>0.260</a:t>
                     </a:r>
@@ -2591,6 +2743,9 @@
                       <a:solidFill>
                         <a:srgbClr val="123442"/>
                       </a:solidFill>
+                      <a:latin typeface="Microsoft YaHei"/>
+                      <a:ea typeface="Microsoft YaHei"/>
+                      <a:cs typeface="Microsoft YaHei"/>
                     </a:defRPr>
                   </a:pPr>
                 </a:p>
@@ -2614,6 +2769,9 @@
                         <a:solidFill>
                           <a:srgbClr val="123442"/>
                         </a:solidFill>
+                        <a:latin typeface="Microsoft YaHei"/>
+                        <a:ea typeface="Microsoft YaHei"/>
+                        <a:cs typeface="Microsoft YaHei"/>
                       </a:rPr>
                       <a:t>0.205</a:t>
                     </a:r>
@@ -2629,6 +2787,9 @@
                       <a:solidFill>
                         <a:srgbClr val="123442"/>
                       </a:solidFill>
+                      <a:latin typeface="Microsoft YaHei"/>
+                      <a:ea typeface="Microsoft YaHei"/>
+                      <a:cs typeface="Microsoft YaHei"/>
                     </a:defRPr>
                   </a:pPr>
                 </a:p>
@@ -2642,39 +2803,45 @@
             </c:dLbl>
           </c:dLbls>
           <c:cat>
-            <c:strLit>
-              <c:ptCount val="4"/>
-              <c:pt idx="0">
-                <c:v>2组</c:v>
-              </c:pt>
-              <c:pt idx="1">
-                <c:v>3组</c:v>
-              </c:pt>
-              <c:pt idx="2">
-                <c:v>4组</c:v>
-              </c:pt>
-              <c:pt idx="3">
-                <c:v>5组</c:v>
-              </c:pt>
-            </c:strLit>
+            <c:strRef>
+              <c:f>'Chart Data'!$A$2:$A$5</c:f>
+              <c:strCache>
+                <c:ptCount val="4"/>
+                <c:pt idx="0">
+                  <c:v>2组</c:v>
+                </c:pt>
+                <c:pt idx="1">
+                  <c:v>3组</c:v>
+                </c:pt>
+                <c:pt idx="2">
+                  <c:v>4组</c:v>
+                </c:pt>
+                <c:pt idx="3">
+                  <c:v>5组</c:v>
+                </c:pt>
+              </c:strCache>
+            </c:strRef>
           </c:cat>
           <c:val>
-            <c:numLit>
-              <c:formatCode>0.000</c:formatCode>
-              <c:ptCount val="4"/>
-              <c:pt idx="0">
-                <c:v>0.427</c:v>
-              </c:pt>
-              <c:pt idx="1">
-                <c:v>0.299</c:v>
-              </c:pt>
-              <c:pt idx="2">
-                <c:v>0.26</c:v>
-              </c:pt>
-              <c:pt idx="3">
-                <c:v>0.205</c:v>
-              </c:pt>
-            </c:numLit>
+            <c:numRef>
+              <c:f>'Chart Data'!$B$2:$B$5</c:f>
+              <c:numCache>
+                <c:formatCode>0.000</c:formatCode>
+                <c:ptCount val="4"/>
+                <c:pt idx="0">
+                  <c:v>0.427</c:v>
+                </c:pt>
+                <c:pt idx="1">
+                  <c:v>0.299</c:v>
+                </c:pt>
+                <c:pt idx="2">
+                  <c:v>0.26</c:v>
+                </c:pt>
+                <c:pt idx="3">
+                  <c:v>0.205</c:v>
+                </c:pt>
+              </c:numCache>
+            </c:numRef>
           </c:val>
         </c:ser>
         <c:dLbls>
@@ -2687,6 +2854,9 @@
                   <a:solidFill>
                     <a:srgbClr val="123442"/>
                   </a:solidFill>
+                  <a:latin typeface="Microsoft YaHei"/>
+                  <a:ea typeface="Microsoft YaHei"/>
+                  <a:cs typeface="Microsoft YaHei"/>
                 </a:defRPr>
               </a:pPr>
             </a:p>
@@ -2730,6 +2900,9 @@
                 <a:solidFill>
                   <a:srgbClr val="536C77"/>
                 </a:solidFill>
+                <a:latin typeface="Microsoft YaHei"/>
+                <a:ea typeface="Microsoft YaHei"/>
+                <a:cs typeface="Microsoft YaHei"/>
               </a:defRPr>
             </a:pPr>
           </a:p>
@@ -2773,6 +2946,9 @@
                 <a:solidFill>
                   <a:srgbClr val="536C77"/>
                 </a:solidFill>
+                <a:latin typeface="Microsoft YaHei"/>
+                <a:ea typeface="Microsoft YaHei"/>
+                <a:cs typeface="Microsoft YaHei"/>
               </a:defRPr>
             </a:pPr>
           </a:p>
@@ -2793,6 +2969,9 @@
       <a:srgbClr val="F6F8FA"/>
     </a:solidFill>
   </c:spPr>
+  <c:externalData r:id="rIdChartSnapshot1">
+    <c:autoUpdate val="0"/>
+  </c:externalData>
 </c:chartSpace>
 </file>
 
@@ -2820,7 +2999,7 @@
           <p:cNvPr id="6" name="">
             <a:extLst xmlns:a="http://schemas.openxmlformats.org/drawingml/2006/main">
               <a:ext uri="{FF2B5EF4-FFF2-40B4-BE49-F238E27FC236}">
-                <a16:creationId xmlns:a16="http://schemas.microsoft.com/office/drawing/2014/main" id="{AF3F7FA0-6CE4-48DC-A9D6-9017554E34D9}"/>
+                <a16:creationId xmlns:a16="http://schemas.microsoft.com/office/drawing/2014/main" id="{642A81E6-D0CD-46CF-A368-075FFEAE0548}"/>
               </a:ext>
             </a:extLst>
           </p:cNvPr>
@@ -2878,7 +3057,7 @@
           <p:cNvPr id="2" name="">
             <a:extLst xmlns:a="http://schemas.openxmlformats.org/drawingml/2006/main">
               <a:ext uri="{FF2B5EF4-FFF2-40B4-BE49-F238E27FC236}">
-                <a16:creationId xmlns:a16="http://schemas.microsoft.com/office/drawing/2014/main" id="{9DBC9FED-1D1E-4461-9422-3A1EEF520A45}"/>
+                <a16:creationId xmlns:a16="http://schemas.microsoft.com/office/drawing/2014/main" id="{D7EE46DC-353F-4C02-84D2-89C336211916}"/>
               </a:ext>
             </a:extLst>
           </p:cNvPr>
@@ -2936,7 +3115,7 @@
           <p:cNvPr id="3" name="">
             <a:extLst xmlns:a="http://schemas.openxmlformats.org/drawingml/2006/main">
               <a:ext uri="{FF2B5EF4-FFF2-40B4-BE49-F238E27FC236}">
-                <a16:creationId xmlns:a16="http://schemas.microsoft.com/office/drawing/2014/main" id="{2B2F13BC-B980-4941-8B0B-122D3822106A}"/>
+                <a16:creationId xmlns:a16="http://schemas.microsoft.com/office/drawing/2014/main" id="{89D2B1E0-4F11-464B-AFC5-12A25CE304C5}"/>
               </a:ext>
             </a:extLst>
           </p:cNvPr>
@@ -2994,7 +3173,7 @@
           <p:cNvPr id="4" name="">
             <a:extLst xmlns:a="http://schemas.openxmlformats.org/drawingml/2006/main">
               <a:ext uri="{FF2B5EF4-FFF2-40B4-BE49-F238E27FC236}">
-                <a16:creationId xmlns:a16="http://schemas.microsoft.com/office/drawing/2014/main" id="{73C5F145-84D6-4CFA-B2DB-860391B6F589}"/>
+                <a16:creationId xmlns:a16="http://schemas.microsoft.com/office/drawing/2014/main" id="{D6CA5F63-4C2A-4BD0-8F93-252335B00855}"/>
               </a:ext>
             </a:extLst>
           </p:cNvPr>
@@ -3052,7 +3231,7 @@
           <p:cNvPr id="5" name="">
             <a:extLst xmlns:a="http://schemas.openxmlformats.org/drawingml/2006/main">
               <a:ext uri="{FF2B5EF4-FFF2-40B4-BE49-F238E27FC236}">
-                <a16:creationId xmlns:a16="http://schemas.microsoft.com/office/drawing/2014/main" id="{08E44E45-389E-4C12-8819-2F1B0B29A0F9}"/>
+                <a16:creationId xmlns:a16="http://schemas.microsoft.com/office/drawing/2014/main" id="{20EDAEA3-2878-4D9A-817A-13A8530DD5B5}"/>
               </a:ext>
             </a:extLst>
           </p:cNvPr>
@@ -3108,7 +3287,7 @@
     </p:spTree>
     <p:extLst>
       <p:ext uri="{BB962C8B-B14F-4D97-AF65-F5344CB8AC3E}">
-        <p14:creationId xmlns:p14="http://schemas.microsoft.com/office/powerpoint/2010/main" val="1517372020"/>
+        <p14:creationId xmlns:p14="http://schemas.microsoft.com/office/powerpoint/2010/main" val="1008064526"/>
       </p:ext>
     </p:extLst>
   </p:cSld>
@@ -3139,7 +3318,7 @@
           <p:cNvPr id="9" name="">
             <a:extLst xmlns:a="http://schemas.openxmlformats.org/drawingml/2006/main">
               <a:ext uri="{FF2B5EF4-FFF2-40B4-BE49-F238E27FC236}">
-                <a16:creationId xmlns:a16="http://schemas.microsoft.com/office/drawing/2014/main" id="{24D9A24D-035A-429C-A932-59696A7D64D8}"/>
+                <a16:creationId xmlns:a16="http://schemas.microsoft.com/office/drawing/2014/main" id="{DECA84E8-A2CB-40EF-A984-F481FD9E80E8}"/>
               </a:ext>
             </a:extLst>
           </p:cNvPr>
@@ -3197,7 +3376,7 @@
           <p:cNvPr id="2" name="">
             <a:extLst xmlns:a="http://schemas.openxmlformats.org/drawingml/2006/main">
               <a:ext uri="{FF2B5EF4-FFF2-40B4-BE49-F238E27FC236}">
-                <a16:creationId xmlns:a16="http://schemas.microsoft.com/office/drawing/2014/main" id="{23E09D8B-B8E0-4271-8BA7-A0D56B53E7FE}"/>
+                <a16:creationId xmlns:a16="http://schemas.microsoft.com/office/drawing/2014/main" id="{14B5F891-6324-4C04-9097-AB07F818E350}"/>
               </a:ext>
             </a:extLst>
           </p:cNvPr>
@@ -3255,7 +3434,7 @@
           <p:cNvPr id="3" name="">
             <a:extLst xmlns:a="http://schemas.openxmlformats.org/drawingml/2006/main">
               <a:ext uri="{FF2B5EF4-FFF2-40B4-BE49-F238E27FC236}">
-                <a16:creationId xmlns:a16="http://schemas.microsoft.com/office/drawing/2014/main" id="{AA1F034A-BF88-4B1D-AA77-7F00362B818F}"/>
+                <a16:creationId xmlns:a16="http://schemas.microsoft.com/office/drawing/2014/main" id="{1EEE0493-6E77-4861-8A5C-F55C92EF54AA}"/>
               </a:ext>
             </a:extLst>
           </p:cNvPr>
@@ -3303,7 +3482,7 @@
                 <a:ea typeface="Microsoft YaHei"/>
                 <a:cs typeface="Microsoft YaHei"/>
               </a:rPr>
-              <a:t>一次演示：筛选、定位、解释、导出</a:t>
+              <a:t>相对曲线聚成2组，内部评价为0.427</a:t>
             </a:r>
           </a:p>
         </p:txBody>
@@ -3313,7 +3492,7 @@
           <p:cNvPr id="4" name="">
             <a:extLst xmlns:a="http://schemas.openxmlformats.org/drawingml/2006/main">
               <a:ext uri="{FF2B5EF4-FFF2-40B4-BE49-F238E27FC236}">
-                <a16:creationId xmlns:a16="http://schemas.microsoft.com/office/drawing/2014/main" id="{5FD3D860-4792-4678-AACD-99B645CBC1BE}"/>
+                <a16:creationId xmlns:a16="http://schemas.microsoft.com/office/drawing/2014/main" id="{5DC2A984-73D8-49A6-8B10-9107DD8C1D5B}"/>
               </a:ext>
             </a:extLst>
           </p:cNvPr>
@@ -3361,39 +3540,33 @@
                 <a:ea typeface="Microsoft YaHei"/>
                 <a:cs typeface="Microsoft YaHei"/>
               </a:rPr>
-              <a:t>六页系统共用清楚的统计口径。</a:t>
-            </a:r>
-          </a:p>
-        </p:txBody>
-      </p:sp>
-      <p:pic>
-        <p:nvPicPr>
-          <p:cNvPr id="13" name=""/>
-          <p:cNvPicPr>
-            <a:picLocks xmlns:a="http://schemas.openxmlformats.org/drawingml/2006/main" noChangeAspect="1"/>
-          </p:cNvPicPr>
-          <p:nvPr/>
-        </p:nvPicPr>
-        <p:blipFill>
-          <a:blip xmlns:r="http://schemas.openxmlformats.org/officeDocument/2006/relationships" xmlns:a="http://schemas.openxmlformats.org/drawingml/2006/main" r:embed="Rf1fdce86cbc94ef0"/>
-          <a:stretch xmlns:a="http://schemas.openxmlformats.org/drawingml/2006/main"/>
-        </p:blipFill>
-        <p:spPr>
-          <a:xfrm xmlns:a="http://schemas.openxmlformats.org/drawingml/2006/main">
-            <a:off x="1254654" y="2286000"/>
-            <a:ext cx="5825067" cy="4095750"/>
-          </a:xfrm>
-          <a:prstGeom xmlns:a="http://schemas.openxmlformats.org/drawingml/2006/main" prst="rect">
-            <a:avLst/>
-          </a:prstGeom>
-        </p:spPr>
-      </p:pic>
+              <a:t>初始参照为3组；统一比较2—5组后选择最高轮廓系数。</a:t>
+            </a:r>
+          </a:p>
+        </p:txBody>
+      </p:sp>
+      <p:graphicFrame>
+        <p:nvGraphicFramePr>
+          <p:cNvPr id="13" name="Chart"/>
+          <p:cNvGraphicFramePr/>
+          <p:nvPr/>
+        </p:nvGraphicFramePr>
+        <p:xfrm>
+          <a:off xmlns:a="http://schemas.openxmlformats.org/drawingml/2006/main" x="619125" y="2381250"/>
+          <a:ext xmlns:a="http://schemas.openxmlformats.org/drawingml/2006/main" cx="6953250" cy="3667125"/>
+        </p:xfrm>
+        <a:graphic xmlns:a="http://schemas.openxmlformats.org/drawingml/2006/main">
+          <a:graphicData uri="http://schemas.openxmlformats.org/drawingml/2006/chart">
+            <c:chart xmlns:r="http://schemas.openxmlformats.org/officeDocument/2006/relationships" xmlns:c="http://schemas.openxmlformats.org/drawingml/2006/chart" r:id="Rdea67d4f5b4e4312"/>
+          </a:graphicData>
+        </a:graphic>
+      </p:graphicFrame>
       <p:sp>
         <p:nvSpPr>
           <p:cNvPr id="6" name="">
             <a:extLst xmlns:a="http://schemas.openxmlformats.org/drawingml/2006/main">
               <a:ext uri="{FF2B5EF4-FFF2-40B4-BE49-F238E27FC236}">
-                <a16:creationId xmlns:a16="http://schemas.microsoft.com/office/drawing/2014/main" id="{76DF1F8F-E4A1-4844-A9FE-9EB2F98FF5C7}"/>
+                <a16:creationId xmlns:a16="http://schemas.microsoft.com/office/drawing/2014/main" id="{645928D4-1BB1-4FFB-9517-D21D92A2B328}"/>
               </a:ext>
             </a:extLst>
           </p:cNvPr>
@@ -3405,7 +3578,7 @@
         <p:spPr>
           <a:xfrm xmlns:a="http://schemas.openxmlformats.org/drawingml/2006/main">
             <a:off x="8096250" y="2571750"/>
-            <a:ext cx="3429000" cy="1047750"/>
+            <a:ext cx="3505200" cy="923925"/>
           </a:xfrm>
           <a:prstGeom xmlns:a="http://schemas.openxmlformats.org/drawingml/2006/main" prst="rect">
             <a:avLst/>
@@ -3441,7 +3614,7 @@
                 <a:ea typeface="Microsoft YaHei"/>
                 <a:cs typeface="Microsoft YaHei"/>
               </a:rPr>
-              <a:t>概览 → 时间 → 站点</a:t>
+              <a:t>175站 / 127站</a:t>
             </a:r>
           </a:p>
         </p:txBody>
@@ -3451,7 +3624,7 @@
           <p:cNvPr id="7" name="">
             <a:extLst xmlns:a="http://schemas.openxmlformats.org/drawingml/2006/main">
               <a:ext uri="{FF2B5EF4-FFF2-40B4-BE49-F238E27FC236}">
-                <a16:creationId xmlns:a16="http://schemas.microsoft.com/office/drawing/2014/main" id="{E23B0ED1-C755-47D8-B6CD-219319D61545}"/>
+                <a16:creationId xmlns:a16="http://schemas.microsoft.com/office/drawing/2014/main" id="{BC9AECAD-7553-4271-BA26-6D0CB1747F34}"/>
               </a:ext>
             </a:extLst>
           </p:cNvPr>
@@ -3462,8 +3635,8 @@
         </p:nvSpPr>
         <p:spPr>
           <a:xfrm xmlns:a="http://schemas.openxmlformats.org/drawingml/2006/main">
-            <a:off x="8096250" y="3762375"/>
-            <a:ext cx="3429000" cy="1047750"/>
+            <a:off x="8096250" y="3638550"/>
+            <a:ext cx="3505200" cy="923925"/>
           </a:xfrm>
           <a:prstGeom xmlns:a="http://schemas.openxmlformats.org/drawingml/2006/main" prst="rect">
             <a:avLst/>
@@ -3499,7 +3672,30 @@
                 <a:ea typeface="Microsoft YaHei"/>
                 <a:cs typeface="Microsoft YaHei"/>
               </a:rPr>
-              <a:t>出行模式 → 天气 → 质量</a:t>
+              <a:t>输入：两类日期 ×</a:t>
+            </a:r>
+          </a:p>
+          <a:p xmlns:a="http://schemas.openxmlformats.org/drawingml/2006/main">
+            <a:pPr>
+              <a:defRPr sz="2100" b="0">
+                <a:solidFill>
+                  <a:srgbClr val="123442"/>
+                </a:solidFill>
+                <a:latin typeface="Microsoft YaHei"/>
+                <a:ea typeface="Microsoft YaHei"/>
+                <a:cs typeface="Microsoft YaHei"/>
+              </a:defRPr>
+            </a:pPr>
+            <a:r>
+              <a:rPr sz="2100" b="0">
+                <a:solidFill>
+                  <a:srgbClr val="123442"/>
+                </a:solidFill>
+                <a:latin typeface="Microsoft YaHei"/>
+                <a:ea typeface="Microsoft YaHei"/>
+                <a:cs typeface="Microsoft YaHei"/>
+              </a:rPr>
+              <a:t>17小时 × 进出 = 68项</a:t>
             </a:r>
           </a:p>
         </p:txBody>
@@ -3509,7 +3705,7 @@
           <p:cNvPr id="8" name="">
             <a:extLst xmlns:a="http://schemas.openxmlformats.org/drawingml/2006/main">
               <a:ext uri="{FF2B5EF4-FFF2-40B4-BE49-F238E27FC236}">
-                <a16:creationId xmlns:a16="http://schemas.microsoft.com/office/drawing/2014/main" id="{69CF2A4B-36C7-4154-A963-E27BAB69F6B3}"/>
+                <a16:creationId xmlns:a16="http://schemas.microsoft.com/office/drawing/2014/main" id="{2CCC3599-45B4-43DA-9C91-E917BC628B80}"/>
               </a:ext>
             </a:extLst>
           </p:cNvPr>
@@ -3520,8 +3716,8 @@
         </p:nvSpPr>
         <p:spPr>
           <a:xfrm xmlns:a="http://schemas.openxmlformats.org/drawingml/2006/main">
-            <a:off x="8096250" y="4953000"/>
-            <a:ext cx="3429000" cy="1047750"/>
+            <a:off x="8096250" y="4705350"/>
+            <a:ext cx="3505200" cy="923925"/>
           </a:xfrm>
           <a:prstGeom xmlns:a="http://schemas.openxmlformats.org/drawingml/2006/main" prst="rect">
             <a:avLst/>
@@ -3557,7 +3753,7 @@
                 <a:ea typeface="Microsoft YaHei"/>
                 <a:cs typeface="Microsoft YaHei"/>
               </a:rPr>
-              <a:t>CSV保留筛选条件</a:t>
+              <a:t>评价已有数据的结构</a:t>
             </a:r>
           </a:p>
           <a:p xmlns:a="http://schemas.openxmlformats.org/drawingml/2006/main">
@@ -3580,7 +3776,7 @@
                 <a:ea typeface="Microsoft YaHei"/>
                 <a:cs typeface="Microsoft YaHei"/>
               </a:rPr>
-              <a:t>PNG保留图题与范围</a:t>
+              <a:t>不代表预测准确率</a:t>
             </a:r>
           </a:p>
         </p:txBody>
@@ -3588,7 +3784,7 @@
     </p:spTree>
     <p:extLst>
       <p:ext uri="{BB962C8B-B14F-4D97-AF65-F5344CB8AC3E}">
-        <p14:creationId xmlns:p14="http://schemas.microsoft.com/office/powerpoint/2010/main" val="249734260"/>
+        <p14:creationId xmlns:p14="http://schemas.microsoft.com/office/powerpoint/2010/main" val="342205429"/>
       </p:ext>
     </p:extLst>
   </p:cSld>
@@ -3619,7 +3815,7 @@
           <p:cNvPr id="9" name="">
             <a:extLst xmlns:a="http://schemas.openxmlformats.org/drawingml/2006/main">
               <a:ext uri="{FF2B5EF4-FFF2-40B4-BE49-F238E27FC236}">
-                <a16:creationId xmlns:a16="http://schemas.microsoft.com/office/drawing/2014/main" id="{F4F9216E-DAE7-4609-8846-49397790C5A5}"/>
+                <a16:creationId xmlns:a16="http://schemas.microsoft.com/office/drawing/2014/main" id="{4C73E5E7-5729-4754-BCEC-49ED705B33DC}"/>
               </a:ext>
             </a:extLst>
           </p:cNvPr>
@@ -3677,7 +3873,7 @@
           <p:cNvPr id="2" name="">
             <a:extLst xmlns:a="http://schemas.openxmlformats.org/drawingml/2006/main">
               <a:ext uri="{FF2B5EF4-FFF2-40B4-BE49-F238E27FC236}">
-                <a16:creationId xmlns:a16="http://schemas.microsoft.com/office/drawing/2014/main" id="{067CA155-8FDE-45EC-A090-2E1C866E1CFA}"/>
+                <a16:creationId xmlns:a16="http://schemas.microsoft.com/office/drawing/2014/main" id="{38E05396-063F-499F-AB36-E56BD9C77B86}"/>
               </a:ext>
             </a:extLst>
           </p:cNvPr>
@@ -3735,7 +3931,7 @@
           <p:cNvPr id="3" name="">
             <a:extLst xmlns:a="http://schemas.openxmlformats.org/drawingml/2006/main">
               <a:ext uri="{FF2B5EF4-FFF2-40B4-BE49-F238E27FC236}">
-                <a16:creationId xmlns:a16="http://schemas.microsoft.com/office/drawing/2014/main" id="{94483A1F-0DC9-4A05-A1F0-F88C9B5DC950}"/>
+                <a16:creationId xmlns:a16="http://schemas.microsoft.com/office/drawing/2014/main" id="{3DC4B7DB-79AF-4683-97C4-E5927488A577}"/>
               </a:ext>
             </a:extLst>
           </p:cNvPr>
@@ -3783,7 +3979,7 @@
                 <a:ea typeface="Microsoft YaHei"/>
                 <a:cs typeface="Microsoft YaHei"/>
               </a:rPr>
-              <a:t>把可运行与可解释一起交付</a:t>
+              <a:t>一次演示：筛选、定位、解释、导出</a:t>
             </a:r>
           </a:p>
         </p:txBody>
@@ -3793,7 +3989,7 @@
           <p:cNvPr id="4" name="">
             <a:extLst xmlns:a="http://schemas.openxmlformats.org/drawingml/2006/main">
               <a:ext uri="{FF2B5EF4-FFF2-40B4-BE49-F238E27FC236}">
-                <a16:creationId xmlns:a16="http://schemas.microsoft.com/office/drawing/2014/main" id="{322F0C78-BA94-446D-99B3-27327A0048A0}"/>
+                <a16:creationId xmlns:a16="http://schemas.microsoft.com/office/drawing/2014/main" id="{C7BE2074-16CE-4EA1-A309-B36FE58AF902}"/>
               </a:ext>
             </a:extLst>
           </p:cNvPr>
@@ -3841,17 +4037,39 @@
                 <a:ea typeface="Microsoft YaHei"/>
                 <a:cs typeface="Microsoft YaHei"/>
               </a:rPr>
-              <a:t>开发验证有记录，现场验收仍要实做。</a:t>
-            </a:r>
-          </a:p>
-        </p:txBody>
-      </p:sp>
-      <p:sp>
-        <p:nvSpPr>
-          <p:cNvPr id="5" name="">
+              <a:t>七页系统共用清楚的统计口径。</a:t>
+            </a:r>
+          </a:p>
+        </p:txBody>
+      </p:sp>
+      <p:pic>
+        <p:nvPicPr>
+          <p:cNvPr id="13" name=""/>
+          <p:cNvPicPr>
+            <a:picLocks xmlns:a="http://schemas.openxmlformats.org/drawingml/2006/main" noChangeAspect="1"/>
+          </p:cNvPicPr>
+          <p:nvPr/>
+        </p:nvPicPr>
+        <p:blipFill>
+          <a:blip xmlns:r="http://schemas.openxmlformats.org/officeDocument/2006/relationships" xmlns:a="http://schemas.openxmlformats.org/drawingml/2006/main" r:embed="Rfb8bfe07cd09474b"/>
+          <a:stretch xmlns:a="http://schemas.openxmlformats.org/drawingml/2006/main"/>
+        </p:blipFill>
+        <p:spPr>
+          <a:xfrm xmlns:a="http://schemas.openxmlformats.org/drawingml/2006/main">
+            <a:off x="1254654" y="2286000"/>
+            <a:ext cx="5825067" cy="4095750"/>
+          </a:xfrm>
+          <a:prstGeom xmlns:a="http://schemas.openxmlformats.org/drawingml/2006/main" prst="rect">
+            <a:avLst/>
+          </a:prstGeom>
+        </p:spPr>
+      </p:pic>
+      <p:sp>
+        <p:nvSpPr>
+          <p:cNvPr id="6" name="">
             <a:extLst xmlns:a="http://schemas.openxmlformats.org/drawingml/2006/main">
               <a:ext uri="{FF2B5EF4-FFF2-40B4-BE49-F238E27FC236}">
-                <a16:creationId xmlns:a16="http://schemas.microsoft.com/office/drawing/2014/main" id="{27CBDB47-7BBE-455A-96A2-8474606FCE82}"/>
+                <a16:creationId xmlns:a16="http://schemas.microsoft.com/office/drawing/2014/main" id="{D2F11063-9505-43D6-A5D6-391BD3E7C380}"/>
               </a:ext>
             </a:extLst>
           </p:cNvPr>
@@ -3862,8 +4080,8 @@
         </p:nvSpPr>
         <p:spPr>
           <a:xfrm xmlns:a="http://schemas.openxmlformats.org/drawingml/2006/main">
-            <a:off x="666750" y="2524125"/>
-            <a:ext cx="10477500" cy="666750"/>
+            <a:off x="8096250" y="2571750"/>
+            <a:ext cx="3429000" cy="1047750"/>
           </a:xfrm>
           <a:prstGeom xmlns:a="http://schemas.openxmlformats.org/drawingml/2006/main" prst="rect">
             <a:avLst/>
@@ -3881,7 +4099,7 @@
           <a:lstStyle xmlns:a="http://schemas.openxmlformats.org/drawingml/2006/main"/>
           <a:p xmlns:a="http://schemas.openxmlformats.org/drawingml/2006/main">
             <a:pPr>
-              <a:defRPr sz="3525" b="1">
+              <a:defRPr sz="2100" b="1">
                 <a:solidFill>
                   <a:srgbClr val="187887"/>
                 </a:solidFill>
@@ -3891,7 +4109,7 @@
               </a:defRPr>
             </a:pPr>
             <a:r>
-              <a:rPr sz="3525" b="1">
+              <a:rPr sz="2100" b="1">
                 <a:solidFill>
                   <a:srgbClr val="187887"/>
                 </a:solidFill>
@@ -3899,17 +4117,17 @@
                 <a:ea typeface="Microsoft YaHei"/>
                 <a:cs typeface="Microsoft YaHei"/>
               </a:rPr>
-              <a:t>13项测试通过</a:t>
-            </a:r>
-          </a:p>
-        </p:txBody>
-      </p:sp>
-      <p:sp>
-        <p:nvSpPr>
-          <p:cNvPr id="6" name="">
+              <a:t>概览 → 时间 → 站点</a:t>
+            </a:r>
+          </a:p>
+        </p:txBody>
+      </p:sp>
+      <p:sp>
+        <p:nvSpPr>
+          <p:cNvPr id="7" name="">
             <a:extLst xmlns:a="http://schemas.openxmlformats.org/drawingml/2006/main">
               <a:ext uri="{FF2B5EF4-FFF2-40B4-BE49-F238E27FC236}">
-                <a16:creationId xmlns:a16="http://schemas.microsoft.com/office/drawing/2014/main" id="{EEFA2074-8E51-4396-AB89-06231B3EE3EF}"/>
+                <a16:creationId xmlns:a16="http://schemas.microsoft.com/office/drawing/2014/main" id="{4F5DD7B0-D712-4045-8F9A-AAEFA97B4044}"/>
               </a:ext>
             </a:extLst>
           </p:cNvPr>
@@ -3920,8 +4138,8 @@
         </p:nvSpPr>
         <p:spPr>
           <a:xfrm xmlns:a="http://schemas.openxmlformats.org/drawingml/2006/main">
-            <a:off x="666750" y="3314700"/>
-            <a:ext cx="10668000" cy="571500"/>
+            <a:off x="8096250" y="3762375"/>
+            <a:ext cx="3429000" cy="1047750"/>
           </a:xfrm>
           <a:prstGeom xmlns:a="http://schemas.openxmlformats.org/drawingml/2006/main" prst="rect">
             <a:avLst/>
@@ -3939,35 +4157,35 @@
           <a:lstStyle xmlns:a="http://schemas.openxmlformats.org/drawingml/2006/main"/>
           <a:p xmlns:a="http://schemas.openxmlformats.org/drawingml/2006/main">
             <a:pPr>
-              <a:defRPr sz="2250" b="0">
-                <a:solidFill>
-                  <a:srgbClr val="123442"/>
-                </a:solidFill>
-                <a:latin typeface="Microsoft YaHei"/>
-                <a:ea typeface="Microsoft YaHei"/>
-                <a:cs typeface="Microsoft YaHei"/>
-              </a:defRPr>
-            </a:pPr>
-            <a:r>
-              <a:rPr sz="2250" b="0">
-                <a:solidFill>
-                  <a:srgbClr val="123442"/>
-                </a:solidFill>
-                <a:latin typeface="Microsoft YaHei"/>
-                <a:ea typeface="Microsoft YaHei"/>
-                <a:cs typeface="Microsoft YaHei"/>
-              </a:rPr>
-              <a:t>清洗边界、统计口径、六页与模式、筛选及空状态</a:t>
-            </a:r>
-          </a:p>
-        </p:txBody>
-      </p:sp>
-      <p:sp>
-        <p:nvSpPr>
-          <p:cNvPr id="7" name="">
+              <a:defRPr sz="2100" b="0">
+                <a:solidFill>
+                  <a:srgbClr val="123442"/>
+                </a:solidFill>
+                <a:latin typeface="Microsoft YaHei"/>
+                <a:ea typeface="Microsoft YaHei"/>
+                <a:cs typeface="Microsoft YaHei"/>
+              </a:defRPr>
+            </a:pPr>
+            <a:r>
+              <a:rPr sz="2100" b="0">
+                <a:solidFill>
+                  <a:srgbClr val="123442"/>
+                </a:solidFill>
+                <a:latin typeface="Microsoft YaHei"/>
+                <a:ea typeface="Microsoft YaHei"/>
+                <a:cs typeface="Microsoft YaHei"/>
+              </a:rPr>
+              <a:t>出行模式 → 天气 → POI</a:t>
+            </a:r>
+          </a:p>
+        </p:txBody>
+      </p:sp>
+      <p:sp>
+        <p:nvSpPr>
+          <p:cNvPr id="8" name="">
             <a:extLst xmlns:a="http://schemas.openxmlformats.org/drawingml/2006/main">
               <a:ext uri="{FF2B5EF4-FFF2-40B4-BE49-F238E27FC236}">
-                <a16:creationId xmlns:a16="http://schemas.microsoft.com/office/drawing/2014/main" id="{FA885F69-F93D-49C1-993C-43DF957FDD40}"/>
+                <a16:creationId xmlns:a16="http://schemas.microsoft.com/office/drawing/2014/main" id="{1C5DF343-B606-403E-9D10-CCBA3467F3AE}"/>
               </a:ext>
             </a:extLst>
           </p:cNvPr>
@@ -3978,8 +4196,8 @@
         </p:nvSpPr>
         <p:spPr>
           <a:xfrm xmlns:a="http://schemas.openxmlformats.org/drawingml/2006/main">
-            <a:off x="666750" y="4410075"/>
-            <a:ext cx="10668000" cy="552450"/>
+            <a:off x="8096250" y="4953000"/>
+            <a:ext cx="3429000" cy="1047750"/>
           </a:xfrm>
           <a:prstGeom xmlns:a="http://schemas.openxmlformats.org/drawingml/2006/main" prst="rect">
             <a:avLst/>
@@ -3997,83 +4215,25 @@
           <a:lstStyle xmlns:a="http://schemas.openxmlformats.org/drawingml/2006/main"/>
           <a:p xmlns:a="http://schemas.openxmlformats.org/drawingml/2006/main">
             <a:pPr>
-              <a:defRPr sz="2250" b="0">
-                <a:solidFill>
-                  <a:srgbClr val="123442"/>
-                </a:solidFill>
-                <a:latin typeface="Microsoft YaHei"/>
-                <a:ea typeface="Microsoft YaHei"/>
-                <a:cs typeface="Microsoft YaHei"/>
-              </a:defRPr>
-            </a:pPr>
-            <a:r>
-              <a:rPr sz="2250" b="0">
-                <a:solidFill>
-                  <a:srgbClr val="123442"/>
-                </a:solidFill>
-                <a:latin typeface="Microsoft YaHei"/>
-                <a:ea typeface="Microsoft YaHei"/>
-                <a:cs typeface="Microsoft YaHei"/>
-              </a:rPr>
-              <a:t>源代码ZIP约8.4MB；独立便携包内置Python与数据</a:t>
-            </a:r>
-          </a:p>
-        </p:txBody>
-      </p:sp>
-      <p:sp>
-        <p:nvSpPr>
-          <p:cNvPr id="8" name="">
-            <a:extLst xmlns:a="http://schemas.openxmlformats.org/drawingml/2006/main">
-              <a:ext uri="{FF2B5EF4-FFF2-40B4-BE49-F238E27FC236}">
-                <a16:creationId xmlns:a16="http://schemas.microsoft.com/office/drawing/2014/main" id="{75E2397F-CC82-44D2-B19F-B0D328838DE2}"/>
-              </a:ext>
-            </a:extLst>
-          </p:cNvPr>
-          <p:cNvSpPr>
-            <a:spLocks xmlns:a="http://schemas.openxmlformats.org/drawingml/2006/main" noGrp="1"/>
-          </p:cNvSpPr>
-          <p:nvPr/>
-        </p:nvSpPr>
-        <p:spPr>
-          <a:xfrm xmlns:a="http://schemas.openxmlformats.org/drawingml/2006/main">
-            <a:off x="666750" y="5572125"/>
-            <a:ext cx="10668000" cy="571500"/>
-          </a:xfrm>
-          <a:prstGeom xmlns:a="http://schemas.openxmlformats.org/drawingml/2006/main" prst="rect">
-            <a:avLst/>
-          </a:prstGeom>
-          <a:noFill xmlns:a="http://schemas.openxmlformats.org/drawingml/2006/main"/>
-          <a:ln xmlns:a="http://schemas.openxmlformats.org/drawingml/2006/main" w="0">
-            <a:noFill/>
-            <a:prstDash val="solid"/>
-          </a:ln>
-        </p:spPr>
-        <p:txBody>
-          <a:bodyPr xmlns:a="http://schemas.openxmlformats.org/drawingml/2006/main" lIns="0" tIns="0" rIns="0" bIns="0">
-            <a:noAutofit/>
-          </a:bodyPr>
-          <a:lstStyle xmlns:a="http://schemas.openxmlformats.org/drawingml/2006/main"/>
-          <a:p xmlns:a="http://schemas.openxmlformats.org/drawingml/2006/main">
-            <a:pPr>
-              <a:defRPr sz="2175" b="0">
-                <a:solidFill>
-                  <a:srgbClr val="536C77"/>
-                </a:solidFill>
-                <a:latin typeface="Microsoft YaHei"/>
-                <a:ea typeface="Microsoft YaHei"/>
-                <a:cs typeface="Microsoft YaHei"/>
-              </a:defRPr>
-            </a:pPr>
-            <a:r>
-              <a:rPr sz="2175" b="0">
-                <a:solidFill>
-                  <a:srgbClr val="536C77"/>
-                </a:solidFill>
-                <a:latin typeface="Microsoft YaHei"/>
-                <a:ea typeface="Microsoft YaHei"/>
-                <a:cs typeface="Microsoft YaHei"/>
-              </a:rPr>
-              <a:t>仍需：另一台Windows电脑断网测试、学号补齐、材料核验</a:t>
+              <a:defRPr sz="2100" b="0">
+                <a:solidFill>
+                  <a:srgbClr val="123442"/>
+                </a:solidFill>
+                <a:latin typeface="Microsoft YaHei"/>
+                <a:ea typeface="Microsoft YaHei"/>
+                <a:cs typeface="Microsoft YaHei"/>
+              </a:defRPr>
+            </a:pPr>
+            <a:r>
+              <a:rPr sz="2100" b="0">
+                <a:solidFill>
+                  <a:srgbClr val="123442"/>
+                </a:solidFill>
+                <a:latin typeface="Microsoft YaHei"/>
+                <a:ea typeface="Microsoft YaHei"/>
+                <a:cs typeface="Microsoft YaHei"/>
+              </a:rPr>
+              <a:t>质量核对与结果导出</a:t>
             </a:r>
           </a:p>
         </p:txBody>
@@ -4081,7 +4241,7 @@
     </p:spTree>
     <p:extLst>
       <p:ext uri="{BB962C8B-B14F-4D97-AF65-F5344CB8AC3E}">
-        <p14:creationId xmlns:p14="http://schemas.microsoft.com/office/powerpoint/2010/main" val="293869118"/>
+        <p14:creationId xmlns:p14="http://schemas.microsoft.com/office/powerpoint/2010/main" val="1358531908"/>
       </p:ext>
     </p:extLst>
   </p:cSld>
@@ -4109,10 +4269,503 @@
       </p:grpSpPr>
       <p:sp>
         <p:nvSpPr>
+          <p:cNvPr id="9" name="">
+            <a:extLst xmlns:a="http://schemas.openxmlformats.org/drawingml/2006/main">
+              <a:ext uri="{FF2B5EF4-FFF2-40B4-BE49-F238E27FC236}">
+                <a16:creationId xmlns:a16="http://schemas.microsoft.com/office/drawing/2014/main" id="{414AE672-AD2C-4320-A3F8-FB2874CF203D}"/>
+              </a:ext>
+            </a:extLst>
+          </p:cNvPr>
+          <p:cNvSpPr>
+            <a:spLocks xmlns:a="http://schemas.openxmlformats.org/drawingml/2006/main" noGrp="1"/>
+          </p:cNvSpPr>
+          <p:nvPr/>
+        </p:nvSpPr>
+        <p:spPr>
+          <a:xfrm xmlns:a="http://schemas.openxmlformats.org/drawingml/2006/main">
+            <a:off x="571500" y="266700"/>
+            <a:ext cx="8572500" cy="266700"/>
+          </a:xfrm>
+          <a:prstGeom xmlns:a="http://schemas.openxmlformats.org/drawingml/2006/main" prst="rect">
+            <a:avLst/>
+          </a:prstGeom>
+          <a:noFill xmlns:a="http://schemas.openxmlformats.org/drawingml/2006/main"/>
+          <a:ln xmlns:a="http://schemas.openxmlformats.org/drawingml/2006/main" w="0">
+            <a:noFill/>
+            <a:prstDash val="solid"/>
+          </a:ln>
+        </p:spPr>
+        <p:txBody>
+          <a:bodyPr xmlns:a="http://schemas.openxmlformats.org/drawingml/2006/main" lIns="0" tIns="0" rIns="0" bIns="0">
+            <a:noAutofit/>
+          </a:bodyPr>
+          <a:lstStyle xmlns:a="http://schemas.openxmlformats.org/drawingml/2006/main"/>
+          <a:p xmlns:a="http://schemas.openxmlformats.org/drawingml/2006/main">
+            <a:pPr>
+              <a:defRPr sz="1350" b="1">
+                <a:solidFill>
+                  <a:srgbClr val="187887"/>
+                </a:solidFill>
+                <a:latin typeface="Microsoft YaHei"/>
+                <a:ea typeface="Microsoft YaHei"/>
+                <a:cs typeface="Microsoft YaHei"/>
+              </a:defRPr>
+            </a:pPr>
+            <a:r>
+              <a:rPr sz="1350" b="1">
+                <a:solidFill>
+                  <a:srgbClr val="187887"/>
+                </a:solidFill>
+                <a:latin typeface="Microsoft YaHei"/>
+                <a:ea typeface="Microsoft YaHei"/>
+                <a:cs typeface="Microsoft YaHei"/>
+              </a:rPr>
+              <a:t>沪上流动  /  软件开发实践1</a:t>
+            </a:r>
+          </a:p>
+        </p:txBody>
+      </p:sp>
+      <p:sp>
+        <p:nvSpPr>
+          <p:cNvPr id="2" name="">
+            <a:extLst xmlns:a="http://schemas.openxmlformats.org/drawingml/2006/main">
+              <a:ext uri="{FF2B5EF4-FFF2-40B4-BE49-F238E27FC236}">
+                <a16:creationId xmlns:a16="http://schemas.microsoft.com/office/drawing/2014/main" id="{25EC9676-0B11-45FB-9391-A1F6D1E9B514}"/>
+              </a:ext>
+            </a:extLst>
+          </p:cNvPr>
+          <p:cNvSpPr>
+            <a:spLocks xmlns:a="http://schemas.openxmlformats.org/drawingml/2006/main" noGrp="1"/>
+          </p:cNvSpPr>
+          <p:nvPr/>
+        </p:nvSpPr>
+        <p:spPr>
+          <a:xfrm xmlns:a="http://schemas.openxmlformats.org/drawingml/2006/main">
+            <a:off x="10953750" y="266700"/>
+            <a:ext cx="666750" cy="266700"/>
+          </a:xfrm>
+          <a:prstGeom xmlns:a="http://schemas.openxmlformats.org/drawingml/2006/main" prst="rect">
+            <a:avLst/>
+          </a:prstGeom>
+          <a:noFill xmlns:a="http://schemas.openxmlformats.org/drawingml/2006/main"/>
+          <a:ln xmlns:a="http://schemas.openxmlformats.org/drawingml/2006/main" w="0">
+            <a:noFill/>
+            <a:prstDash val="solid"/>
+          </a:ln>
+        </p:spPr>
+        <p:txBody>
+          <a:bodyPr xmlns:a="http://schemas.openxmlformats.org/drawingml/2006/main" lIns="0" tIns="0" rIns="0" bIns="0">
+            <a:noAutofit/>
+          </a:bodyPr>
+          <a:lstStyle xmlns:a="http://schemas.openxmlformats.org/drawingml/2006/main"/>
+          <a:p xmlns:a="http://schemas.openxmlformats.org/drawingml/2006/main">
+            <a:pPr>
+              <a:defRPr sz="1350" b="0">
+                <a:solidFill>
+                  <a:srgbClr val="536C77"/>
+                </a:solidFill>
+                <a:latin typeface="Microsoft YaHei"/>
+                <a:ea typeface="Microsoft YaHei"/>
+                <a:cs typeface="Microsoft YaHei"/>
+              </a:defRPr>
+            </a:pPr>
+            <a:r>
+              <a:rPr sz="1350" b="0">
+                <a:solidFill>
+                  <a:srgbClr val="536C77"/>
+                </a:solidFill>
+                <a:latin typeface="Microsoft YaHei"/>
+                <a:ea typeface="Microsoft YaHei"/>
+                <a:cs typeface="Microsoft YaHei"/>
+              </a:rPr>
+              <a:t>12</a:t>
+            </a:r>
+          </a:p>
+        </p:txBody>
+      </p:sp>
+      <p:sp>
+        <p:nvSpPr>
+          <p:cNvPr id="3" name="">
+            <a:extLst xmlns:a="http://schemas.openxmlformats.org/drawingml/2006/main">
+              <a:ext uri="{FF2B5EF4-FFF2-40B4-BE49-F238E27FC236}">
+                <a16:creationId xmlns:a16="http://schemas.microsoft.com/office/drawing/2014/main" id="{7DB786DC-1020-477E-8975-65C9201EF2AC}"/>
+              </a:ext>
+            </a:extLst>
+          </p:cNvPr>
+          <p:cNvSpPr>
+            <a:spLocks xmlns:a="http://schemas.openxmlformats.org/drawingml/2006/main" noGrp="1"/>
+          </p:cNvSpPr>
+          <p:nvPr/>
+        </p:nvSpPr>
+        <p:spPr>
+          <a:xfrm xmlns:a="http://schemas.openxmlformats.org/drawingml/2006/main">
+            <a:off x="571500" y="828675"/>
+            <a:ext cx="11049000" cy="742950"/>
+          </a:xfrm>
+          <a:prstGeom xmlns:a="http://schemas.openxmlformats.org/drawingml/2006/main" prst="rect">
+            <a:avLst/>
+          </a:prstGeom>
+          <a:noFill xmlns:a="http://schemas.openxmlformats.org/drawingml/2006/main"/>
+          <a:ln xmlns:a="http://schemas.openxmlformats.org/drawingml/2006/main" w="0">
+            <a:noFill/>
+            <a:prstDash val="solid"/>
+          </a:ln>
+        </p:spPr>
+        <p:txBody>
+          <a:bodyPr xmlns:a="http://schemas.openxmlformats.org/drawingml/2006/main" lIns="0" tIns="0" rIns="0" bIns="0">
+            <a:noAutofit/>
+          </a:bodyPr>
+          <a:lstStyle xmlns:a="http://schemas.openxmlformats.org/drawingml/2006/main"/>
+          <a:p xmlns:a="http://schemas.openxmlformats.org/drawingml/2006/main">
+            <a:pPr>
+              <a:defRPr sz="3600" b="1">
+                <a:solidFill>
+                  <a:srgbClr val="123442"/>
+                </a:solidFill>
+                <a:latin typeface="Microsoft YaHei"/>
+                <a:ea typeface="Microsoft YaHei"/>
+                <a:cs typeface="Microsoft YaHei"/>
+              </a:defRPr>
+            </a:pPr>
+            <a:r>
+              <a:rPr sz="3600" b="1">
+                <a:solidFill>
+                  <a:srgbClr val="123442"/>
+                </a:solidFill>
+                <a:latin typeface="Microsoft YaHei"/>
+                <a:ea typeface="Microsoft YaHei"/>
+                <a:cs typeface="Microsoft YaHei"/>
+              </a:rPr>
+              <a:t>把可运行与可解释一起交付</a:t>
+            </a:r>
+          </a:p>
+        </p:txBody>
+      </p:sp>
+      <p:sp>
+        <p:nvSpPr>
+          <p:cNvPr id="4" name="">
+            <a:extLst xmlns:a="http://schemas.openxmlformats.org/drawingml/2006/main">
+              <a:ext uri="{FF2B5EF4-FFF2-40B4-BE49-F238E27FC236}">
+                <a16:creationId xmlns:a16="http://schemas.microsoft.com/office/drawing/2014/main" id="{8302329E-3AF0-4430-B7A4-0D6C1AC478E6}"/>
+              </a:ext>
+            </a:extLst>
+          </p:cNvPr>
+          <p:cNvSpPr>
+            <a:spLocks xmlns:a="http://schemas.openxmlformats.org/drawingml/2006/main" noGrp="1"/>
+          </p:cNvSpPr>
+          <p:nvPr/>
+        </p:nvSpPr>
+        <p:spPr>
+          <a:xfrm xmlns:a="http://schemas.openxmlformats.org/drawingml/2006/main">
+            <a:off x="571500" y="1638300"/>
+            <a:ext cx="11049000" cy="457200"/>
+          </a:xfrm>
+          <a:prstGeom xmlns:a="http://schemas.openxmlformats.org/drawingml/2006/main" prst="rect">
+            <a:avLst/>
+          </a:prstGeom>
+          <a:noFill xmlns:a="http://schemas.openxmlformats.org/drawingml/2006/main"/>
+          <a:ln xmlns:a="http://schemas.openxmlformats.org/drawingml/2006/main" w="0">
+            <a:noFill/>
+            <a:prstDash val="solid"/>
+          </a:ln>
+        </p:spPr>
+        <p:txBody>
+          <a:bodyPr xmlns:a="http://schemas.openxmlformats.org/drawingml/2006/main" lIns="0" tIns="0" rIns="0" bIns="0">
+            <a:noAutofit/>
+          </a:bodyPr>
+          <a:lstStyle xmlns:a="http://schemas.openxmlformats.org/drawingml/2006/main"/>
+          <a:p xmlns:a="http://schemas.openxmlformats.org/drawingml/2006/main">
+            <a:pPr>
+              <a:defRPr sz="1800" b="0">
+                <a:solidFill>
+                  <a:srgbClr val="536C77"/>
+                </a:solidFill>
+                <a:latin typeface="Microsoft YaHei"/>
+                <a:ea typeface="Microsoft YaHei"/>
+                <a:cs typeface="Microsoft YaHei"/>
+              </a:defRPr>
+            </a:pPr>
+            <a:r>
+              <a:rPr sz="1800" b="0">
+                <a:solidFill>
+                  <a:srgbClr val="536C77"/>
+                </a:solidFill>
+                <a:latin typeface="Microsoft YaHei"/>
+                <a:ea typeface="Microsoft YaHei"/>
+                <a:cs typeface="Microsoft YaHei"/>
+              </a:rPr>
+              <a:t>开发验证有记录，现场验收仍要实做。</a:t>
+            </a:r>
+          </a:p>
+        </p:txBody>
+      </p:sp>
+      <p:sp>
+        <p:nvSpPr>
+          <p:cNvPr id="5" name="">
+            <a:extLst xmlns:a="http://schemas.openxmlformats.org/drawingml/2006/main">
+              <a:ext uri="{FF2B5EF4-FFF2-40B4-BE49-F238E27FC236}">
+                <a16:creationId xmlns:a16="http://schemas.microsoft.com/office/drawing/2014/main" id="{2564B76E-75A0-410C-9AA1-508A03C891A0}"/>
+              </a:ext>
+            </a:extLst>
+          </p:cNvPr>
+          <p:cNvSpPr>
+            <a:spLocks xmlns:a="http://schemas.openxmlformats.org/drawingml/2006/main" noGrp="1"/>
+          </p:cNvSpPr>
+          <p:nvPr/>
+        </p:nvSpPr>
+        <p:spPr>
+          <a:xfrm xmlns:a="http://schemas.openxmlformats.org/drawingml/2006/main">
+            <a:off x="666750" y="2524125"/>
+            <a:ext cx="10477500" cy="666750"/>
+          </a:xfrm>
+          <a:prstGeom xmlns:a="http://schemas.openxmlformats.org/drawingml/2006/main" prst="rect">
+            <a:avLst/>
+          </a:prstGeom>
+          <a:noFill xmlns:a="http://schemas.openxmlformats.org/drawingml/2006/main"/>
+          <a:ln xmlns:a="http://schemas.openxmlformats.org/drawingml/2006/main" w="0">
+            <a:noFill/>
+            <a:prstDash val="solid"/>
+          </a:ln>
+        </p:spPr>
+        <p:txBody>
+          <a:bodyPr xmlns:a="http://schemas.openxmlformats.org/drawingml/2006/main" lIns="0" tIns="0" rIns="0" bIns="0">
+            <a:noAutofit/>
+          </a:bodyPr>
+          <a:lstStyle xmlns:a="http://schemas.openxmlformats.org/drawingml/2006/main"/>
+          <a:p xmlns:a="http://schemas.openxmlformats.org/drawingml/2006/main">
+            <a:pPr>
+              <a:defRPr sz="3525" b="1">
+                <a:solidFill>
+                  <a:srgbClr val="187887"/>
+                </a:solidFill>
+                <a:latin typeface="Microsoft YaHei"/>
+                <a:ea typeface="Microsoft YaHei"/>
+                <a:cs typeface="Microsoft YaHei"/>
+              </a:defRPr>
+            </a:pPr>
+            <a:r>
+              <a:rPr sz="3525" b="1">
+                <a:solidFill>
+                  <a:srgbClr val="187887"/>
+                </a:solidFill>
+                <a:latin typeface="Microsoft YaHei"/>
+                <a:ea typeface="Microsoft YaHei"/>
+                <a:cs typeface="Microsoft YaHei"/>
+              </a:rPr>
+              <a:t>19项测试通过</a:t>
+            </a:r>
+          </a:p>
+        </p:txBody>
+      </p:sp>
+      <p:sp>
+        <p:nvSpPr>
+          <p:cNvPr id="6" name="">
+            <a:extLst xmlns:a="http://schemas.openxmlformats.org/drawingml/2006/main">
+              <a:ext uri="{FF2B5EF4-FFF2-40B4-BE49-F238E27FC236}">
+                <a16:creationId xmlns:a16="http://schemas.microsoft.com/office/drawing/2014/main" id="{E7E74C4A-EDB8-428D-9FC7-C03169E9C7F9}"/>
+              </a:ext>
+            </a:extLst>
+          </p:cNvPr>
+          <p:cNvSpPr>
+            <a:spLocks xmlns:a="http://schemas.openxmlformats.org/drawingml/2006/main" noGrp="1"/>
+          </p:cNvSpPr>
+          <p:nvPr/>
+        </p:nvSpPr>
+        <p:spPr>
+          <a:xfrm xmlns:a="http://schemas.openxmlformats.org/drawingml/2006/main">
+            <a:off x="666750" y="3314700"/>
+            <a:ext cx="10668000" cy="571500"/>
+          </a:xfrm>
+          <a:prstGeom xmlns:a="http://schemas.openxmlformats.org/drawingml/2006/main" prst="rect">
+            <a:avLst/>
+          </a:prstGeom>
+          <a:noFill xmlns:a="http://schemas.openxmlformats.org/drawingml/2006/main"/>
+          <a:ln xmlns:a="http://schemas.openxmlformats.org/drawingml/2006/main" w="0">
+            <a:noFill/>
+            <a:prstDash val="solid"/>
+          </a:ln>
+        </p:spPr>
+        <p:txBody>
+          <a:bodyPr xmlns:a="http://schemas.openxmlformats.org/drawingml/2006/main" lIns="0" tIns="0" rIns="0" bIns="0">
+            <a:noAutofit/>
+          </a:bodyPr>
+          <a:lstStyle xmlns:a="http://schemas.openxmlformats.org/drawingml/2006/main"/>
+          <a:p xmlns:a="http://schemas.openxmlformats.org/drawingml/2006/main">
+            <a:pPr>
+              <a:defRPr sz="2250" b="0">
+                <a:solidFill>
+                  <a:srgbClr val="123442"/>
+                </a:solidFill>
+                <a:latin typeface="Microsoft YaHei"/>
+                <a:ea typeface="Microsoft YaHei"/>
+                <a:cs typeface="Microsoft YaHei"/>
+              </a:defRPr>
+            </a:pPr>
+            <a:r>
+              <a:rPr sz="2250" b="0">
+                <a:solidFill>
+                  <a:srgbClr val="123442"/>
+                </a:solidFill>
+                <a:latin typeface="Microsoft YaHei"/>
+                <a:ea typeface="Microsoft YaHei"/>
+                <a:cs typeface="Microsoft YaHei"/>
+              </a:rPr>
+              <a:t>清洗边界、统计口径、七页、POI处理、筛选及空状态</a:t>
+            </a:r>
+          </a:p>
+        </p:txBody>
+      </p:sp>
+      <p:sp>
+        <p:nvSpPr>
+          <p:cNvPr id="7" name="">
+            <a:extLst xmlns:a="http://schemas.openxmlformats.org/drawingml/2006/main">
+              <a:ext uri="{FF2B5EF4-FFF2-40B4-BE49-F238E27FC236}">
+                <a16:creationId xmlns:a16="http://schemas.microsoft.com/office/drawing/2014/main" id="{38D908C0-CBA9-4CC8-84C3-A3ADF8AE2E33}"/>
+              </a:ext>
+            </a:extLst>
+          </p:cNvPr>
+          <p:cNvSpPr>
+            <a:spLocks xmlns:a="http://schemas.openxmlformats.org/drawingml/2006/main" noGrp="1"/>
+          </p:cNvSpPr>
+          <p:nvPr/>
+        </p:nvSpPr>
+        <p:spPr>
+          <a:xfrm xmlns:a="http://schemas.openxmlformats.org/drawingml/2006/main">
+            <a:off x="666750" y="4410075"/>
+            <a:ext cx="10668000" cy="552450"/>
+          </a:xfrm>
+          <a:prstGeom xmlns:a="http://schemas.openxmlformats.org/drawingml/2006/main" prst="rect">
+            <a:avLst/>
+          </a:prstGeom>
+          <a:noFill xmlns:a="http://schemas.openxmlformats.org/drawingml/2006/main"/>
+          <a:ln xmlns:a="http://schemas.openxmlformats.org/drawingml/2006/main" w="0">
+            <a:noFill/>
+            <a:prstDash val="solid"/>
+          </a:ln>
+        </p:spPr>
+        <p:txBody>
+          <a:bodyPr xmlns:a="http://schemas.openxmlformats.org/drawingml/2006/main" lIns="0" tIns="0" rIns="0" bIns="0">
+            <a:noAutofit/>
+          </a:bodyPr>
+          <a:lstStyle xmlns:a="http://schemas.openxmlformats.org/drawingml/2006/main"/>
+          <a:p xmlns:a="http://schemas.openxmlformats.org/drawingml/2006/main">
+            <a:pPr>
+              <a:defRPr sz="2250" b="0">
+                <a:solidFill>
+                  <a:srgbClr val="123442"/>
+                </a:solidFill>
+                <a:latin typeface="Microsoft YaHei"/>
+                <a:ea typeface="Microsoft YaHei"/>
+                <a:cs typeface="Microsoft YaHei"/>
+              </a:defRPr>
+            </a:pPr>
+            <a:r>
+              <a:rPr sz="2250" b="0">
+                <a:solidFill>
+                  <a:srgbClr val="123442"/>
+                </a:solidFill>
+                <a:latin typeface="Microsoft YaHei"/>
+                <a:ea typeface="Microsoft YaHei"/>
+                <a:cs typeface="Microsoft YaHei"/>
+              </a:rPr>
+              <a:t>源代码ZIP小于30MB；独立便携包内置Python与数据</a:t>
+            </a:r>
+          </a:p>
+        </p:txBody>
+      </p:sp>
+      <p:sp>
+        <p:nvSpPr>
+          <p:cNvPr id="8" name="">
+            <a:extLst xmlns:a="http://schemas.openxmlformats.org/drawingml/2006/main">
+              <a:ext uri="{FF2B5EF4-FFF2-40B4-BE49-F238E27FC236}">
+                <a16:creationId xmlns:a16="http://schemas.microsoft.com/office/drawing/2014/main" id="{95915D1B-9E69-4577-BC91-3C944D6E46C2}"/>
+              </a:ext>
+            </a:extLst>
+          </p:cNvPr>
+          <p:cNvSpPr>
+            <a:spLocks xmlns:a="http://schemas.openxmlformats.org/drawingml/2006/main" noGrp="1"/>
+          </p:cNvSpPr>
+          <p:nvPr/>
+        </p:nvSpPr>
+        <p:spPr>
+          <a:xfrm xmlns:a="http://schemas.openxmlformats.org/drawingml/2006/main">
+            <a:off x="666750" y="5572125"/>
+            <a:ext cx="10668000" cy="571500"/>
+          </a:xfrm>
+          <a:prstGeom xmlns:a="http://schemas.openxmlformats.org/drawingml/2006/main" prst="rect">
+            <a:avLst/>
+          </a:prstGeom>
+          <a:noFill xmlns:a="http://schemas.openxmlformats.org/drawingml/2006/main"/>
+          <a:ln xmlns:a="http://schemas.openxmlformats.org/drawingml/2006/main" w="0">
+            <a:noFill/>
+            <a:prstDash val="solid"/>
+          </a:ln>
+        </p:spPr>
+        <p:txBody>
+          <a:bodyPr xmlns:a="http://schemas.openxmlformats.org/drawingml/2006/main" lIns="0" tIns="0" rIns="0" bIns="0">
+            <a:noAutofit/>
+          </a:bodyPr>
+          <a:lstStyle xmlns:a="http://schemas.openxmlformats.org/drawingml/2006/main"/>
+          <a:p xmlns:a="http://schemas.openxmlformats.org/drawingml/2006/main">
+            <a:pPr>
+              <a:defRPr sz="2175" b="0">
+                <a:solidFill>
+                  <a:srgbClr val="536C77"/>
+                </a:solidFill>
+                <a:latin typeface="Microsoft YaHei"/>
+                <a:ea typeface="Microsoft YaHei"/>
+                <a:cs typeface="Microsoft YaHei"/>
+              </a:defRPr>
+            </a:pPr>
+            <a:r>
+              <a:rPr sz="2175" b="0">
+                <a:solidFill>
+                  <a:srgbClr val="536C77"/>
+                </a:solidFill>
+                <a:latin typeface="Microsoft YaHei"/>
+                <a:ea typeface="Microsoft YaHei"/>
+                <a:cs typeface="Microsoft YaHei"/>
+              </a:rPr>
+              <a:t>仍需：另一台Windows电脑断网测试、学号补齐、材料核验</a:t>
+            </a:r>
+          </a:p>
+        </p:txBody>
+      </p:sp>
+    </p:spTree>
+    <p:extLst>
+      <p:ext uri="{BB962C8B-B14F-4D97-AF65-F5344CB8AC3E}">
+        <p14:creationId xmlns:p14="http://schemas.microsoft.com/office/powerpoint/2010/main" val="1744466245"/>
+      </p:ext>
+    </p:extLst>
+  </p:cSld>
+</p:sld>
+</file>
+
+<file path=ppt/slides/slide13.xml><?xml version="1.0" encoding="utf-8"?>
+<p:sld xmlns:p="http://schemas.openxmlformats.org/presentationml/2006/main">
+  <p:cSld>
+    <p:bg>
+      <p:bgPr>
+        <a:solidFill xmlns:a="http://schemas.openxmlformats.org/drawingml/2006/main">
+          <a:srgbClr val="F6F8FA"/>
+        </a:solidFill>
+      </p:bgPr>
+    </p:bg>
+    <p:spTree>
+      <p:nvGrpSpPr>
+        <p:cNvPr id="1" name=""/>
+        <p:cNvGrpSpPr/>
+        <p:nvPr/>
+      </p:nvGrpSpPr>
+      <p:grpSpPr>
+        <a:xfrm xmlns:a="http://schemas.openxmlformats.org/drawingml/2006/main"/>
+      </p:grpSpPr>
+      <p:sp>
+        <p:nvSpPr>
           <p:cNvPr id="11" name="">
             <a:extLst xmlns:a="http://schemas.openxmlformats.org/drawingml/2006/main">
               <a:ext uri="{FF2B5EF4-FFF2-40B4-BE49-F238E27FC236}">
-                <a16:creationId xmlns:a16="http://schemas.microsoft.com/office/drawing/2014/main" id="{7F2627D3-ADDA-40EA-B335-34B5129DCC8F}"/>
+                <a16:creationId xmlns:a16="http://schemas.microsoft.com/office/drawing/2014/main" id="{0943B76F-4B65-4055-8E80-D34BEE4DC381}"/>
               </a:ext>
             </a:extLst>
           </p:cNvPr>
@@ -4170,7 +4823,7 @@
           <p:cNvPr id="2" name="">
             <a:extLst xmlns:a="http://schemas.openxmlformats.org/drawingml/2006/main">
               <a:ext uri="{FF2B5EF4-FFF2-40B4-BE49-F238E27FC236}">
-                <a16:creationId xmlns:a16="http://schemas.microsoft.com/office/drawing/2014/main" id="{7F3B8511-8CA3-4627-A689-61F29F2FD0BD}"/>
+                <a16:creationId xmlns:a16="http://schemas.microsoft.com/office/drawing/2014/main" id="{CB94491A-118B-42F0-A90A-7C8EAAD681E5}"/>
               </a:ext>
             </a:extLst>
           </p:cNvPr>
@@ -4218,7 +4871,7 @@
                 <a:ea typeface="Microsoft YaHei"/>
                 <a:cs typeface="Microsoft YaHei"/>
               </a:rPr>
-              <a:t>12</a:t>
+              <a:t>13</a:t>
             </a:r>
           </a:p>
         </p:txBody>
@@ -4228,7 +4881,7 @@
           <p:cNvPr id="3" name="">
             <a:extLst xmlns:a="http://schemas.openxmlformats.org/drawingml/2006/main">
               <a:ext uri="{FF2B5EF4-FFF2-40B4-BE49-F238E27FC236}">
-                <a16:creationId xmlns:a16="http://schemas.microsoft.com/office/drawing/2014/main" id="{F26B6355-61C8-4273-8194-7F34E06AF38D}"/>
+                <a16:creationId xmlns:a16="http://schemas.microsoft.com/office/drawing/2014/main" id="{DCF432F6-0A69-4523-BCA6-499A7F6D1BE6}"/>
               </a:ext>
             </a:extLst>
           </p:cNvPr>
@@ -4286,7 +4939,7 @@
           <p:cNvPr id="4" name="">
             <a:extLst xmlns:a="http://schemas.openxmlformats.org/drawingml/2006/main">
               <a:ext uri="{FF2B5EF4-FFF2-40B4-BE49-F238E27FC236}">
-                <a16:creationId xmlns:a16="http://schemas.microsoft.com/office/drawing/2014/main" id="{95A003F4-C034-4F22-9E0F-97291082DC6C}"/>
+                <a16:creationId xmlns:a16="http://schemas.microsoft.com/office/drawing/2014/main" id="{5A2D336A-BDFA-45DA-AEC3-485C755B5D1E}"/>
               </a:ext>
             </a:extLst>
           </p:cNvPr>
@@ -4344,7 +4997,7 @@
           <p:cNvPr id="5" name="">
             <a:extLst xmlns:a="http://schemas.openxmlformats.org/drawingml/2006/main">
               <a:ext uri="{FF2B5EF4-FFF2-40B4-BE49-F238E27FC236}">
-                <a16:creationId xmlns:a16="http://schemas.microsoft.com/office/drawing/2014/main" id="{BE4A695D-EEE5-468F-9A56-F00676768F50}"/>
+                <a16:creationId xmlns:a16="http://schemas.microsoft.com/office/drawing/2014/main" id="{4C64D5BC-ECAE-43A6-9AAB-1F5FED7D3A90}"/>
               </a:ext>
             </a:extLst>
           </p:cNvPr>
@@ -4402,7 +5055,7 @@
           <p:cNvPr id="6" name="">
             <a:extLst xmlns:a="http://schemas.openxmlformats.org/drawingml/2006/main">
               <a:ext uri="{FF2B5EF4-FFF2-40B4-BE49-F238E27FC236}">
-                <a16:creationId xmlns:a16="http://schemas.microsoft.com/office/drawing/2014/main" id="{9D5D8F98-E33E-439F-ADF5-5B3B62497BED}"/>
+                <a16:creationId xmlns:a16="http://schemas.microsoft.com/office/drawing/2014/main" id="{9EB9DDDF-2D96-4A6D-B20F-ADB66E4AF067}"/>
               </a:ext>
             </a:extLst>
           </p:cNvPr>
@@ -4450,7 +5103,7 @@
                 <a:ea typeface="Microsoft YaHei"/>
                 <a:cs typeface="Microsoft YaHei"/>
               </a:rPr>
-              <a:t>时间与空间规律、方向与构成、天气关联、站点分组</a:t>
+              <a:t>时间与空间规律、方向与构成、天气和POI关联、站点分组</a:t>
             </a:r>
           </a:p>
         </p:txBody>
@@ -4460,7 +5113,7 @@
           <p:cNvPr id="7" name="">
             <a:extLst xmlns:a="http://schemas.openxmlformats.org/drawingml/2006/main">
               <a:ext uri="{FF2B5EF4-FFF2-40B4-BE49-F238E27FC236}">
-                <a16:creationId xmlns:a16="http://schemas.microsoft.com/office/drawing/2014/main" id="{827BA391-DEE3-4F35-9778-3A87026183AE}"/>
+                <a16:creationId xmlns:a16="http://schemas.microsoft.com/office/drawing/2014/main" id="{CA6FDFD4-5862-43A8-8320-8F85EF82FA7A}"/>
               </a:ext>
             </a:extLst>
           </p:cNvPr>
@@ -4518,7 +5171,7 @@
           <p:cNvPr id="8" name="">
             <a:extLst xmlns:a="http://schemas.openxmlformats.org/drawingml/2006/main">
               <a:ext uri="{FF2B5EF4-FFF2-40B4-BE49-F238E27FC236}">
-                <a16:creationId xmlns:a16="http://schemas.microsoft.com/office/drawing/2014/main" id="{4745C7F9-9E12-4941-A2CC-E6195F448A65}"/>
+                <a16:creationId xmlns:a16="http://schemas.microsoft.com/office/drawing/2014/main" id="{E751F651-E4D1-4FC6-A968-09019C94CF8B}"/>
               </a:ext>
             </a:extLst>
           </p:cNvPr>
@@ -4576,7 +5229,7 @@
           <p:cNvPr id="9" name="">
             <a:extLst xmlns:a="http://schemas.openxmlformats.org/drawingml/2006/main">
               <a:ext uri="{FF2B5EF4-FFF2-40B4-BE49-F238E27FC236}">
-                <a16:creationId xmlns:a16="http://schemas.microsoft.com/office/drawing/2014/main" id="{1BD95459-569A-4FE8-BDF9-748022400F54}"/>
+                <a16:creationId xmlns:a16="http://schemas.microsoft.com/office/drawing/2014/main" id="{C6861F08-59F3-4389-97CF-39EC8774281E}"/>
               </a:ext>
             </a:extLst>
           </p:cNvPr>
@@ -4634,7 +5287,7 @@
           <p:cNvPr id="10" name="">
             <a:extLst xmlns:a="http://schemas.openxmlformats.org/drawingml/2006/main">
               <a:ext uri="{FF2B5EF4-FFF2-40B4-BE49-F238E27FC236}">
-                <a16:creationId xmlns:a16="http://schemas.microsoft.com/office/drawing/2014/main" id="{5DA1C25E-DDB9-44C3-B3C7-038E587D1C4E}"/>
+                <a16:creationId xmlns:a16="http://schemas.microsoft.com/office/drawing/2014/main" id="{783DE08F-EAEE-4A80-B4EB-B5A87CB0BAFB}"/>
               </a:ext>
             </a:extLst>
           </p:cNvPr>
@@ -4682,7 +5335,7 @@
                 <a:ea typeface="Microsoft YaHei"/>
                 <a:cs typeface="Microsoft YaHei"/>
               </a:rPr>
-              <a:t>历史样本、单点天气；聚类仍需独立时期与外部资料验证</a:t>
+              <a:t>历史样本、单点天气、POI覆盖边界；关联结论不能代替因果分析</a:t>
             </a:r>
           </a:p>
         </p:txBody>
@@ -4690,7 +5343,7 @@
     </p:spTree>
     <p:extLst>
       <p:ext uri="{BB962C8B-B14F-4D97-AF65-F5344CB8AC3E}">
-        <p14:creationId xmlns:p14="http://schemas.microsoft.com/office/powerpoint/2010/main" val="233386533"/>
+        <p14:creationId xmlns:p14="http://schemas.microsoft.com/office/powerpoint/2010/main" val="70515814"/>
       </p:ext>
     </p:extLst>
   </p:cSld>
@@ -4718,10 +5371,532 @@
       </p:grpSpPr>
       <p:sp>
         <p:nvSpPr>
+          <p:cNvPr id="11" name="">
+            <a:extLst xmlns:a="http://schemas.openxmlformats.org/drawingml/2006/main">
+              <a:ext uri="{FF2B5EF4-FFF2-40B4-BE49-F238E27FC236}">
+                <a16:creationId xmlns:a16="http://schemas.microsoft.com/office/drawing/2014/main" id="{6F89A4CF-483F-4374-9306-75108B5937E2}"/>
+              </a:ext>
+            </a:extLst>
+          </p:cNvPr>
+          <p:cNvSpPr>
+            <a:spLocks xmlns:a="http://schemas.openxmlformats.org/drawingml/2006/main" noGrp="1"/>
+          </p:cNvSpPr>
+          <p:nvPr/>
+        </p:nvSpPr>
+        <p:spPr>
+          <a:xfrm xmlns:a="http://schemas.openxmlformats.org/drawingml/2006/main">
+            <a:off x="571500" y="266700"/>
+            <a:ext cx="8572500" cy="266700"/>
+          </a:xfrm>
+          <a:prstGeom xmlns:a="http://schemas.openxmlformats.org/drawingml/2006/main" prst="rect">
+            <a:avLst/>
+          </a:prstGeom>
+          <a:noFill xmlns:a="http://schemas.openxmlformats.org/drawingml/2006/main"/>
+          <a:ln xmlns:a="http://schemas.openxmlformats.org/drawingml/2006/main" w="0">
+            <a:noFill/>
+            <a:prstDash val="solid"/>
+          </a:ln>
+        </p:spPr>
+        <p:txBody>
+          <a:bodyPr xmlns:a="http://schemas.openxmlformats.org/drawingml/2006/main" lIns="0" tIns="0" rIns="0" bIns="0">
+            <a:noAutofit/>
+          </a:bodyPr>
+          <a:lstStyle xmlns:a="http://schemas.openxmlformats.org/drawingml/2006/main"/>
+          <a:p xmlns:a="http://schemas.openxmlformats.org/drawingml/2006/main">
+            <a:pPr>
+              <a:defRPr sz="1350" b="1">
+                <a:solidFill>
+                  <a:srgbClr val="187887"/>
+                </a:solidFill>
+                <a:latin typeface="Microsoft YaHei"/>
+                <a:ea typeface="Microsoft YaHei"/>
+                <a:cs typeface="Microsoft YaHei"/>
+              </a:defRPr>
+            </a:pPr>
+            <a:r>
+              <a:rPr sz="1350" b="1">
+                <a:solidFill>
+                  <a:srgbClr val="187887"/>
+                </a:solidFill>
+                <a:latin typeface="Microsoft YaHei"/>
+                <a:ea typeface="Microsoft YaHei"/>
+                <a:cs typeface="Microsoft YaHei"/>
+              </a:rPr>
+              <a:t>沪上流动  /  软件开发实践1</a:t>
+            </a:r>
+          </a:p>
+        </p:txBody>
+      </p:sp>
+      <p:sp>
+        <p:nvSpPr>
+          <p:cNvPr id="2" name="">
+            <a:extLst xmlns:a="http://schemas.openxmlformats.org/drawingml/2006/main">
+              <a:ext uri="{FF2B5EF4-FFF2-40B4-BE49-F238E27FC236}">
+                <a16:creationId xmlns:a16="http://schemas.microsoft.com/office/drawing/2014/main" id="{6089F86B-B8F2-49BA-82E2-C67A1DC31FA6}"/>
+              </a:ext>
+            </a:extLst>
+          </p:cNvPr>
+          <p:cNvSpPr>
+            <a:spLocks xmlns:a="http://schemas.openxmlformats.org/drawingml/2006/main" noGrp="1"/>
+          </p:cNvSpPr>
+          <p:nvPr/>
+        </p:nvSpPr>
+        <p:spPr>
+          <a:xfrm xmlns:a="http://schemas.openxmlformats.org/drawingml/2006/main">
+            <a:off x="10953750" y="266700"/>
+            <a:ext cx="666750" cy="266700"/>
+          </a:xfrm>
+          <a:prstGeom xmlns:a="http://schemas.openxmlformats.org/drawingml/2006/main" prst="rect">
+            <a:avLst/>
+          </a:prstGeom>
+          <a:noFill xmlns:a="http://schemas.openxmlformats.org/drawingml/2006/main"/>
+          <a:ln xmlns:a="http://schemas.openxmlformats.org/drawingml/2006/main" w="0">
+            <a:noFill/>
+            <a:prstDash val="solid"/>
+          </a:ln>
+        </p:spPr>
+        <p:txBody>
+          <a:bodyPr xmlns:a="http://schemas.openxmlformats.org/drawingml/2006/main" lIns="0" tIns="0" rIns="0" bIns="0">
+            <a:noAutofit/>
+          </a:bodyPr>
+          <a:lstStyle xmlns:a="http://schemas.openxmlformats.org/drawingml/2006/main"/>
+          <a:p xmlns:a="http://schemas.openxmlformats.org/drawingml/2006/main">
+            <a:pPr>
+              <a:defRPr sz="1350" b="0">
+                <a:solidFill>
+                  <a:srgbClr val="536C77"/>
+                </a:solidFill>
+                <a:latin typeface="Microsoft YaHei"/>
+                <a:ea typeface="Microsoft YaHei"/>
+                <a:cs typeface="Microsoft YaHei"/>
+              </a:defRPr>
+            </a:pPr>
+            <a:r>
+              <a:rPr sz="1350" b="0">
+                <a:solidFill>
+                  <a:srgbClr val="536C77"/>
+                </a:solidFill>
+                <a:latin typeface="Microsoft YaHei"/>
+                <a:ea typeface="Microsoft YaHei"/>
+                <a:cs typeface="Microsoft YaHei"/>
+              </a:rPr>
+              <a:t>02</a:t>
+            </a:r>
+          </a:p>
+        </p:txBody>
+      </p:sp>
+      <p:sp>
+        <p:nvSpPr>
+          <p:cNvPr id="3" name="">
+            <a:extLst xmlns:a="http://schemas.openxmlformats.org/drawingml/2006/main">
+              <a:ext uri="{FF2B5EF4-FFF2-40B4-BE49-F238E27FC236}">
+                <a16:creationId xmlns:a16="http://schemas.microsoft.com/office/drawing/2014/main" id="{D8745557-8FFF-4ABB-B78B-C3E341E2D882}"/>
+              </a:ext>
+            </a:extLst>
+          </p:cNvPr>
+          <p:cNvSpPr>
+            <a:spLocks xmlns:a="http://schemas.openxmlformats.org/drawingml/2006/main" noGrp="1"/>
+          </p:cNvSpPr>
+          <p:nvPr/>
+        </p:nvSpPr>
+        <p:spPr>
+          <a:xfrm xmlns:a="http://schemas.openxmlformats.org/drawingml/2006/main">
+            <a:off x="571500" y="828675"/>
+            <a:ext cx="11049000" cy="742950"/>
+          </a:xfrm>
+          <a:prstGeom xmlns:a="http://schemas.openxmlformats.org/drawingml/2006/main" prst="rect">
+            <a:avLst/>
+          </a:prstGeom>
+          <a:noFill xmlns:a="http://schemas.openxmlformats.org/drawingml/2006/main"/>
+          <a:ln xmlns:a="http://schemas.openxmlformats.org/drawingml/2006/main" w="0">
+            <a:noFill/>
+            <a:prstDash val="solid"/>
+          </a:ln>
+        </p:spPr>
+        <p:txBody>
+          <a:bodyPr xmlns:a="http://schemas.openxmlformats.org/drawingml/2006/main" lIns="0" tIns="0" rIns="0" bIns="0">
+            <a:noAutofit/>
+          </a:bodyPr>
+          <a:lstStyle xmlns:a="http://schemas.openxmlformats.org/drawingml/2006/main"/>
+          <a:p xmlns:a="http://schemas.openxmlformats.org/drawingml/2006/main">
+            <a:pPr>
+              <a:defRPr sz="3600" b="1">
+                <a:solidFill>
+                  <a:srgbClr val="123442"/>
+                </a:solidFill>
+                <a:latin typeface="Microsoft YaHei"/>
+                <a:ea typeface="Microsoft YaHei"/>
+                <a:cs typeface="Microsoft YaHei"/>
+              </a:defRPr>
+            </a:pPr>
+            <a:r>
+              <a:rPr sz="3600" b="1">
+                <a:solidFill>
+                  <a:srgbClr val="123442"/>
+                </a:solidFill>
+                <a:latin typeface="Microsoft YaHei"/>
+                <a:ea typeface="Microsoft YaHei"/>
+                <a:cs typeface="Microsoft YaHei"/>
+              </a:rPr>
+              <a:t>六个问题决定功能范围</a:t>
+            </a:r>
+          </a:p>
+        </p:txBody>
+      </p:sp>
+      <p:sp>
+        <p:nvSpPr>
+          <p:cNvPr id="4" name="">
+            <a:extLst xmlns:a="http://schemas.openxmlformats.org/drawingml/2006/main">
+              <a:ext uri="{FF2B5EF4-FFF2-40B4-BE49-F238E27FC236}">
+                <a16:creationId xmlns:a16="http://schemas.microsoft.com/office/drawing/2014/main" id="{A6F83B9C-8F06-4122-BF40-36D0BDAB52FF}"/>
+              </a:ext>
+            </a:extLst>
+          </p:cNvPr>
+          <p:cNvSpPr>
+            <a:spLocks xmlns:a="http://schemas.openxmlformats.org/drawingml/2006/main" noGrp="1"/>
+          </p:cNvSpPr>
+          <p:nvPr/>
+        </p:nvSpPr>
+        <p:spPr>
+          <a:xfrm xmlns:a="http://schemas.openxmlformats.org/drawingml/2006/main">
+            <a:off x="571500" y="1638300"/>
+            <a:ext cx="11049000" cy="457200"/>
+          </a:xfrm>
+          <a:prstGeom xmlns:a="http://schemas.openxmlformats.org/drawingml/2006/main" prst="rect">
+            <a:avLst/>
+          </a:prstGeom>
+          <a:noFill xmlns:a="http://schemas.openxmlformats.org/drawingml/2006/main"/>
+          <a:ln xmlns:a="http://schemas.openxmlformats.org/drawingml/2006/main" w="0">
+            <a:noFill/>
+            <a:prstDash val="solid"/>
+          </a:ln>
+        </p:spPr>
+        <p:txBody>
+          <a:bodyPr xmlns:a="http://schemas.openxmlformats.org/drawingml/2006/main" lIns="0" tIns="0" rIns="0" bIns="0">
+            <a:noAutofit/>
+          </a:bodyPr>
+          <a:lstStyle xmlns:a="http://schemas.openxmlformats.org/drawingml/2006/main"/>
+          <a:p xmlns:a="http://schemas.openxmlformats.org/drawingml/2006/main">
+            <a:pPr>
+              <a:defRPr sz="1800" b="0">
+                <a:solidFill>
+                  <a:srgbClr val="536C77"/>
+                </a:solidFill>
+                <a:latin typeface="Microsoft YaHei"/>
+                <a:ea typeface="Microsoft YaHei"/>
+                <a:cs typeface="Microsoft YaHei"/>
+              </a:defRPr>
+            </a:pPr>
+            <a:r>
+              <a:rPr sz="1800" b="0">
+                <a:solidFill>
+                  <a:srgbClr val="536C77"/>
+                </a:solidFill>
+                <a:latin typeface="Microsoft YaHei"/>
+                <a:ea typeface="Microsoft YaHei"/>
+                <a:cs typeface="Microsoft YaHei"/>
+              </a:rPr>
+              <a:t>每个页面都要回答问题，并给出可核验的结果。</a:t>
+            </a:r>
+          </a:p>
+        </p:txBody>
+      </p:sp>
+      <p:sp>
+        <p:nvSpPr>
+          <p:cNvPr id="5" name="">
+            <a:extLst xmlns:a="http://schemas.openxmlformats.org/drawingml/2006/main">
+              <a:ext uri="{FF2B5EF4-FFF2-40B4-BE49-F238E27FC236}">
+                <a16:creationId xmlns:a16="http://schemas.microsoft.com/office/drawing/2014/main" id="{8841C8ED-D181-43C1-8D26-DA9B2485054C}"/>
+              </a:ext>
+            </a:extLst>
+          </p:cNvPr>
+          <p:cNvSpPr>
+            <a:spLocks xmlns:a="http://schemas.openxmlformats.org/drawingml/2006/main" noGrp="1"/>
+          </p:cNvSpPr>
+          <p:nvPr/>
+        </p:nvSpPr>
+        <p:spPr>
+          <a:xfrm xmlns:a="http://schemas.openxmlformats.org/drawingml/2006/main">
+            <a:off x="685800" y="2190750"/>
+            <a:ext cx="10287000" cy="495300"/>
+          </a:xfrm>
+          <a:prstGeom xmlns:a="http://schemas.openxmlformats.org/drawingml/2006/main" prst="rect">
+            <a:avLst/>
+          </a:prstGeom>
+          <a:noFill xmlns:a="http://schemas.openxmlformats.org/drawingml/2006/main"/>
+          <a:ln xmlns:a="http://schemas.openxmlformats.org/drawingml/2006/main" w="0">
+            <a:noFill/>
+            <a:prstDash val="solid"/>
+          </a:ln>
+        </p:spPr>
+        <p:txBody>
+          <a:bodyPr xmlns:a="http://schemas.openxmlformats.org/drawingml/2006/main" lIns="0" tIns="0" rIns="0" bIns="0">
+            <a:noAutofit/>
+          </a:bodyPr>
+          <a:lstStyle xmlns:a="http://schemas.openxmlformats.org/drawingml/2006/main"/>
+          <a:p xmlns:a="http://schemas.openxmlformats.org/drawingml/2006/main">
+            <a:pPr>
+              <a:defRPr sz="2325" b="1">
+                <a:solidFill>
+                  <a:srgbClr val="187887"/>
+                </a:solidFill>
+                <a:latin typeface="Microsoft YaHei"/>
+                <a:ea typeface="Microsoft YaHei"/>
+                <a:cs typeface="Microsoft YaHei"/>
+              </a:defRPr>
+            </a:pPr>
+            <a:r>
+              <a:rPr sz="2325" b="1">
+                <a:solidFill>
+                  <a:srgbClr val="187887"/>
+                </a:solidFill>
+                <a:latin typeface="Microsoft YaHei"/>
+                <a:ea typeface="Microsoft YaHei"/>
+                <a:cs typeface="Microsoft YaHei"/>
+              </a:rPr>
+              <a:t>A  高峰何时出现？</a:t>
+            </a:r>
+          </a:p>
+        </p:txBody>
+      </p:sp>
+      <p:sp>
+        <p:nvSpPr>
+          <p:cNvPr id="6" name="">
+            <a:extLst xmlns:a="http://schemas.openxmlformats.org/drawingml/2006/main">
+              <a:ext uri="{FF2B5EF4-FFF2-40B4-BE49-F238E27FC236}">
+                <a16:creationId xmlns:a16="http://schemas.microsoft.com/office/drawing/2014/main" id="{EEDF91CC-8F97-4E96-89EA-EE725564F08D}"/>
+              </a:ext>
+            </a:extLst>
+          </p:cNvPr>
+          <p:cNvSpPr>
+            <a:spLocks xmlns:a="http://schemas.openxmlformats.org/drawingml/2006/main" noGrp="1"/>
+          </p:cNvSpPr>
+          <p:nvPr/>
+        </p:nvSpPr>
+        <p:spPr>
+          <a:xfrm xmlns:a="http://schemas.openxmlformats.org/drawingml/2006/main">
+            <a:off x="685800" y="2819400"/>
+            <a:ext cx="10287000" cy="495300"/>
+          </a:xfrm>
+          <a:prstGeom xmlns:a="http://schemas.openxmlformats.org/drawingml/2006/main" prst="rect">
+            <a:avLst/>
+          </a:prstGeom>
+          <a:noFill xmlns:a="http://schemas.openxmlformats.org/drawingml/2006/main"/>
+          <a:ln xmlns:a="http://schemas.openxmlformats.org/drawingml/2006/main" w="0">
+            <a:noFill/>
+            <a:prstDash val="solid"/>
+          </a:ln>
+        </p:spPr>
+        <p:txBody>
+          <a:bodyPr xmlns:a="http://schemas.openxmlformats.org/drawingml/2006/main" lIns="0" tIns="0" rIns="0" bIns="0">
+            <a:noAutofit/>
+          </a:bodyPr>
+          <a:lstStyle xmlns:a="http://schemas.openxmlformats.org/drawingml/2006/main"/>
+          <a:p xmlns:a="http://schemas.openxmlformats.org/drawingml/2006/main">
+            <a:pPr>
+              <a:defRPr sz="2325" b="1">
+                <a:solidFill>
+                  <a:srgbClr val="123442"/>
+                </a:solidFill>
+                <a:latin typeface="Microsoft YaHei"/>
+                <a:ea typeface="Microsoft YaHei"/>
+                <a:cs typeface="Microsoft YaHei"/>
+              </a:defRPr>
+            </a:pPr>
+            <a:r>
+              <a:rPr sz="2325" b="1">
+                <a:solidFill>
+                  <a:srgbClr val="123442"/>
+                </a:solidFill>
+                <a:latin typeface="Microsoft YaHei"/>
+                <a:ea typeface="Microsoft YaHei"/>
+                <a:cs typeface="Microsoft YaHei"/>
+              </a:rPr>
+              <a:t>B  哪些站点更繁忙，在哪里？</a:t>
+            </a:r>
+          </a:p>
+        </p:txBody>
+      </p:sp>
+      <p:sp>
+        <p:nvSpPr>
+          <p:cNvPr id="7" name="">
+            <a:extLst xmlns:a="http://schemas.openxmlformats.org/drawingml/2006/main">
+              <a:ext uri="{FF2B5EF4-FFF2-40B4-BE49-F238E27FC236}">
+                <a16:creationId xmlns:a16="http://schemas.microsoft.com/office/drawing/2014/main" id="{0C645A9A-B985-4726-B62B-7042DE24FF6D}"/>
+              </a:ext>
+            </a:extLst>
+          </p:cNvPr>
+          <p:cNvSpPr>
+            <a:spLocks xmlns:a="http://schemas.openxmlformats.org/drawingml/2006/main" noGrp="1"/>
+          </p:cNvSpPr>
+          <p:nvPr/>
+        </p:nvSpPr>
+        <p:spPr>
+          <a:xfrm xmlns:a="http://schemas.openxmlformats.org/drawingml/2006/main">
+            <a:off x="685800" y="3448050"/>
+            <a:ext cx="10287000" cy="495300"/>
+          </a:xfrm>
+          <a:prstGeom xmlns:a="http://schemas.openxmlformats.org/drawingml/2006/main" prst="rect">
+            <a:avLst/>
+          </a:prstGeom>
+          <a:noFill xmlns:a="http://schemas.openxmlformats.org/drawingml/2006/main"/>
+          <a:ln xmlns:a="http://schemas.openxmlformats.org/drawingml/2006/main" w="0">
+            <a:noFill/>
+            <a:prstDash val="solid"/>
+          </a:ln>
+        </p:spPr>
+        <p:txBody>
+          <a:bodyPr xmlns:a="http://schemas.openxmlformats.org/drawingml/2006/main" lIns="0" tIns="0" rIns="0" bIns="0">
+            <a:noAutofit/>
+          </a:bodyPr>
+          <a:lstStyle xmlns:a="http://schemas.openxmlformats.org/drawingml/2006/main"/>
+          <a:p xmlns:a="http://schemas.openxmlformats.org/drawingml/2006/main">
+            <a:pPr>
+              <a:defRPr sz="2325" b="1">
+                <a:solidFill>
+                  <a:srgbClr val="187887"/>
+                </a:solidFill>
+                <a:latin typeface="Microsoft YaHei"/>
+                <a:ea typeface="Microsoft YaHei"/>
+                <a:cs typeface="Microsoft YaHei"/>
+              </a:defRPr>
+            </a:pPr>
+            <a:r>
+              <a:rPr sz="2325" b="1">
+                <a:solidFill>
+                  <a:srgbClr val="187887"/>
+                </a:solidFill>
+                <a:latin typeface="Microsoft YaHei"/>
+                <a:ea typeface="Microsoft YaHei"/>
+                <a:cs typeface="Microsoft YaHei"/>
+              </a:rPr>
+              <a:t>C  早晚进出方向如何变化？</a:t>
+            </a:r>
+          </a:p>
+        </p:txBody>
+      </p:sp>
+      <p:sp>
+        <p:nvSpPr>
+          <p:cNvPr id="8" name="">
+            <a:extLst xmlns:a="http://schemas.openxmlformats.org/drawingml/2006/main">
+              <a:ext uri="{FF2B5EF4-FFF2-40B4-BE49-F238E27FC236}">
+                <a16:creationId xmlns:a16="http://schemas.microsoft.com/office/drawing/2014/main" id="{18BDAB06-3C7B-4949-8F58-FB4615450350}"/>
+              </a:ext>
+            </a:extLst>
+          </p:cNvPr>
+          <p:cNvSpPr>
+            <a:spLocks xmlns:a="http://schemas.openxmlformats.org/drawingml/2006/main" noGrp="1"/>
+          </p:cNvSpPr>
+          <p:nvPr/>
+        </p:nvSpPr>
+        <p:spPr>
+          <a:xfrm xmlns:a="http://schemas.openxmlformats.org/drawingml/2006/main">
+            <a:off x="685800" y="4076700"/>
+            <a:ext cx="10287000" cy="495300"/>
+          </a:xfrm>
+          <a:prstGeom xmlns:a="http://schemas.openxmlformats.org/drawingml/2006/main" prst="rect">
+            <a:avLst/>
+          </a:prstGeom>
+          <a:noFill xmlns:a="http://schemas.openxmlformats.org/drawingml/2006/main"/>
+          <a:ln xmlns:a="http://schemas.openxmlformats.org/drawingml/2006/main" w="0">
+            <a:noFill/>
+            <a:prstDash val="solid"/>
+          </a:ln>
+        </p:spPr>
+        <p:txBody>
+          <a:bodyPr xmlns:a="http://schemas.openxmlformats.org/drawingml/2006/main" lIns="0" tIns="0" rIns="0" bIns="0">
+            <a:noAutofit/>
+          </a:bodyPr>
+          <a:lstStyle xmlns:a="http://schemas.openxmlformats.org/drawingml/2006/main"/>
+          <a:p xmlns:a="http://schemas.openxmlformats.org/drawingml/2006/main">
+            <a:pPr>
+              <a:defRPr sz="2325" b="1">
+                <a:solidFill>
+                  <a:srgbClr val="123442"/>
+                </a:solidFill>
+                <a:latin typeface="Microsoft YaHei"/>
+                <a:ea typeface="Microsoft YaHei"/>
+                <a:cs typeface="Microsoft YaHei"/>
+              </a:defRPr>
+            </a:pPr>
+            <a:r>
+              <a:rPr sz="2325" b="1">
+                <a:solidFill>
+                  <a:srgbClr val="123442"/>
+                </a:solidFill>
+                <a:latin typeface="Microsoft YaHei"/>
+                <a:ea typeface="Microsoft YaHei"/>
+                <a:cs typeface="Microsoft YaHei"/>
+              </a:rPr>
+              <a:t>D  三类出行各占多少？</a:t>
+            </a:r>
+          </a:p>
+        </p:txBody>
+      </p:sp>
+      <p:sp>
+        <p:nvSpPr>
+          <p:cNvPr id="9" name="">
+            <a:extLst xmlns:a="http://schemas.openxmlformats.org/drawingml/2006/main">
+              <a:ext uri="{FF2B5EF4-FFF2-40B4-BE49-F238E27FC236}">
+                <a16:creationId xmlns:a16="http://schemas.microsoft.com/office/drawing/2014/main" id="{4F15E7FF-63B3-470F-9798-603199F1F1BD}"/>
+              </a:ext>
+            </a:extLst>
+          </p:cNvPr>
+          <p:cNvSpPr>
+            <a:spLocks xmlns:a="http://schemas.openxmlformats.org/drawingml/2006/main" noGrp="1"/>
+          </p:cNvSpPr>
+          <p:nvPr/>
+        </p:nvSpPr>
+        <p:spPr>
+          <a:xfrm xmlns:a="http://schemas.openxmlformats.org/drawingml/2006/main">
+            <a:off x="685800" y="4705350"/>
+            <a:ext cx="10287000" cy="495300"/>
+          </a:xfrm>
+          <a:prstGeom xmlns:a="http://schemas.openxmlformats.org/drawingml/2006/main" prst="rect">
+            <a:avLst/>
+          </a:prstGeom>
+          <a:noFill xmlns:a="http://schemas.openxmlformats.org/drawingml/2006/main"/>
+          <a:ln xmlns:a="http://schemas.openxmlformats.org/drawingml/2006/main" w="0">
+            <a:noFill/>
+            <a:prstDash val="solid"/>
+          </a:ln>
+        </p:spPr>
+        <p:txBody>
+          <a:bodyPr xmlns:a="http://schemas.openxmlformats.org/drawingml/2006/main" lIns="0" tIns="0" rIns="0" bIns="0">
+            <a:noAutofit/>
+          </a:bodyPr>
+          <a:lstStyle xmlns:a="http://schemas.openxmlformats.org/drawingml/2006/main"/>
+          <a:p xmlns:a="http://schemas.openxmlformats.org/drawingml/2006/main">
+            <a:pPr>
+              <a:defRPr sz="2325" b="1">
+                <a:solidFill>
+                  <a:srgbClr val="187887"/>
+                </a:solidFill>
+                <a:latin typeface="Microsoft YaHei"/>
+                <a:ea typeface="Microsoft YaHei"/>
+                <a:cs typeface="Microsoft YaHei"/>
+              </a:defRPr>
+            </a:pPr>
+            <a:r>
+              <a:rPr sz="2325" b="1">
+                <a:solidFill>
+                  <a:srgbClr val="187887"/>
+                </a:solidFill>
+                <a:latin typeface="Microsoft YaHei"/>
+                <a:ea typeface="Microsoft YaHei"/>
+                <a:cs typeface="Microsoft YaHei"/>
+              </a:rPr>
+              <a:t>E  天气与客流是否有关？</a:t>
+            </a:r>
+          </a:p>
+        </p:txBody>
+      </p:sp>
+      <p:sp>
+        <p:nvSpPr>
           <p:cNvPr id="10" name="">
             <a:extLst xmlns:a="http://schemas.openxmlformats.org/drawingml/2006/main">
               <a:ext uri="{FF2B5EF4-FFF2-40B4-BE49-F238E27FC236}">
-                <a16:creationId xmlns:a16="http://schemas.microsoft.com/office/drawing/2014/main" id="{D5998E9B-1D94-47AC-85AF-B79293802243}"/>
+                <a16:creationId xmlns:a16="http://schemas.microsoft.com/office/drawing/2014/main" id="{6DC0AA04-FE02-44A9-AE92-FCA567452307}"/>
               </a:ext>
             </a:extLst>
           </p:cNvPr>
@@ -4732,8 +5907,8 @@
         </p:nvSpPr>
         <p:spPr>
           <a:xfrm xmlns:a="http://schemas.openxmlformats.org/drawingml/2006/main">
-            <a:off x="571500" y="266700"/>
-            <a:ext cx="8572500" cy="266700"/>
+            <a:off x="685800" y="5334000"/>
+            <a:ext cx="10287000" cy="495300"/>
           </a:xfrm>
           <a:prstGeom xmlns:a="http://schemas.openxmlformats.org/drawingml/2006/main" prst="rect">
             <a:avLst/>
@@ -4751,489 +5926,25 @@
           <a:lstStyle xmlns:a="http://schemas.openxmlformats.org/drawingml/2006/main"/>
           <a:p xmlns:a="http://schemas.openxmlformats.org/drawingml/2006/main">
             <a:pPr>
-              <a:defRPr sz="1350" b="1">
-                <a:solidFill>
-                  <a:srgbClr val="187887"/>
-                </a:solidFill>
-                <a:latin typeface="Microsoft YaHei"/>
-                <a:ea typeface="Microsoft YaHei"/>
-                <a:cs typeface="Microsoft YaHei"/>
-              </a:defRPr>
-            </a:pPr>
-            <a:r>
-              <a:rPr sz="1350" b="1">
-                <a:solidFill>
-                  <a:srgbClr val="187887"/>
-                </a:solidFill>
-                <a:latin typeface="Microsoft YaHei"/>
-                <a:ea typeface="Microsoft YaHei"/>
-                <a:cs typeface="Microsoft YaHei"/>
-              </a:rPr>
-              <a:t>沪上流动  /  软件开发实践1</a:t>
-            </a:r>
-          </a:p>
-        </p:txBody>
-      </p:sp>
-      <p:sp>
-        <p:nvSpPr>
-          <p:cNvPr id="2" name="">
-            <a:extLst xmlns:a="http://schemas.openxmlformats.org/drawingml/2006/main">
-              <a:ext uri="{FF2B5EF4-FFF2-40B4-BE49-F238E27FC236}">
-                <a16:creationId xmlns:a16="http://schemas.microsoft.com/office/drawing/2014/main" id="{4BCBF882-A41C-4708-8CD1-8F7D49F2A28D}"/>
-              </a:ext>
-            </a:extLst>
-          </p:cNvPr>
-          <p:cNvSpPr>
-            <a:spLocks xmlns:a="http://schemas.openxmlformats.org/drawingml/2006/main" noGrp="1"/>
-          </p:cNvSpPr>
-          <p:nvPr/>
-        </p:nvSpPr>
-        <p:spPr>
-          <a:xfrm xmlns:a="http://schemas.openxmlformats.org/drawingml/2006/main">
-            <a:off x="10953750" y="266700"/>
-            <a:ext cx="666750" cy="266700"/>
-          </a:xfrm>
-          <a:prstGeom xmlns:a="http://schemas.openxmlformats.org/drawingml/2006/main" prst="rect">
-            <a:avLst/>
-          </a:prstGeom>
-          <a:noFill xmlns:a="http://schemas.openxmlformats.org/drawingml/2006/main"/>
-          <a:ln xmlns:a="http://schemas.openxmlformats.org/drawingml/2006/main" w="0">
-            <a:noFill/>
-            <a:prstDash val="solid"/>
-          </a:ln>
-        </p:spPr>
-        <p:txBody>
-          <a:bodyPr xmlns:a="http://schemas.openxmlformats.org/drawingml/2006/main" lIns="0" tIns="0" rIns="0" bIns="0">
-            <a:noAutofit/>
-          </a:bodyPr>
-          <a:lstStyle xmlns:a="http://schemas.openxmlformats.org/drawingml/2006/main"/>
-          <a:p xmlns:a="http://schemas.openxmlformats.org/drawingml/2006/main">
-            <a:pPr>
-              <a:defRPr sz="1350" b="0">
-                <a:solidFill>
-                  <a:srgbClr val="536C77"/>
-                </a:solidFill>
-                <a:latin typeface="Microsoft YaHei"/>
-                <a:ea typeface="Microsoft YaHei"/>
-                <a:cs typeface="Microsoft YaHei"/>
-              </a:defRPr>
-            </a:pPr>
-            <a:r>
-              <a:rPr sz="1350" b="0">
-                <a:solidFill>
-                  <a:srgbClr val="536C77"/>
-                </a:solidFill>
-                <a:latin typeface="Microsoft YaHei"/>
-                <a:ea typeface="Microsoft YaHei"/>
-                <a:cs typeface="Microsoft YaHei"/>
-              </a:rPr>
-              <a:t>02</a:t>
-            </a:r>
-          </a:p>
-        </p:txBody>
-      </p:sp>
-      <p:sp>
-        <p:nvSpPr>
-          <p:cNvPr id="3" name="">
-            <a:extLst xmlns:a="http://schemas.openxmlformats.org/drawingml/2006/main">
-              <a:ext uri="{FF2B5EF4-FFF2-40B4-BE49-F238E27FC236}">
-                <a16:creationId xmlns:a16="http://schemas.microsoft.com/office/drawing/2014/main" id="{A3A3AAEF-C51E-415F-93C0-9DE8F8673387}"/>
-              </a:ext>
-            </a:extLst>
-          </p:cNvPr>
-          <p:cNvSpPr>
-            <a:spLocks xmlns:a="http://schemas.openxmlformats.org/drawingml/2006/main" noGrp="1"/>
-          </p:cNvSpPr>
-          <p:nvPr/>
-        </p:nvSpPr>
-        <p:spPr>
-          <a:xfrm xmlns:a="http://schemas.openxmlformats.org/drawingml/2006/main">
-            <a:off x="571500" y="828675"/>
-            <a:ext cx="11049000" cy="742950"/>
-          </a:xfrm>
-          <a:prstGeom xmlns:a="http://schemas.openxmlformats.org/drawingml/2006/main" prst="rect">
-            <a:avLst/>
-          </a:prstGeom>
-          <a:noFill xmlns:a="http://schemas.openxmlformats.org/drawingml/2006/main"/>
-          <a:ln xmlns:a="http://schemas.openxmlformats.org/drawingml/2006/main" w="0">
-            <a:noFill/>
-            <a:prstDash val="solid"/>
-          </a:ln>
-        </p:spPr>
-        <p:txBody>
-          <a:bodyPr xmlns:a="http://schemas.openxmlformats.org/drawingml/2006/main" lIns="0" tIns="0" rIns="0" bIns="0">
-            <a:noAutofit/>
-          </a:bodyPr>
-          <a:lstStyle xmlns:a="http://schemas.openxmlformats.org/drawingml/2006/main"/>
-          <a:p xmlns:a="http://schemas.openxmlformats.org/drawingml/2006/main">
-            <a:pPr>
-              <a:defRPr sz="3600" b="1">
-                <a:solidFill>
-                  <a:srgbClr val="123442"/>
-                </a:solidFill>
-                <a:latin typeface="Microsoft YaHei"/>
-                <a:ea typeface="Microsoft YaHei"/>
-                <a:cs typeface="Microsoft YaHei"/>
-              </a:defRPr>
-            </a:pPr>
-            <a:r>
-              <a:rPr sz="3600" b="1">
-                <a:solidFill>
-                  <a:srgbClr val="123442"/>
-                </a:solidFill>
-                <a:latin typeface="Microsoft YaHei"/>
-                <a:ea typeface="Microsoft YaHei"/>
-                <a:cs typeface="Microsoft YaHei"/>
-              </a:rPr>
-              <a:t>五个问题决定功能范围</a:t>
-            </a:r>
-          </a:p>
-        </p:txBody>
-      </p:sp>
-      <p:sp>
-        <p:nvSpPr>
-          <p:cNvPr id="4" name="">
-            <a:extLst xmlns:a="http://schemas.openxmlformats.org/drawingml/2006/main">
-              <a:ext uri="{FF2B5EF4-FFF2-40B4-BE49-F238E27FC236}">
-                <a16:creationId xmlns:a16="http://schemas.microsoft.com/office/drawing/2014/main" id="{8F8727FD-B0B2-44E8-8D82-7CCD060FE345}"/>
-              </a:ext>
-            </a:extLst>
-          </p:cNvPr>
-          <p:cNvSpPr>
-            <a:spLocks xmlns:a="http://schemas.openxmlformats.org/drawingml/2006/main" noGrp="1"/>
-          </p:cNvSpPr>
-          <p:nvPr/>
-        </p:nvSpPr>
-        <p:spPr>
-          <a:xfrm xmlns:a="http://schemas.openxmlformats.org/drawingml/2006/main">
-            <a:off x="571500" y="1638300"/>
-            <a:ext cx="11049000" cy="457200"/>
-          </a:xfrm>
-          <a:prstGeom xmlns:a="http://schemas.openxmlformats.org/drawingml/2006/main" prst="rect">
-            <a:avLst/>
-          </a:prstGeom>
-          <a:noFill xmlns:a="http://schemas.openxmlformats.org/drawingml/2006/main"/>
-          <a:ln xmlns:a="http://schemas.openxmlformats.org/drawingml/2006/main" w="0">
-            <a:noFill/>
-            <a:prstDash val="solid"/>
-          </a:ln>
-        </p:spPr>
-        <p:txBody>
-          <a:bodyPr xmlns:a="http://schemas.openxmlformats.org/drawingml/2006/main" lIns="0" tIns="0" rIns="0" bIns="0">
-            <a:noAutofit/>
-          </a:bodyPr>
-          <a:lstStyle xmlns:a="http://schemas.openxmlformats.org/drawingml/2006/main"/>
-          <a:p xmlns:a="http://schemas.openxmlformats.org/drawingml/2006/main">
-            <a:pPr>
-              <a:defRPr sz="1800" b="0">
-                <a:solidFill>
-                  <a:srgbClr val="536C77"/>
-                </a:solidFill>
-                <a:latin typeface="Microsoft YaHei"/>
-                <a:ea typeface="Microsoft YaHei"/>
-                <a:cs typeface="Microsoft YaHei"/>
-              </a:defRPr>
-            </a:pPr>
-            <a:r>
-              <a:rPr sz="1800" b="0">
-                <a:solidFill>
-                  <a:srgbClr val="536C77"/>
-                </a:solidFill>
-                <a:latin typeface="Microsoft YaHei"/>
-                <a:ea typeface="Microsoft YaHei"/>
-                <a:cs typeface="Microsoft YaHei"/>
-              </a:rPr>
-              <a:t>每个页面都要回答问题，并给出可核验的结果。</a:t>
-            </a:r>
-          </a:p>
-        </p:txBody>
-      </p:sp>
-      <p:sp>
-        <p:nvSpPr>
-          <p:cNvPr id="5" name="">
-            <a:extLst xmlns:a="http://schemas.openxmlformats.org/drawingml/2006/main">
-              <a:ext uri="{FF2B5EF4-FFF2-40B4-BE49-F238E27FC236}">
-                <a16:creationId xmlns:a16="http://schemas.microsoft.com/office/drawing/2014/main" id="{8D9D5FB9-B4E4-404F-B4DD-5065D7A362D4}"/>
-              </a:ext>
-            </a:extLst>
-          </p:cNvPr>
-          <p:cNvSpPr>
-            <a:spLocks xmlns:a="http://schemas.openxmlformats.org/drawingml/2006/main" noGrp="1"/>
-          </p:cNvSpPr>
-          <p:nvPr/>
-        </p:nvSpPr>
-        <p:spPr>
-          <a:xfrm xmlns:a="http://schemas.openxmlformats.org/drawingml/2006/main">
-            <a:off x="685800" y="2476500"/>
-            <a:ext cx="9048750" cy="523875"/>
-          </a:xfrm>
-          <a:prstGeom xmlns:a="http://schemas.openxmlformats.org/drawingml/2006/main" prst="rect">
-            <a:avLst/>
-          </a:prstGeom>
-          <a:noFill xmlns:a="http://schemas.openxmlformats.org/drawingml/2006/main"/>
-          <a:ln xmlns:a="http://schemas.openxmlformats.org/drawingml/2006/main" w="0">
-            <a:noFill/>
-            <a:prstDash val="solid"/>
-          </a:ln>
-        </p:spPr>
-        <p:txBody>
-          <a:bodyPr xmlns:a="http://schemas.openxmlformats.org/drawingml/2006/main" lIns="0" tIns="0" rIns="0" bIns="0">
-            <a:noAutofit/>
-          </a:bodyPr>
-          <a:lstStyle xmlns:a="http://schemas.openxmlformats.org/drawingml/2006/main"/>
-          <a:p xmlns:a="http://schemas.openxmlformats.org/drawingml/2006/main">
-            <a:pPr>
-              <a:defRPr sz="2550" b="1">
-                <a:solidFill>
-                  <a:srgbClr val="187887"/>
-                </a:solidFill>
-                <a:latin typeface="Microsoft YaHei"/>
-                <a:ea typeface="Microsoft YaHei"/>
-                <a:cs typeface="Microsoft YaHei"/>
-              </a:defRPr>
-            </a:pPr>
-            <a:r>
-              <a:rPr sz="2550" b="1">
-                <a:solidFill>
-                  <a:srgbClr val="187887"/>
-                </a:solidFill>
-                <a:latin typeface="Microsoft YaHei"/>
-                <a:ea typeface="Microsoft YaHei"/>
-                <a:cs typeface="Microsoft YaHei"/>
-              </a:rPr>
-              <a:t>A  高峰何时出现？</a:t>
-            </a:r>
-          </a:p>
-        </p:txBody>
-      </p:sp>
-      <p:sp>
-        <p:nvSpPr>
-          <p:cNvPr id="6" name="">
-            <a:extLst xmlns:a="http://schemas.openxmlformats.org/drawingml/2006/main">
-              <a:ext uri="{FF2B5EF4-FFF2-40B4-BE49-F238E27FC236}">
-                <a16:creationId xmlns:a16="http://schemas.microsoft.com/office/drawing/2014/main" id="{939C5996-BD7E-40E0-9BE7-B9DBD604B3E5}"/>
-              </a:ext>
-            </a:extLst>
-          </p:cNvPr>
-          <p:cNvSpPr>
-            <a:spLocks xmlns:a="http://schemas.openxmlformats.org/drawingml/2006/main" noGrp="1"/>
-          </p:cNvSpPr>
-          <p:nvPr/>
-        </p:nvSpPr>
-        <p:spPr>
-          <a:xfrm xmlns:a="http://schemas.openxmlformats.org/drawingml/2006/main">
-            <a:off x="685800" y="3181350"/>
-            <a:ext cx="9048750" cy="523875"/>
-          </a:xfrm>
-          <a:prstGeom xmlns:a="http://schemas.openxmlformats.org/drawingml/2006/main" prst="rect">
-            <a:avLst/>
-          </a:prstGeom>
-          <a:noFill xmlns:a="http://schemas.openxmlformats.org/drawingml/2006/main"/>
-          <a:ln xmlns:a="http://schemas.openxmlformats.org/drawingml/2006/main" w="0">
-            <a:noFill/>
-            <a:prstDash val="solid"/>
-          </a:ln>
-        </p:spPr>
-        <p:txBody>
-          <a:bodyPr xmlns:a="http://schemas.openxmlformats.org/drawingml/2006/main" lIns="0" tIns="0" rIns="0" bIns="0">
-            <a:noAutofit/>
-          </a:bodyPr>
-          <a:lstStyle xmlns:a="http://schemas.openxmlformats.org/drawingml/2006/main"/>
-          <a:p xmlns:a="http://schemas.openxmlformats.org/drawingml/2006/main">
-            <a:pPr>
-              <a:defRPr sz="2550" b="1">
-                <a:solidFill>
-                  <a:srgbClr val="123442"/>
-                </a:solidFill>
-                <a:latin typeface="Microsoft YaHei"/>
-                <a:ea typeface="Microsoft YaHei"/>
-                <a:cs typeface="Microsoft YaHei"/>
-              </a:defRPr>
-            </a:pPr>
-            <a:r>
-              <a:rPr sz="2550" b="1">
-                <a:solidFill>
-                  <a:srgbClr val="123442"/>
-                </a:solidFill>
-                <a:latin typeface="Microsoft YaHei"/>
-                <a:ea typeface="Microsoft YaHei"/>
-                <a:cs typeface="Microsoft YaHei"/>
-              </a:rPr>
-              <a:t>B  哪些站点更繁忙，在哪里？</a:t>
-            </a:r>
-          </a:p>
-        </p:txBody>
-      </p:sp>
-      <p:sp>
-        <p:nvSpPr>
-          <p:cNvPr id="7" name="">
-            <a:extLst xmlns:a="http://schemas.openxmlformats.org/drawingml/2006/main">
-              <a:ext uri="{FF2B5EF4-FFF2-40B4-BE49-F238E27FC236}">
-                <a16:creationId xmlns:a16="http://schemas.microsoft.com/office/drawing/2014/main" id="{674B16FC-1878-4336-AAEC-A721734D3531}"/>
-              </a:ext>
-            </a:extLst>
-          </p:cNvPr>
-          <p:cNvSpPr>
-            <a:spLocks xmlns:a="http://schemas.openxmlformats.org/drawingml/2006/main" noGrp="1"/>
-          </p:cNvSpPr>
-          <p:nvPr/>
-        </p:nvSpPr>
-        <p:spPr>
-          <a:xfrm xmlns:a="http://schemas.openxmlformats.org/drawingml/2006/main">
-            <a:off x="685800" y="3886200"/>
-            <a:ext cx="9048750" cy="523875"/>
-          </a:xfrm>
-          <a:prstGeom xmlns:a="http://schemas.openxmlformats.org/drawingml/2006/main" prst="rect">
-            <a:avLst/>
-          </a:prstGeom>
-          <a:noFill xmlns:a="http://schemas.openxmlformats.org/drawingml/2006/main"/>
-          <a:ln xmlns:a="http://schemas.openxmlformats.org/drawingml/2006/main" w="0">
-            <a:noFill/>
-            <a:prstDash val="solid"/>
-          </a:ln>
-        </p:spPr>
-        <p:txBody>
-          <a:bodyPr xmlns:a="http://schemas.openxmlformats.org/drawingml/2006/main" lIns="0" tIns="0" rIns="0" bIns="0">
-            <a:noAutofit/>
-          </a:bodyPr>
-          <a:lstStyle xmlns:a="http://schemas.openxmlformats.org/drawingml/2006/main"/>
-          <a:p xmlns:a="http://schemas.openxmlformats.org/drawingml/2006/main">
-            <a:pPr>
-              <a:defRPr sz="2550" b="1">
-                <a:solidFill>
-                  <a:srgbClr val="187887"/>
-                </a:solidFill>
-                <a:latin typeface="Microsoft YaHei"/>
-                <a:ea typeface="Microsoft YaHei"/>
-                <a:cs typeface="Microsoft YaHei"/>
-              </a:defRPr>
-            </a:pPr>
-            <a:r>
-              <a:rPr sz="2550" b="1">
-                <a:solidFill>
-                  <a:srgbClr val="187887"/>
-                </a:solidFill>
-                <a:latin typeface="Microsoft YaHei"/>
-                <a:ea typeface="Microsoft YaHei"/>
-                <a:cs typeface="Microsoft YaHei"/>
-              </a:rPr>
-              <a:t>C  早晚进出方向如何变化？</a:t>
-            </a:r>
-          </a:p>
-        </p:txBody>
-      </p:sp>
-      <p:sp>
-        <p:nvSpPr>
-          <p:cNvPr id="8" name="">
-            <a:extLst xmlns:a="http://schemas.openxmlformats.org/drawingml/2006/main">
-              <a:ext uri="{FF2B5EF4-FFF2-40B4-BE49-F238E27FC236}">
-                <a16:creationId xmlns:a16="http://schemas.microsoft.com/office/drawing/2014/main" id="{82F06E96-8305-4C27-BA59-4F155B741305}"/>
-              </a:ext>
-            </a:extLst>
-          </p:cNvPr>
-          <p:cNvSpPr>
-            <a:spLocks xmlns:a="http://schemas.openxmlformats.org/drawingml/2006/main" noGrp="1"/>
-          </p:cNvSpPr>
-          <p:nvPr/>
-        </p:nvSpPr>
-        <p:spPr>
-          <a:xfrm xmlns:a="http://schemas.openxmlformats.org/drawingml/2006/main">
-            <a:off x="685800" y="4591050"/>
-            <a:ext cx="9048750" cy="523875"/>
-          </a:xfrm>
-          <a:prstGeom xmlns:a="http://schemas.openxmlformats.org/drawingml/2006/main" prst="rect">
-            <a:avLst/>
-          </a:prstGeom>
-          <a:noFill xmlns:a="http://schemas.openxmlformats.org/drawingml/2006/main"/>
-          <a:ln xmlns:a="http://schemas.openxmlformats.org/drawingml/2006/main" w="0">
-            <a:noFill/>
-            <a:prstDash val="solid"/>
-          </a:ln>
-        </p:spPr>
-        <p:txBody>
-          <a:bodyPr xmlns:a="http://schemas.openxmlformats.org/drawingml/2006/main" lIns="0" tIns="0" rIns="0" bIns="0">
-            <a:noAutofit/>
-          </a:bodyPr>
-          <a:lstStyle xmlns:a="http://schemas.openxmlformats.org/drawingml/2006/main"/>
-          <a:p xmlns:a="http://schemas.openxmlformats.org/drawingml/2006/main">
-            <a:pPr>
-              <a:defRPr sz="2550" b="1">
-                <a:solidFill>
-                  <a:srgbClr val="123442"/>
-                </a:solidFill>
-                <a:latin typeface="Microsoft YaHei"/>
-                <a:ea typeface="Microsoft YaHei"/>
-                <a:cs typeface="Microsoft YaHei"/>
-              </a:defRPr>
-            </a:pPr>
-            <a:r>
-              <a:rPr sz="2550" b="1">
-                <a:solidFill>
-                  <a:srgbClr val="123442"/>
-                </a:solidFill>
-                <a:latin typeface="Microsoft YaHei"/>
-                <a:ea typeface="Microsoft YaHei"/>
-                <a:cs typeface="Microsoft YaHei"/>
-              </a:rPr>
-              <a:t>D  三类出行各占多少？</a:t>
-            </a:r>
-          </a:p>
-        </p:txBody>
-      </p:sp>
-      <p:sp>
-        <p:nvSpPr>
-          <p:cNvPr id="9" name="">
-            <a:extLst xmlns:a="http://schemas.openxmlformats.org/drawingml/2006/main">
-              <a:ext uri="{FF2B5EF4-FFF2-40B4-BE49-F238E27FC236}">
-                <a16:creationId xmlns:a16="http://schemas.microsoft.com/office/drawing/2014/main" id="{FBBD3021-2A27-4ACC-9575-C8896B2E2593}"/>
-              </a:ext>
-            </a:extLst>
-          </p:cNvPr>
-          <p:cNvSpPr>
-            <a:spLocks xmlns:a="http://schemas.openxmlformats.org/drawingml/2006/main" noGrp="1"/>
-          </p:cNvSpPr>
-          <p:nvPr/>
-        </p:nvSpPr>
-        <p:spPr>
-          <a:xfrm xmlns:a="http://schemas.openxmlformats.org/drawingml/2006/main">
-            <a:off x="685800" y="5295900"/>
-            <a:ext cx="9048750" cy="523875"/>
-          </a:xfrm>
-          <a:prstGeom xmlns:a="http://schemas.openxmlformats.org/drawingml/2006/main" prst="rect">
-            <a:avLst/>
-          </a:prstGeom>
-          <a:noFill xmlns:a="http://schemas.openxmlformats.org/drawingml/2006/main"/>
-          <a:ln xmlns:a="http://schemas.openxmlformats.org/drawingml/2006/main" w="0">
-            <a:noFill/>
-            <a:prstDash val="solid"/>
-          </a:ln>
-        </p:spPr>
-        <p:txBody>
-          <a:bodyPr xmlns:a="http://schemas.openxmlformats.org/drawingml/2006/main" lIns="0" tIns="0" rIns="0" bIns="0">
-            <a:noAutofit/>
-          </a:bodyPr>
-          <a:lstStyle xmlns:a="http://schemas.openxmlformats.org/drawingml/2006/main"/>
-          <a:p xmlns:a="http://schemas.openxmlformats.org/drawingml/2006/main">
-            <a:pPr>
-              <a:defRPr sz="2550" b="1">
-                <a:solidFill>
-                  <a:srgbClr val="187887"/>
-                </a:solidFill>
-                <a:latin typeface="Microsoft YaHei"/>
-                <a:ea typeface="Microsoft YaHei"/>
-                <a:cs typeface="Microsoft YaHei"/>
-              </a:defRPr>
-            </a:pPr>
-            <a:r>
-              <a:rPr sz="2550" b="1">
-                <a:solidFill>
-                  <a:srgbClr val="187887"/>
-                </a:solidFill>
-                <a:latin typeface="Microsoft YaHei"/>
-                <a:ea typeface="Microsoft YaHei"/>
-                <a:cs typeface="Microsoft YaHei"/>
-              </a:rPr>
-              <a:t>E  天气与客流是否有关？</a:t>
+              <a:defRPr sz="2325" b="1">
+                <a:solidFill>
+                  <a:srgbClr val="123442"/>
+                </a:solidFill>
+                <a:latin typeface="Microsoft YaHei"/>
+                <a:ea typeface="Microsoft YaHei"/>
+                <a:cs typeface="Microsoft YaHei"/>
+              </a:defRPr>
+            </a:pPr>
+            <a:r>
+              <a:rPr sz="2325" b="1">
+                <a:solidFill>
+                  <a:srgbClr val="123442"/>
+                </a:solidFill>
+                <a:latin typeface="Microsoft YaHei"/>
+                <a:ea typeface="Microsoft YaHei"/>
+                <a:cs typeface="Microsoft YaHei"/>
+              </a:rPr>
+              <a:t>F  站点周边功能与客流有何关系？</a:t>
             </a:r>
           </a:p>
         </p:txBody>
@@ -5241,7 +5952,7 @@
     </p:spTree>
     <p:extLst>
       <p:ext uri="{BB962C8B-B14F-4D97-AF65-F5344CB8AC3E}">
-        <p14:creationId xmlns:p14="http://schemas.microsoft.com/office/powerpoint/2010/main" val="644128051"/>
+        <p14:creationId xmlns:p14="http://schemas.microsoft.com/office/powerpoint/2010/main" val="1023084128"/>
       </p:ext>
     </p:extLst>
   </p:cSld>
@@ -5272,7 +5983,7 @@
           <p:cNvPr id="9" name="">
             <a:extLst xmlns:a="http://schemas.openxmlformats.org/drawingml/2006/main">
               <a:ext uri="{FF2B5EF4-FFF2-40B4-BE49-F238E27FC236}">
-                <a16:creationId xmlns:a16="http://schemas.microsoft.com/office/drawing/2014/main" id="{926B0D9C-6878-413A-B768-7FFAD7A14EC9}"/>
+                <a16:creationId xmlns:a16="http://schemas.microsoft.com/office/drawing/2014/main" id="{516DB22F-5025-4006-9382-75B67AB5788C}"/>
               </a:ext>
             </a:extLst>
           </p:cNvPr>
@@ -5330,7 +6041,7 @@
           <p:cNvPr id="2" name="">
             <a:extLst xmlns:a="http://schemas.openxmlformats.org/drawingml/2006/main">
               <a:ext uri="{FF2B5EF4-FFF2-40B4-BE49-F238E27FC236}">
-                <a16:creationId xmlns:a16="http://schemas.microsoft.com/office/drawing/2014/main" id="{B7897886-9161-47CB-B552-395F26E36A11}"/>
+                <a16:creationId xmlns:a16="http://schemas.microsoft.com/office/drawing/2014/main" id="{6F9F70F0-30D5-4ABD-AA7F-7DDD0A036EA6}"/>
               </a:ext>
             </a:extLst>
           </p:cNvPr>
@@ -5388,7 +6099,7 @@
           <p:cNvPr id="3" name="">
             <a:extLst xmlns:a="http://schemas.openxmlformats.org/drawingml/2006/main">
               <a:ext uri="{FF2B5EF4-FFF2-40B4-BE49-F238E27FC236}">
-                <a16:creationId xmlns:a16="http://schemas.microsoft.com/office/drawing/2014/main" id="{1756DF55-6143-4580-A6BC-DFF329AACA77}"/>
+                <a16:creationId xmlns:a16="http://schemas.microsoft.com/office/drawing/2014/main" id="{138BF115-E23A-434A-97A7-BC6BAFAF0D84}"/>
               </a:ext>
             </a:extLst>
           </p:cNvPr>
@@ -5446,7 +6157,7 @@
           <p:cNvPr id="4" name="">
             <a:extLst xmlns:a="http://schemas.openxmlformats.org/drawingml/2006/main">
               <a:ext uri="{FF2B5EF4-FFF2-40B4-BE49-F238E27FC236}">
-                <a16:creationId xmlns:a16="http://schemas.microsoft.com/office/drawing/2014/main" id="{80CA99D8-4F9E-4AD3-8193-264413ED7E82}"/>
+                <a16:creationId xmlns:a16="http://schemas.microsoft.com/office/drawing/2014/main" id="{F80DE1FA-673F-43EC-8D4C-1655381F5DF5}"/>
               </a:ext>
             </a:extLst>
           </p:cNvPr>
@@ -5504,7 +6215,7 @@
           <p:cNvPr id="5" name="">
             <a:extLst xmlns:a="http://schemas.openxmlformats.org/drawingml/2006/main">
               <a:ext uri="{FF2B5EF4-FFF2-40B4-BE49-F238E27FC236}">
-                <a16:creationId xmlns:a16="http://schemas.microsoft.com/office/drawing/2014/main" id="{53CA4C6A-EAD5-4D07-A50A-8EA935E422FA}"/>
+                <a16:creationId xmlns:a16="http://schemas.microsoft.com/office/drawing/2014/main" id="{EF041469-C23E-4F9A-9C8D-0ED136C53CD2}"/>
               </a:ext>
             </a:extLst>
           </p:cNvPr>
@@ -5562,7 +6273,7 @@
           <p:cNvPr id="6" name="">
             <a:extLst xmlns:a="http://schemas.openxmlformats.org/drawingml/2006/main">
               <a:ext uri="{FF2B5EF4-FFF2-40B4-BE49-F238E27FC236}">
-                <a16:creationId xmlns:a16="http://schemas.microsoft.com/office/drawing/2014/main" id="{FB4E07A6-5CC6-43FD-AF67-0EF9061DFA5E}"/>
+                <a16:creationId xmlns:a16="http://schemas.microsoft.com/office/drawing/2014/main" id="{D078DD97-ADFB-490F-8F7C-ED474179F3CB}"/>
               </a:ext>
             </a:extLst>
           </p:cNvPr>
@@ -5620,7 +6331,7 @@
           <p:cNvPr id="7" name="">
             <a:extLst xmlns:a="http://schemas.openxmlformats.org/drawingml/2006/main">
               <a:ext uri="{FF2B5EF4-FFF2-40B4-BE49-F238E27FC236}">
-                <a16:creationId xmlns:a16="http://schemas.microsoft.com/office/drawing/2014/main" id="{3A9911DC-982F-49CD-94BF-40AD5C4CEDF0}"/>
+                <a16:creationId xmlns:a16="http://schemas.microsoft.com/office/drawing/2014/main" id="{A4D86F6D-720C-4C71-A4C1-A36948EF6C50}"/>
               </a:ext>
             </a:extLst>
           </p:cNvPr>
@@ -5678,7 +6389,7 @@
           <p:cNvPr id="8" name="">
             <a:extLst xmlns:a="http://schemas.openxmlformats.org/drawingml/2006/main">
               <a:ext uri="{FF2B5EF4-FFF2-40B4-BE49-F238E27FC236}">
-                <a16:creationId xmlns:a16="http://schemas.microsoft.com/office/drawing/2014/main" id="{578545FF-4187-4855-9B9C-5732ADEFB8E8}"/>
+                <a16:creationId xmlns:a16="http://schemas.microsoft.com/office/drawing/2014/main" id="{A9A12FA9-20F3-4A97-A2C5-3F0DC60DAFB7}"/>
               </a:ext>
             </a:extLst>
           </p:cNvPr>
@@ -5734,7 +6445,7 @@
     </p:spTree>
     <p:extLst>
       <p:ext uri="{BB962C8B-B14F-4D97-AF65-F5344CB8AC3E}">
-        <p14:creationId xmlns:p14="http://schemas.microsoft.com/office/powerpoint/2010/main" val="545691576"/>
+        <p14:creationId xmlns:p14="http://schemas.microsoft.com/office/powerpoint/2010/main" val="1724988363"/>
       </p:ext>
     </p:extLst>
   </p:cSld>
@@ -5765,7 +6476,7 @@
           <p:cNvPr id="9" name="">
             <a:extLst xmlns:a="http://schemas.openxmlformats.org/drawingml/2006/main">
               <a:ext uri="{FF2B5EF4-FFF2-40B4-BE49-F238E27FC236}">
-                <a16:creationId xmlns:a16="http://schemas.microsoft.com/office/drawing/2014/main" id="{5222F008-8018-4425-83E4-F5638FDDDE84}"/>
+                <a16:creationId xmlns:a16="http://schemas.microsoft.com/office/drawing/2014/main" id="{72B10BF7-63B8-4C62-897C-EFA6FBECFB92}"/>
               </a:ext>
             </a:extLst>
           </p:cNvPr>
@@ -5823,7 +6534,7 @@
           <p:cNvPr id="2" name="">
             <a:extLst xmlns:a="http://schemas.openxmlformats.org/drawingml/2006/main">
               <a:ext uri="{FF2B5EF4-FFF2-40B4-BE49-F238E27FC236}">
-                <a16:creationId xmlns:a16="http://schemas.microsoft.com/office/drawing/2014/main" id="{C90ECDAE-C37C-4651-8C90-653FF89D9E79}"/>
+                <a16:creationId xmlns:a16="http://schemas.microsoft.com/office/drawing/2014/main" id="{E965E1AB-9BD8-4376-9209-4DDD01F8142C}"/>
               </a:ext>
             </a:extLst>
           </p:cNvPr>
@@ -5881,7 +6592,7 @@
           <p:cNvPr id="3" name="">
             <a:extLst xmlns:a="http://schemas.openxmlformats.org/drawingml/2006/main">
               <a:ext uri="{FF2B5EF4-FFF2-40B4-BE49-F238E27FC236}">
-                <a16:creationId xmlns:a16="http://schemas.microsoft.com/office/drawing/2014/main" id="{90E75284-332F-45C1-8A6B-4B373A9E9DFD}"/>
+                <a16:creationId xmlns:a16="http://schemas.microsoft.com/office/drawing/2014/main" id="{02BE4972-FD92-411E-A380-80456A9197C6}"/>
               </a:ext>
             </a:extLst>
           </p:cNvPr>
@@ -5939,7 +6650,7 @@
           <p:cNvPr id="4" name="">
             <a:extLst xmlns:a="http://schemas.openxmlformats.org/drawingml/2006/main">
               <a:ext uri="{FF2B5EF4-FFF2-40B4-BE49-F238E27FC236}">
-                <a16:creationId xmlns:a16="http://schemas.microsoft.com/office/drawing/2014/main" id="{4EC6A369-EEDC-46AF-8AFD-5E0D6774E181}"/>
+                <a16:creationId xmlns:a16="http://schemas.microsoft.com/office/drawing/2014/main" id="{79051225-E464-412C-9AB0-6B43E3FB4214}"/>
               </a:ext>
             </a:extLst>
           </p:cNvPr>
@@ -5987,7 +6698,7 @@
                 <a:ea typeface="Microsoft YaHei"/>
                 <a:cs typeface="Microsoft YaHei"/>
               </a:rPr>
-              <a:t>四个小模块支撑六个页面，便于复核和答辩解释。</a:t>
+              <a:t>五个小模块支撑七个页面，便于复核和答辩解释。</a:t>
             </a:r>
           </a:p>
         </p:txBody>
@@ -5997,7 +6708,7 @@
           <p:cNvPr id="5" name="">
             <a:extLst xmlns:a="http://schemas.openxmlformats.org/drawingml/2006/main">
               <a:ext uri="{FF2B5EF4-FFF2-40B4-BE49-F238E27FC236}">
-                <a16:creationId xmlns:a16="http://schemas.microsoft.com/office/drawing/2014/main" id="{2EB1D42B-DCDA-4051-BC76-CE0800642936}"/>
+                <a16:creationId xmlns:a16="http://schemas.microsoft.com/office/drawing/2014/main" id="{DBA46BD1-5550-417B-8CFB-684D8F4C8E11}"/>
               </a:ext>
             </a:extLst>
           </p:cNvPr>
@@ -6027,7 +6738,7 @@
           <a:lstStyle xmlns:a="http://schemas.openxmlformats.org/drawingml/2006/main"/>
           <a:p xmlns:a="http://schemas.openxmlformats.org/drawingml/2006/main">
             <a:pPr>
-              <a:defRPr sz="2925" b="1">
+              <a:defRPr sz="2775" b="1">
                 <a:solidFill>
                   <a:srgbClr val="187887"/>
                 </a:solidFill>
@@ -6037,7 +6748,7 @@
               </a:defRPr>
             </a:pPr>
             <a:r>
-              <a:rPr sz="2925" b="1">
+              <a:rPr sz="2775" b="1">
                 <a:solidFill>
                   <a:srgbClr val="187887"/>
                 </a:solidFill>
@@ -6045,7 +6756,7 @@
                 <a:ea typeface="Microsoft YaHei"/>
                 <a:cs typeface="Microsoft YaHei"/>
               </a:rPr>
-              <a:t>公开数据 → 检查与标记 → 小时/日聚合</a:t>
+              <a:t>客流、天气、站点与POI → 检查、校正和聚合</a:t>
             </a:r>
           </a:p>
         </p:txBody>
@@ -6055,7 +6766,7 @@
           <p:cNvPr id="6" name="">
             <a:extLst xmlns:a="http://schemas.openxmlformats.org/drawingml/2006/main">
               <a:ext uri="{FF2B5EF4-FFF2-40B4-BE49-F238E27FC236}">
-                <a16:creationId xmlns:a16="http://schemas.microsoft.com/office/drawing/2014/main" id="{C4DE1C03-E7BD-46EB-A539-7B86D3F06758}"/>
+                <a16:creationId xmlns:a16="http://schemas.microsoft.com/office/drawing/2014/main" id="{BB49587C-4254-4885-85E0-5AF5961CE773}"/>
               </a:ext>
             </a:extLst>
           </p:cNvPr>
@@ -6085,25 +6796,25 @@
           <a:lstStyle xmlns:a="http://schemas.openxmlformats.org/drawingml/2006/main"/>
           <a:p xmlns:a="http://schemas.openxmlformats.org/drawingml/2006/main">
             <a:pPr>
-              <a:defRPr sz="2775" b="1">
-                <a:solidFill>
-                  <a:srgbClr val="123442"/>
-                </a:solidFill>
-                <a:latin typeface="Microsoft YaHei"/>
-                <a:ea typeface="Microsoft YaHei"/>
-                <a:cs typeface="Microsoft YaHei"/>
-              </a:defRPr>
-            </a:pPr>
-            <a:r>
-              <a:rPr sz="2775" b="1">
-                <a:solidFill>
-                  <a:srgbClr val="123442"/>
-                </a:solidFill>
-                <a:latin typeface="Microsoft YaHei"/>
-                <a:ea typeface="Microsoft YaHei"/>
-                <a:cs typeface="Microsoft YaHei"/>
-              </a:rPr>
-              <a:t>统计与聚类 → 本地加载 → 筛选、解释与导出</a:t>
+              <a:defRPr sz="2625" b="1">
+                <a:solidFill>
+                  <a:srgbClr val="123442"/>
+                </a:solidFill>
+                <a:latin typeface="Microsoft YaHei"/>
+                <a:ea typeface="Microsoft YaHei"/>
+                <a:cs typeface="Microsoft YaHei"/>
+              </a:defRPr>
+            </a:pPr>
+            <a:r>
+              <a:rPr sz="2625" b="1">
+                <a:solidFill>
+                  <a:srgbClr val="123442"/>
+                </a:solidFill>
+                <a:latin typeface="Microsoft YaHei"/>
+                <a:ea typeface="Microsoft YaHei"/>
+                <a:cs typeface="Microsoft YaHei"/>
+              </a:rPr>
+              <a:t>统计、关联与聚类 → 本地加载 → 筛选、解释与导出</a:t>
             </a:r>
           </a:p>
         </p:txBody>
@@ -6113,7 +6824,7 @@
           <p:cNvPr id="7" name="">
             <a:extLst xmlns:a="http://schemas.openxmlformats.org/drawingml/2006/main">
               <a:ext uri="{FF2B5EF4-FFF2-40B4-BE49-F238E27FC236}">
-                <a16:creationId xmlns:a16="http://schemas.microsoft.com/office/drawing/2014/main" id="{7B3C04AD-46A7-41AB-A83B-B011A7693EB5}"/>
+                <a16:creationId xmlns:a16="http://schemas.microsoft.com/office/drawing/2014/main" id="{23099693-50F0-4D2C-A18A-99CEB5CF682F}"/>
               </a:ext>
             </a:extLst>
           </p:cNvPr>
@@ -6171,7 +6882,7 @@
           <p:cNvPr id="8" name="">
             <a:extLst xmlns:a="http://schemas.openxmlformats.org/drawingml/2006/main">
               <a:ext uri="{FF2B5EF4-FFF2-40B4-BE49-F238E27FC236}">
-                <a16:creationId xmlns:a16="http://schemas.microsoft.com/office/drawing/2014/main" id="{D03B335A-7246-43A9-8A27-D8D2DA83E76E}"/>
+                <a16:creationId xmlns:a16="http://schemas.microsoft.com/office/drawing/2014/main" id="{E81A2A92-0D42-407D-8D4A-639F730FA83B}"/>
               </a:ext>
             </a:extLst>
           </p:cNvPr>
@@ -6227,7 +6938,7 @@
     </p:spTree>
     <p:extLst>
       <p:ext uri="{BB962C8B-B14F-4D97-AF65-F5344CB8AC3E}">
-        <p14:creationId xmlns:p14="http://schemas.microsoft.com/office/powerpoint/2010/main" val="2026028539"/>
+        <p14:creationId xmlns:p14="http://schemas.microsoft.com/office/powerpoint/2010/main" val="933137370"/>
       </p:ext>
     </p:extLst>
   </p:cSld>
@@ -6258,7 +6969,7 @@
           <p:cNvPr id="9" name="">
             <a:extLst xmlns:a="http://schemas.openxmlformats.org/drawingml/2006/main">
               <a:ext uri="{FF2B5EF4-FFF2-40B4-BE49-F238E27FC236}">
-                <a16:creationId xmlns:a16="http://schemas.microsoft.com/office/drawing/2014/main" id="{337A3C3A-A801-48A2-A0BE-2E8EB89091C0}"/>
+                <a16:creationId xmlns:a16="http://schemas.microsoft.com/office/drawing/2014/main" id="{5B93C5BB-2FF7-46A7-A9DE-92A4984633DA}"/>
               </a:ext>
             </a:extLst>
           </p:cNvPr>
@@ -6316,7 +7027,7 @@
           <p:cNvPr id="2" name="">
             <a:extLst xmlns:a="http://schemas.openxmlformats.org/drawingml/2006/main">
               <a:ext uri="{FF2B5EF4-FFF2-40B4-BE49-F238E27FC236}">
-                <a16:creationId xmlns:a16="http://schemas.microsoft.com/office/drawing/2014/main" id="{5D1C0381-1873-4C3E-86F9-370F9C6707CA}"/>
+                <a16:creationId xmlns:a16="http://schemas.microsoft.com/office/drawing/2014/main" id="{9EF672C9-3499-4A94-B830-45F07743DF7C}"/>
               </a:ext>
             </a:extLst>
           </p:cNvPr>
@@ -6374,7 +7085,7 @@
           <p:cNvPr id="3" name="">
             <a:extLst xmlns:a="http://schemas.openxmlformats.org/drawingml/2006/main">
               <a:ext uri="{FF2B5EF4-FFF2-40B4-BE49-F238E27FC236}">
-                <a16:creationId xmlns:a16="http://schemas.microsoft.com/office/drawing/2014/main" id="{591C1F6D-C8C5-4026-A099-2A935B0DD781}"/>
+                <a16:creationId xmlns:a16="http://schemas.microsoft.com/office/drawing/2014/main" id="{1362EA43-6EC9-442E-99B9-C95E5C553AF4}"/>
               </a:ext>
             </a:extLst>
           </p:cNvPr>
@@ -6432,7 +7143,7 @@
           <p:cNvPr id="4" name="">
             <a:extLst xmlns:a="http://schemas.openxmlformats.org/drawingml/2006/main">
               <a:ext uri="{FF2B5EF4-FFF2-40B4-BE49-F238E27FC236}">
-                <a16:creationId xmlns:a16="http://schemas.microsoft.com/office/drawing/2014/main" id="{5919ADEC-41DB-4086-8E0A-58FDC1F52CFC}"/>
+                <a16:creationId xmlns:a16="http://schemas.microsoft.com/office/drawing/2014/main" id="{7F9BD9EC-7D62-480B-8CFE-A37BF23113DF}"/>
               </a:ext>
             </a:extLst>
           </p:cNvPr>
@@ -6497,7 +7208,7 @@
         </p:xfrm>
         <a:graphic xmlns:a="http://schemas.openxmlformats.org/drawingml/2006/main">
           <a:graphicData uri="http://schemas.openxmlformats.org/drawingml/2006/chart">
-            <c:chart xmlns:r="http://schemas.openxmlformats.org/officeDocument/2006/relationships" xmlns:c="http://schemas.openxmlformats.org/drawingml/2006/chart" r:id="Re5bb174e43704c81"/>
+            <c:chart xmlns:r="http://schemas.openxmlformats.org/officeDocument/2006/relationships" xmlns:c="http://schemas.openxmlformats.org/drawingml/2006/chart" r:id="R2d92148d7a7f4003"/>
           </a:graphicData>
         </a:graphic>
       </p:graphicFrame>
@@ -6506,7 +7217,7 @@
           <p:cNvPr id="6" name="">
             <a:extLst xmlns:a="http://schemas.openxmlformats.org/drawingml/2006/main">
               <a:ext uri="{FF2B5EF4-FFF2-40B4-BE49-F238E27FC236}">
-                <a16:creationId xmlns:a16="http://schemas.microsoft.com/office/drawing/2014/main" id="{234AF6CE-75F9-4154-BE84-7AE15E827C91}"/>
+                <a16:creationId xmlns:a16="http://schemas.microsoft.com/office/drawing/2014/main" id="{5B58062C-9C28-408A-A402-78FE64EF9ECC}"/>
               </a:ext>
             </a:extLst>
           </p:cNvPr>
@@ -6564,7 +7275,7 @@
           <p:cNvPr id="7" name="">
             <a:extLst xmlns:a="http://schemas.openxmlformats.org/drawingml/2006/main">
               <a:ext uri="{FF2B5EF4-FFF2-40B4-BE49-F238E27FC236}">
-                <a16:creationId xmlns:a16="http://schemas.microsoft.com/office/drawing/2014/main" id="{FE5FE719-4A90-4944-B348-36A2B906D420}"/>
+                <a16:creationId xmlns:a16="http://schemas.microsoft.com/office/drawing/2014/main" id="{862B244C-A66C-4B9C-B3E4-5AC297F37C5E}"/>
               </a:ext>
             </a:extLst>
           </p:cNvPr>
@@ -6645,7 +7356,7 @@
           <p:cNvPr id="8" name="">
             <a:extLst xmlns:a="http://schemas.openxmlformats.org/drawingml/2006/main">
               <a:ext uri="{FF2B5EF4-FFF2-40B4-BE49-F238E27FC236}">
-                <a16:creationId xmlns:a16="http://schemas.microsoft.com/office/drawing/2014/main" id="{6232B47C-C9B2-4FC2-B4D6-BEBB9222FB3E}"/>
+                <a16:creationId xmlns:a16="http://schemas.microsoft.com/office/drawing/2014/main" id="{406D0175-88C4-4F66-B9C8-CB227D9C0273}"/>
               </a:ext>
             </a:extLst>
           </p:cNvPr>
@@ -6724,7 +7435,7 @@
     </p:spTree>
     <p:extLst>
       <p:ext uri="{BB962C8B-B14F-4D97-AF65-F5344CB8AC3E}">
-        <p14:creationId xmlns:p14="http://schemas.microsoft.com/office/powerpoint/2010/main" val="1758604640"/>
+        <p14:creationId xmlns:p14="http://schemas.microsoft.com/office/powerpoint/2010/main" val="1167857705"/>
       </p:ext>
     </p:extLst>
   </p:cSld>
@@ -6755,7 +7466,7 @@
           <p:cNvPr id="9" name="">
             <a:extLst xmlns:a="http://schemas.openxmlformats.org/drawingml/2006/main">
               <a:ext uri="{FF2B5EF4-FFF2-40B4-BE49-F238E27FC236}">
-                <a16:creationId xmlns:a16="http://schemas.microsoft.com/office/drawing/2014/main" id="{5F41FBB5-2A36-454D-811E-6541C29A186F}"/>
+                <a16:creationId xmlns:a16="http://schemas.microsoft.com/office/drawing/2014/main" id="{74C2DB18-E881-42B3-8632-933DD5A88282}"/>
               </a:ext>
             </a:extLst>
           </p:cNvPr>
@@ -6813,7 +7524,7 @@
           <p:cNvPr id="2" name="">
             <a:extLst xmlns:a="http://schemas.openxmlformats.org/drawingml/2006/main">
               <a:ext uri="{FF2B5EF4-FFF2-40B4-BE49-F238E27FC236}">
-                <a16:creationId xmlns:a16="http://schemas.microsoft.com/office/drawing/2014/main" id="{1F3FC072-CAA8-415B-9521-DAAE0759E020}"/>
+                <a16:creationId xmlns:a16="http://schemas.microsoft.com/office/drawing/2014/main" id="{54A3F510-8F26-46CB-9D11-DA328990E1AA}"/>
               </a:ext>
             </a:extLst>
           </p:cNvPr>
@@ -6871,7 +7582,7 @@
           <p:cNvPr id="3" name="">
             <a:extLst xmlns:a="http://schemas.openxmlformats.org/drawingml/2006/main">
               <a:ext uri="{FF2B5EF4-FFF2-40B4-BE49-F238E27FC236}">
-                <a16:creationId xmlns:a16="http://schemas.microsoft.com/office/drawing/2014/main" id="{D9A07909-193D-49AE-BC4A-CA3DA5776B47}"/>
+                <a16:creationId xmlns:a16="http://schemas.microsoft.com/office/drawing/2014/main" id="{4461F2BA-182A-427C-B161-880CAF93AF99}"/>
               </a:ext>
             </a:extLst>
           </p:cNvPr>
@@ -6929,7 +7640,7 @@
           <p:cNvPr id="4" name="">
             <a:extLst xmlns:a="http://schemas.openxmlformats.org/drawingml/2006/main">
               <a:ext uri="{FF2B5EF4-FFF2-40B4-BE49-F238E27FC236}">
-                <a16:creationId xmlns:a16="http://schemas.microsoft.com/office/drawing/2014/main" id="{5C77D913-2EC2-46BD-BB68-D21F17D8A7B6}"/>
+                <a16:creationId xmlns:a16="http://schemas.microsoft.com/office/drawing/2014/main" id="{13ABEFEC-CB7A-4337-B1C5-46A95B978688}"/>
               </a:ext>
             </a:extLst>
           </p:cNvPr>
@@ -6991,7 +7702,7 @@
           <p:nvPr/>
         </p:nvPicPr>
         <p:blipFill>
-          <a:blip xmlns:r="http://schemas.openxmlformats.org/officeDocument/2006/relationships" xmlns:a="http://schemas.openxmlformats.org/drawingml/2006/main" r:embed="Rc78cb53239094a73"/>
+          <a:blip xmlns:r="http://schemas.openxmlformats.org/officeDocument/2006/relationships" xmlns:a="http://schemas.openxmlformats.org/drawingml/2006/main" r:embed="R16c6b0cbda1b46c1"/>
           <a:stretch xmlns:a="http://schemas.openxmlformats.org/drawingml/2006/main"/>
         </p:blipFill>
         <p:spPr>
@@ -7009,7 +7720,7 @@
           <p:cNvPr id="6" name="">
             <a:extLst xmlns:a="http://schemas.openxmlformats.org/drawingml/2006/main">
               <a:ext uri="{FF2B5EF4-FFF2-40B4-BE49-F238E27FC236}">
-                <a16:creationId xmlns:a16="http://schemas.microsoft.com/office/drawing/2014/main" id="{1E9D57E1-FDE9-4FB4-9405-1CCAA932C9BA}"/>
+                <a16:creationId xmlns:a16="http://schemas.microsoft.com/office/drawing/2014/main" id="{0B71C898-172C-46A7-88F1-3EE48A8582AC}"/>
               </a:ext>
             </a:extLst>
           </p:cNvPr>
@@ -7090,7 +7801,7 @@
           <p:cNvPr id="7" name="">
             <a:extLst xmlns:a="http://schemas.openxmlformats.org/drawingml/2006/main">
               <a:ext uri="{FF2B5EF4-FFF2-40B4-BE49-F238E27FC236}">
-                <a16:creationId xmlns:a16="http://schemas.microsoft.com/office/drawing/2014/main" id="{C3294DB5-D069-420B-AD98-FA72B30B2BCB}"/>
+                <a16:creationId xmlns:a16="http://schemas.microsoft.com/office/drawing/2014/main" id="{830C3936-A2E7-4DDC-877D-9C162CE90DC0}"/>
               </a:ext>
             </a:extLst>
           </p:cNvPr>
@@ -7171,7 +7882,7 @@
           <p:cNvPr id="8" name="">
             <a:extLst xmlns:a="http://schemas.openxmlformats.org/drawingml/2006/main">
               <a:ext uri="{FF2B5EF4-FFF2-40B4-BE49-F238E27FC236}">
-                <a16:creationId xmlns:a16="http://schemas.microsoft.com/office/drawing/2014/main" id="{DB2D7728-803F-4CDE-B42B-8DBA876C8DB5}"/>
+                <a16:creationId xmlns:a16="http://schemas.microsoft.com/office/drawing/2014/main" id="{DEA1DA38-7A30-4526-8151-73D9FDBDA231}"/>
               </a:ext>
             </a:extLst>
           </p:cNvPr>
@@ -7250,7 +7961,7 @@
     </p:spTree>
     <p:extLst>
       <p:ext uri="{BB962C8B-B14F-4D97-AF65-F5344CB8AC3E}">
-        <p14:creationId xmlns:p14="http://schemas.microsoft.com/office/powerpoint/2010/main" val="1798783477"/>
+        <p14:creationId xmlns:p14="http://schemas.microsoft.com/office/powerpoint/2010/main" val="694520502"/>
       </p:ext>
     </p:extLst>
   </p:cSld>
@@ -7281,7 +7992,7 @@
           <p:cNvPr id="10" name="">
             <a:extLst xmlns:a="http://schemas.openxmlformats.org/drawingml/2006/main">
               <a:ext uri="{FF2B5EF4-FFF2-40B4-BE49-F238E27FC236}">
-                <a16:creationId xmlns:a16="http://schemas.microsoft.com/office/drawing/2014/main" id="{29BA648A-D222-4E11-81A0-FC91C188E3F3}"/>
+                <a16:creationId xmlns:a16="http://schemas.microsoft.com/office/drawing/2014/main" id="{E82C22F6-65E6-464D-838B-B8D16C70D26D}"/>
               </a:ext>
             </a:extLst>
           </p:cNvPr>
@@ -7339,7 +8050,7 @@
           <p:cNvPr id="2" name="">
             <a:extLst xmlns:a="http://schemas.openxmlformats.org/drawingml/2006/main">
               <a:ext uri="{FF2B5EF4-FFF2-40B4-BE49-F238E27FC236}">
-                <a16:creationId xmlns:a16="http://schemas.microsoft.com/office/drawing/2014/main" id="{211991CE-9023-4C70-96D7-EFEE3C99681D}"/>
+                <a16:creationId xmlns:a16="http://schemas.microsoft.com/office/drawing/2014/main" id="{125BFA38-D2FF-4258-BA70-AC247EECDD49}"/>
               </a:ext>
             </a:extLst>
           </p:cNvPr>
@@ -7397,7 +8108,7 @@
           <p:cNvPr id="3" name="">
             <a:extLst xmlns:a="http://schemas.openxmlformats.org/drawingml/2006/main">
               <a:ext uri="{FF2B5EF4-FFF2-40B4-BE49-F238E27FC236}">
-                <a16:creationId xmlns:a16="http://schemas.microsoft.com/office/drawing/2014/main" id="{1D39847F-F285-4E82-9495-9F40E6E8E536}"/>
+                <a16:creationId xmlns:a16="http://schemas.microsoft.com/office/drawing/2014/main" id="{19EC3CD6-3267-4D31-8B85-70856C3DD16A}"/>
               </a:ext>
             </a:extLst>
           </p:cNvPr>
@@ -7455,7 +8166,7 @@
           <p:cNvPr id="4" name="">
             <a:extLst xmlns:a="http://schemas.openxmlformats.org/drawingml/2006/main">
               <a:ext uri="{FF2B5EF4-FFF2-40B4-BE49-F238E27FC236}">
-                <a16:creationId xmlns:a16="http://schemas.microsoft.com/office/drawing/2014/main" id="{38799E19-645F-4B24-B055-9FE0564F3533}"/>
+                <a16:creationId xmlns:a16="http://schemas.microsoft.com/office/drawing/2014/main" id="{34473340-5BAC-4E66-96B8-BC3021FF0111}"/>
               </a:ext>
             </a:extLst>
           </p:cNvPr>
@@ -7520,7 +8231,7 @@
         </p:xfrm>
         <a:graphic xmlns:a="http://schemas.openxmlformats.org/drawingml/2006/main">
           <a:graphicData uri="http://schemas.openxmlformats.org/drawingml/2006/chart">
-            <c:chart xmlns:r="http://schemas.openxmlformats.org/officeDocument/2006/relationships" xmlns:c="http://schemas.openxmlformats.org/drawingml/2006/chart" r:id="R282ada608dca4749"/>
+            <c:chart xmlns:r="http://schemas.openxmlformats.org/officeDocument/2006/relationships" xmlns:c="http://schemas.openxmlformats.org/drawingml/2006/chart" r:id="R97ea80cf18444d0f"/>
           </a:graphicData>
         </a:graphic>
       </p:graphicFrame>
@@ -7529,7 +8240,7 @@
           <p:cNvPr id="6" name="">
             <a:extLst xmlns:a="http://schemas.openxmlformats.org/drawingml/2006/main">
               <a:ext uri="{FF2B5EF4-FFF2-40B4-BE49-F238E27FC236}">
-                <a16:creationId xmlns:a16="http://schemas.microsoft.com/office/drawing/2014/main" id="{40691C93-C175-4146-AF08-520DE99F105A}"/>
+                <a16:creationId xmlns:a16="http://schemas.microsoft.com/office/drawing/2014/main" id="{8EE0618A-FE91-4C20-9E22-0C35CC229DAD}"/>
               </a:ext>
             </a:extLst>
           </p:cNvPr>
@@ -7587,7 +8298,7 @@
           <p:cNvPr id="7" name="">
             <a:extLst xmlns:a="http://schemas.openxmlformats.org/drawingml/2006/main">
               <a:ext uri="{FF2B5EF4-FFF2-40B4-BE49-F238E27FC236}">
-                <a16:creationId xmlns:a16="http://schemas.microsoft.com/office/drawing/2014/main" id="{D27DADC6-B156-471E-804B-E616285C4568}"/>
+                <a16:creationId xmlns:a16="http://schemas.microsoft.com/office/drawing/2014/main" id="{3AD7062A-14BC-40B5-9192-37B6D832E666}"/>
               </a:ext>
             </a:extLst>
           </p:cNvPr>
@@ -7668,7 +8379,7 @@
           <p:cNvPr id="8" name="">
             <a:extLst xmlns:a="http://schemas.openxmlformats.org/drawingml/2006/main">
               <a:ext uri="{FF2B5EF4-FFF2-40B4-BE49-F238E27FC236}">
-                <a16:creationId xmlns:a16="http://schemas.microsoft.com/office/drawing/2014/main" id="{E034C25E-667A-48DC-A766-A23160065226}"/>
+                <a16:creationId xmlns:a16="http://schemas.microsoft.com/office/drawing/2014/main" id="{6D971BD3-2323-465A-8EA8-C55FCBC871D8}"/>
               </a:ext>
             </a:extLst>
           </p:cNvPr>
@@ -7749,7 +8460,7 @@
           <p:cNvPr id="9" name="">
             <a:extLst xmlns:a="http://schemas.openxmlformats.org/drawingml/2006/main">
               <a:ext uri="{FF2B5EF4-FFF2-40B4-BE49-F238E27FC236}">
-                <a16:creationId xmlns:a16="http://schemas.microsoft.com/office/drawing/2014/main" id="{FA694E8E-814E-4004-AFA2-F4A5F251DCBB}"/>
+                <a16:creationId xmlns:a16="http://schemas.microsoft.com/office/drawing/2014/main" id="{F43E1D9D-6238-4D1E-961F-CAD9907EBB5C}"/>
               </a:ext>
             </a:extLst>
           </p:cNvPr>
@@ -7828,7 +8539,7 @@
     </p:spTree>
     <p:extLst>
       <p:ext uri="{BB962C8B-B14F-4D97-AF65-F5344CB8AC3E}">
-        <p14:creationId xmlns:p14="http://schemas.microsoft.com/office/powerpoint/2010/main" val="1888332005"/>
+        <p14:creationId xmlns:p14="http://schemas.microsoft.com/office/powerpoint/2010/main" val="1870302982"/>
       </p:ext>
     </p:extLst>
   </p:cSld>
@@ -7859,7 +8570,7 @@
           <p:cNvPr id="9" name="">
             <a:extLst xmlns:a="http://schemas.openxmlformats.org/drawingml/2006/main">
               <a:ext uri="{FF2B5EF4-FFF2-40B4-BE49-F238E27FC236}">
-                <a16:creationId xmlns:a16="http://schemas.microsoft.com/office/drawing/2014/main" id="{AD94EDDF-E197-4751-A21F-BAD6FC758F47}"/>
+                <a16:creationId xmlns:a16="http://schemas.microsoft.com/office/drawing/2014/main" id="{3D24A440-7405-4F16-B89C-DCF7FEC93FA8}"/>
               </a:ext>
             </a:extLst>
           </p:cNvPr>
@@ -7917,7 +8628,7 @@
           <p:cNvPr id="2" name="">
             <a:extLst xmlns:a="http://schemas.openxmlformats.org/drawingml/2006/main">
               <a:ext uri="{FF2B5EF4-FFF2-40B4-BE49-F238E27FC236}">
-                <a16:creationId xmlns:a16="http://schemas.microsoft.com/office/drawing/2014/main" id="{EE0EFC2B-1711-4E14-8E37-27DCFDFA492F}"/>
+                <a16:creationId xmlns:a16="http://schemas.microsoft.com/office/drawing/2014/main" id="{C667CC15-7B93-4660-A1FE-1621755773EA}"/>
               </a:ext>
             </a:extLst>
           </p:cNvPr>
@@ -7975,7 +8686,7 @@
           <p:cNvPr id="3" name="">
             <a:extLst xmlns:a="http://schemas.openxmlformats.org/drawingml/2006/main">
               <a:ext uri="{FF2B5EF4-FFF2-40B4-BE49-F238E27FC236}">
-                <a16:creationId xmlns:a16="http://schemas.microsoft.com/office/drawing/2014/main" id="{8937EB05-B43D-4957-A199-107095ECDCDE}"/>
+                <a16:creationId xmlns:a16="http://schemas.microsoft.com/office/drawing/2014/main" id="{C0031CFE-2B0A-499C-9BA2-F4FE08910978}"/>
               </a:ext>
             </a:extLst>
           </p:cNvPr>
@@ -8033,7 +8744,7 @@
           <p:cNvPr id="4" name="">
             <a:extLst xmlns:a="http://schemas.openxmlformats.org/drawingml/2006/main">
               <a:ext uri="{FF2B5EF4-FFF2-40B4-BE49-F238E27FC236}">
-                <a16:creationId xmlns:a16="http://schemas.microsoft.com/office/drawing/2014/main" id="{C9867C2B-4139-4664-B4C6-8EAC3E36148C}"/>
+                <a16:creationId xmlns:a16="http://schemas.microsoft.com/office/drawing/2014/main" id="{0414E955-DD16-4082-BE9C-7EA71BE4DDEB}"/>
               </a:ext>
             </a:extLst>
           </p:cNvPr>
@@ -8095,7 +8806,7 @@
           <p:nvPr/>
         </p:nvPicPr>
         <p:blipFill>
-          <a:blip xmlns:r="http://schemas.openxmlformats.org/officeDocument/2006/relationships" xmlns:a="http://schemas.openxmlformats.org/drawingml/2006/main" r:embed="R12272b899b154948"/>
+          <a:blip xmlns:r="http://schemas.openxmlformats.org/officeDocument/2006/relationships" xmlns:a="http://schemas.openxmlformats.org/drawingml/2006/main" r:embed="R9e8bb1f9e87347c7"/>
           <a:stretch xmlns:a="http://schemas.openxmlformats.org/drawingml/2006/main"/>
         </p:blipFill>
         <p:spPr>
@@ -8113,7 +8824,7 @@
           <p:cNvPr id="6" name="">
             <a:extLst xmlns:a="http://schemas.openxmlformats.org/drawingml/2006/main">
               <a:ext uri="{FF2B5EF4-FFF2-40B4-BE49-F238E27FC236}">
-                <a16:creationId xmlns:a16="http://schemas.microsoft.com/office/drawing/2014/main" id="{36FED2C3-08F5-479F-BFD7-DC191F8F7777}"/>
+                <a16:creationId xmlns:a16="http://schemas.microsoft.com/office/drawing/2014/main" id="{0DF3D5FD-4927-4BBE-BAD0-AF41ED89F15E}"/>
               </a:ext>
             </a:extLst>
           </p:cNvPr>
@@ -8194,7 +8905,7 @@
           <p:cNvPr id="7" name="">
             <a:extLst xmlns:a="http://schemas.openxmlformats.org/drawingml/2006/main">
               <a:ext uri="{FF2B5EF4-FFF2-40B4-BE49-F238E27FC236}">
-                <a16:creationId xmlns:a16="http://schemas.microsoft.com/office/drawing/2014/main" id="{042A70B1-5DB0-4DF3-ACB9-585F8F94E763}"/>
+                <a16:creationId xmlns:a16="http://schemas.microsoft.com/office/drawing/2014/main" id="{CFB2C707-A0B1-495D-8248-2DF523933290}"/>
               </a:ext>
             </a:extLst>
           </p:cNvPr>
@@ -8275,7 +8986,7 @@
           <p:cNvPr id="8" name="">
             <a:extLst xmlns:a="http://schemas.openxmlformats.org/drawingml/2006/main">
               <a:ext uri="{FF2B5EF4-FFF2-40B4-BE49-F238E27FC236}">
-                <a16:creationId xmlns:a16="http://schemas.microsoft.com/office/drawing/2014/main" id="{1FD285A0-8E73-42E7-913D-4DA9BAA453AF}"/>
+                <a16:creationId xmlns:a16="http://schemas.microsoft.com/office/drawing/2014/main" id="{D753AAA6-3BDF-492E-9559-E8C1A17E7C43}"/>
               </a:ext>
             </a:extLst>
           </p:cNvPr>
@@ -8354,7 +9065,7 @@
     </p:spTree>
     <p:extLst>
       <p:ext uri="{BB962C8B-B14F-4D97-AF65-F5344CB8AC3E}">
-        <p14:creationId xmlns:p14="http://schemas.microsoft.com/office/powerpoint/2010/main" val="882817373"/>
+        <p14:creationId xmlns:p14="http://schemas.microsoft.com/office/powerpoint/2010/main" val="159020446"/>
       </p:ext>
     </p:extLst>
   </p:cSld>
@@ -8385,7 +9096,7 @@
           <p:cNvPr id="9" name="">
             <a:extLst xmlns:a="http://schemas.openxmlformats.org/drawingml/2006/main">
               <a:ext uri="{FF2B5EF4-FFF2-40B4-BE49-F238E27FC236}">
-                <a16:creationId xmlns:a16="http://schemas.microsoft.com/office/drawing/2014/main" id="{ADBE2E5C-1753-495F-BAEA-3F212BC57085}"/>
+                <a16:creationId xmlns:a16="http://schemas.microsoft.com/office/drawing/2014/main" id="{CA849F3D-4565-4D87-A09C-0BC2205694EA}"/>
               </a:ext>
             </a:extLst>
           </p:cNvPr>
@@ -8443,7 +9154,7 @@
           <p:cNvPr id="2" name="">
             <a:extLst xmlns:a="http://schemas.openxmlformats.org/drawingml/2006/main">
               <a:ext uri="{FF2B5EF4-FFF2-40B4-BE49-F238E27FC236}">
-                <a16:creationId xmlns:a16="http://schemas.microsoft.com/office/drawing/2014/main" id="{07E00D1D-9604-41D1-AD00-9568387B2899}"/>
+                <a16:creationId xmlns:a16="http://schemas.microsoft.com/office/drawing/2014/main" id="{A6B9F938-ABE0-447C-9B85-7A3747382115}"/>
               </a:ext>
             </a:extLst>
           </p:cNvPr>
@@ -8501,7 +9212,7 @@
           <p:cNvPr id="3" name="">
             <a:extLst xmlns:a="http://schemas.openxmlformats.org/drawingml/2006/main">
               <a:ext uri="{FF2B5EF4-FFF2-40B4-BE49-F238E27FC236}">
-                <a16:creationId xmlns:a16="http://schemas.microsoft.com/office/drawing/2014/main" id="{848E23C7-59D0-4D4B-8C35-927270AAD2CC}"/>
+                <a16:creationId xmlns:a16="http://schemas.microsoft.com/office/drawing/2014/main" id="{72A095C3-1657-49F6-9F42-7336388400ED}"/>
               </a:ext>
             </a:extLst>
           </p:cNvPr>
@@ -8549,7 +9260,7 @@
                 <a:ea typeface="Microsoft YaHei"/>
                 <a:cs typeface="Microsoft YaHei"/>
               </a:rPr>
-              <a:t>相对曲线聚成2组，内部评价为0.427</a:t>
+              <a:t>站点周边POI越密集，客流通常也越高</a:t>
             </a:r>
           </a:p>
         </p:txBody>
@@ -8559,7 +9270,7 @@
           <p:cNvPr id="4" name="">
             <a:extLst xmlns:a="http://schemas.openxmlformats.org/drawingml/2006/main">
               <a:ext uri="{FF2B5EF4-FFF2-40B4-BE49-F238E27FC236}">
-                <a16:creationId xmlns:a16="http://schemas.microsoft.com/office/drawing/2014/main" id="{B39B8158-DEAA-4545-AB6B-FB027183517A}"/>
+                <a16:creationId xmlns:a16="http://schemas.microsoft.com/office/drawing/2014/main" id="{74AB9F74-DBAF-4FD2-BD4A-CA305DE494C2}"/>
               </a:ext>
             </a:extLst>
           </p:cNvPr>
@@ -8607,33 +9318,39 @@
                 <a:ea typeface="Microsoft YaHei"/>
                 <a:cs typeface="Microsoft YaHei"/>
               </a:rPr>
-              <a:t>初始参照为3组；统一比较2—5组后选择最高轮廓系数。</a:t>
-            </a:r>
-          </a:p>
-        </p:txBody>
-      </p:sp>
-      <p:graphicFrame>
-        <p:nvGraphicFramePr>
-          <p:cNvPr id="13" name="Chart"/>
-          <p:cNvGraphicFramePr/>
-          <p:nvPr/>
-        </p:nvGraphicFramePr>
-        <p:xfrm>
-          <a:off xmlns:a="http://schemas.openxmlformats.org/drawingml/2006/main" x="619125" y="2381250"/>
-          <a:ext xmlns:a="http://schemas.openxmlformats.org/drawingml/2006/main" cx="6953250" cy="3667125"/>
-        </p:xfrm>
-        <a:graphic xmlns:a="http://schemas.openxmlformats.org/drawingml/2006/main">
-          <a:graphicData uri="http://schemas.openxmlformats.org/drawingml/2006/chart">
-            <c:chart xmlns:r="http://schemas.openxmlformats.org/officeDocument/2006/relationships" xmlns:c="http://schemas.openxmlformats.org/drawingml/2006/chart" r:id="R5e508f84bd8e4f5a"/>
-          </a:graphicData>
-        </a:graphic>
-      </p:graphicFrame>
+              <a:t>1公里范围采用功能类POI，相关关系不等于因果。</a:t>
+            </a:r>
+          </a:p>
+        </p:txBody>
+      </p:sp>
+      <p:pic>
+        <p:nvPicPr>
+          <p:cNvPr id="13" name=""/>
+          <p:cNvPicPr>
+            <a:picLocks xmlns:a="http://schemas.openxmlformats.org/drawingml/2006/main" noChangeAspect="1"/>
+          </p:cNvPicPr>
+          <p:nvPr/>
+        </p:nvPicPr>
+        <p:blipFill>
+          <a:blip xmlns:r="http://schemas.openxmlformats.org/officeDocument/2006/relationships" xmlns:a="http://schemas.openxmlformats.org/drawingml/2006/main" r:embed="Raf4065db0e484edd"/>
+          <a:stretch xmlns:a="http://schemas.openxmlformats.org/drawingml/2006/main"/>
+        </p:blipFill>
+        <p:spPr>
+          <a:xfrm xmlns:a="http://schemas.openxmlformats.org/drawingml/2006/main">
+            <a:off x="1709738" y="2286000"/>
+            <a:ext cx="4914900" cy="4095750"/>
+          </a:xfrm>
+          <a:prstGeom xmlns:a="http://schemas.openxmlformats.org/drawingml/2006/main" prst="rect">
+            <a:avLst/>
+          </a:prstGeom>
+        </p:spPr>
+      </p:pic>
       <p:sp>
         <p:nvSpPr>
           <p:cNvPr id="6" name="">
             <a:extLst xmlns:a="http://schemas.openxmlformats.org/drawingml/2006/main">
               <a:ext uri="{FF2B5EF4-FFF2-40B4-BE49-F238E27FC236}">
-                <a16:creationId xmlns:a16="http://schemas.microsoft.com/office/drawing/2014/main" id="{8D78E6D3-3457-48B1-9216-186BED7A9BCC}"/>
+                <a16:creationId xmlns:a16="http://schemas.microsoft.com/office/drawing/2014/main" id="{5FE5877F-638F-4B9B-9443-AF9C283DF226}"/>
               </a:ext>
             </a:extLst>
           </p:cNvPr>
@@ -8644,8 +9361,8 @@
         </p:nvSpPr>
         <p:spPr>
           <a:xfrm xmlns:a="http://schemas.openxmlformats.org/drawingml/2006/main">
-            <a:off x="8096250" y="2571750"/>
-            <a:ext cx="3505200" cy="923925"/>
+            <a:off x="8096250" y="2343150"/>
+            <a:ext cx="3476625" cy="1057275"/>
           </a:xfrm>
           <a:prstGeom xmlns:a="http://schemas.openxmlformats.org/drawingml/2006/main" prst="rect">
             <a:avLst/>
@@ -8663,7 +9380,7 @@
           <a:lstStyle xmlns:a="http://schemas.openxmlformats.org/drawingml/2006/main"/>
           <a:p xmlns:a="http://schemas.openxmlformats.org/drawingml/2006/main">
             <a:pPr>
-              <a:defRPr sz="2100" b="1">
+              <a:defRPr sz="2025" b="1">
                 <a:solidFill>
                   <a:srgbClr val="187887"/>
                 </a:solidFill>
@@ -8673,7 +9390,7 @@
               </a:defRPr>
             </a:pPr>
             <a:r>
-              <a:rPr sz="2100" b="1">
+              <a:rPr sz="2025" b="1">
                 <a:solidFill>
                   <a:srgbClr val="187887"/>
                 </a:solidFill>
@@ -8681,7 +9398,30 @@
                 <a:ea typeface="Microsoft YaHei"/>
                 <a:cs typeface="Microsoft YaHei"/>
               </a:rPr>
-              <a:t>175站 / 127站</a:t>
+              <a:t>密度与进站量</a:t>
+            </a:r>
+          </a:p>
+          <a:p xmlns:a="http://schemas.openxmlformats.org/drawingml/2006/main">
+            <a:pPr>
+              <a:defRPr sz="2025" b="1">
+                <a:solidFill>
+                  <a:srgbClr val="187887"/>
+                </a:solidFill>
+                <a:latin typeface="Microsoft YaHei"/>
+                <a:ea typeface="Microsoft YaHei"/>
+                <a:cs typeface="Microsoft YaHei"/>
+              </a:defRPr>
+            </a:pPr>
+            <a:r>
+              <a:rPr sz="2025" b="1">
+                <a:solidFill>
+                  <a:srgbClr val="187887"/>
+                </a:solidFill>
+                <a:latin typeface="Microsoft YaHei"/>
+                <a:ea typeface="Microsoft YaHei"/>
+                <a:cs typeface="Microsoft YaHei"/>
+              </a:rPr>
+              <a:t>Spearman ρ = 0.627</a:t>
             </a:r>
           </a:p>
         </p:txBody>
@@ -8691,7 +9431,7 @@
           <p:cNvPr id="7" name="">
             <a:extLst xmlns:a="http://schemas.openxmlformats.org/drawingml/2006/main">
               <a:ext uri="{FF2B5EF4-FFF2-40B4-BE49-F238E27FC236}">
-                <a16:creationId xmlns:a16="http://schemas.microsoft.com/office/drawing/2014/main" id="{BA65DB99-06F8-4734-9335-60571F65166E}"/>
+                <a16:creationId xmlns:a16="http://schemas.microsoft.com/office/drawing/2014/main" id="{7A581333-FBB4-4EBE-83D2-80B29A289BD1}"/>
               </a:ext>
             </a:extLst>
           </p:cNvPr>
@@ -8702,8 +9442,8 @@
         </p:nvSpPr>
         <p:spPr>
           <a:xfrm xmlns:a="http://schemas.openxmlformats.org/drawingml/2006/main">
-            <a:off x="8096250" y="3638550"/>
-            <a:ext cx="3505200" cy="923925"/>
+            <a:off x="8096250" y="3543300"/>
+            <a:ext cx="3476625" cy="1057275"/>
           </a:xfrm>
           <a:prstGeom xmlns:a="http://schemas.openxmlformats.org/drawingml/2006/main" prst="rect">
             <a:avLst/>
@@ -8721,48 +9461,48 @@
           <a:lstStyle xmlns:a="http://schemas.openxmlformats.org/drawingml/2006/main"/>
           <a:p xmlns:a="http://schemas.openxmlformats.org/drawingml/2006/main">
             <a:pPr>
-              <a:defRPr sz="2100" b="0">
-                <a:solidFill>
-                  <a:srgbClr val="123442"/>
-                </a:solidFill>
-                <a:latin typeface="Microsoft YaHei"/>
-                <a:ea typeface="Microsoft YaHei"/>
-                <a:cs typeface="Microsoft YaHei"/>
-              </a:defRPr>
-            </a:pPr>
-            <a:r>
-              <a:rPr sz="2100" b="0">
-                <a:solidFill>
-                  <a:srgbClr val="123442"/>
-                </a:solidFill>
-                <a:latin typeface="Microsoft YaHei"/>
-                <a:ea typeface="Microsoft YaHei"/>
-                <a:cs typeface="Microsoft YaHei"/>
-              </a:rPr>
-              <a:t>输入：两类日期 ×</a:t>
-            </a:r>
-          </a:p>
-          <a:p xmlns:a="http://schemas.openxmlformats.org/drawingml/2006/main">
-            <a:pPr>
-              <a:defRPr sz="2100" b="0">
-                <a:solidFill>
-                  <a:srgbClr val="123442"/>
-                </a:solidFill>
-                <a:latin typeface="Microsoft YaHei"/>
-                <a:ea typeface="Microsoft YaHei"/>
-                <a:cs typeface="Microsoft YaHei"/>
-              </a:defRPr>
-            </a:pPr>
-            <a:r>
-              <a:rPr sz="2100" b="0">
-                <a:solidFill>
-                  <a:srgbClr val="123442"/>
-                </a:solidFill>
-                <a:latin typeface="Microsoft YaHei"/>
-                <a:ea typeface="Microsoft YaHei"/>
-                <a:cs typeface="Microsoft YaHei"/>
-              </a:rPr>
-              <a:t>17小时 × 进出 = 68项</a:t>
+              <a:defRPr sz="2025" b="0">
+                <a:solidFill>
+                  <a:srgbClr val="123442"/>
+                </a:solidFill>
+                <a:latin typeface="Microsoft YaHei"/>
+                <a:ea typeface="Microsoft YaHei"/>
+                <a:cs typeface="Microsoft YaHei"/>
+              </a:defRPr>
+            </a:pPr>
+            <a:r>
+              <a:rPr sz="2025" b="0">
+                <a:solidFill>
+                  <a:srgbClr val="123442"/>
+                </a:solidFill>
+                <a:latin typeface="Microsoft YaHei"/>
+                <a:ea typeface="Microsoft YaHei"/>
+                <a:cs typeface="Microsoft YaHei"/>
+              </a:rPr>
+              <a:t>95%自助法区间</a:t>
+            </a:r>
+          </a:p>
+          <a:p xmlns:a="http://schemas.openxmlformats.org/drawingml/2006/main">
+            <a:pPr>
+              <a:defRPr sz="2025" b="0">
+                <a:solidFill>
+                  <a:srgbClr val="123442"/>
+                </a:solidFill>
+                <a:latin typeface="Microsoft YaHei"/>
+                <a:ea typeface="Microsoft YaHei"/>
+                <a:cs typeface="Microsoft YaHei"/>
+              </a:defRPr>
+            </a:pPr>
+            <a:r>
+              <a:rPr sz="2025" b="0">
+                <a:solidFill>
+                  <a:srgbClr val="123442"/>
+                </a:solidFill>
+                <a:latin typeface="Microsoft YaHei"/>
+                <a:ea typeface="Microsoft YaHei"/>
+                <a:cs typeface="Microsoft YaHei"/>
+              </a:rPr>
+              <a:t>0.539—0.698</a:t>
             </a:r>
           </a:p>
         </p:txBody>
@@ -8772,7 +9512,7 @@
           <p:cNvPr id="8" name="">
             <a:extLst xmlns:a="http://schemas.openxmlformats.org/drawingml/2006/main">
               <a:ext uri="{FF2B5EF4-FFF2-40B4-BE49-F238E27FC236}">
-                <a16:creationId xmlns:a16="http://schemas.microsoft.com/office/drawing/2014/main" id="{BCF8FC0D-937B-4C46-999A-52548810E7D7}"/>
+                <a16:creationId xmlns:a16="http://schemas.microsoft.com/office/drawing/2014/main" id="{46AAF6AD-811D-4E67-95EA-12BB96A2B2F8}"/>
               </a:ext>
             </a:extLst>
           </p:cNvPr>
@@ -8783,8 +9523,8 @@
         </p:nvSpPr>
         <p:spPr>
           <a:xfrm xmlns:a="http://schemas.openxmlformats.org/drawingml/2006/main">
-            <a:off x="8096250" y="4705350"/>
-            <a:ext cx="3505200" cy="923925"/>
+            <a:off x="8096250" y="4743450"/>
+            <a:ext cx="3476625" cy="1057275"/>
           </a:xfrm>
           <a:prstGeom xmlns:a="http://schemas.openxmlformats.org/drawingml/2006/main" prst="rect">
             <a:avLst/>
@@ -8802,48 +9542,48 @@
           <a:lstStyle xmlns:a="http://schemas.openxmlformats.org/drawingml/2006/main"/>
           <a:p xmlns:a="http://schemas.openxmlformats.org/drawingml/2006/main">
             <a:pPr>
-              <a:defRPr sz="2100" b="0">
-                <a:solidFill>
-                  <a:srgbClr val="123442"/>
-                </a:solidFill>
-                <a:latin typeface="Microsoft YaHei"/>
-                <a:ea typeface="Microsoft YaHei"/>
-                <a:cs typeface="Microsoft YaHei"/>
-              </a:defRPr>
-            </a:pPr>
-            <a:r>
-              <a:rPr sz="2100" b="0">
-                <a:solidFill>
-                  <a:srgbClr val="123442"/>
-                </a:solidFill>
-                <a:latin typeface="Microsoft YaHei"/>
-                <a:ea typeface="Microsoft YaHei"/>
-                <a:cs typeface="Microsoft YaHei"/>
-              </a:rPr>
-              <a:t>评价已有数据的结构</a:t>
-            </a:r>
-          </a:p>
-          <a:p xmlns:a="http://schemas.openxmlformats.org/drawingml/2006/main">
-            <a:pPr>
-              <a:defRPr sz="2100" b="0">
-                <a:solidFill>
-                  <a:srgbClr val="123442"/>
-                </a:solidFill>
-                <a:latin typeface="Microsoft YaHei"/>
-                <a:ea typeface="Microsoft YaHei"/>
-                <a:cs typeface="Microsoft YaHei"/>
-              </a:defRPr>
-            </a:pPr>
-            <a:r>
-              <a:rPr sz="2100" b="0">
-                <a:solidFill>
-                  <a:srgbClr val="123442"/>
-                </a:solidFill>
-                <a:latin typeface="Microsoft YaHei"/>
-                <a:ea typeface="Microsoft YaHei"/>
-                <a:cs typeface="Microsoft YaHei"/>
-              </a:rPr>
-              <a:t>不代表预测准确率</a:t>
+              <a:defRPr sz="2025" b="0">
+                <a:solidFill>
+                  <a:srgbClr val="123442"/>
+                </a:solidFill>
+                <a:latin typeface="Microsoft YaHei"/>
+                <a:ea typeface="Microsoft YaHei"/>
+                <a:cs typeface="Microsoft YaHei"/>
+              </a:defRPr>
+            </a:pPr>
+            <a:r>
+              <a:rPr sz="2025" b="0">
+                <a:solidFill>
+                  <a:srgbClr val="123442"/>
+                </a:solidFill>
+                <a:latin typeface="Microsoft YaHei"/>
+                <a:ea typeface="Microsoft YaHei"/>
+                <a:cs typeface="Microsoft YaHei"/>
+              </a:rPr>
+              <a:t>高密度组客流中位数</a:t>
+            </a:r>
+          </a:p>
+          <a:p xmlns:a="http://schemas.openxmlformats.org/drawingml/2006/main">
+            <a:pPr>
+              <a:defRPr sz="2025" b="0">
+                <a:solidFill>
+                  <a:srgbClr val="123442"/>
+                </a:solidFill>
+                <a:latin typeface="Microsoft YaHei"/>
+                <a:ea typeface="Microsoft YaHei"/>
+                <a:cs typeface="Microsoft YaHei"/>
+              </a:defRPr>
+            </a:pPr>
+            <a:r>
+              <a:rPr sz="2025" b="0">
+                <a:solidFill>
+                  <a:srgbClr val="123442"/>
+                </a:solidFill>
+                <a:latin typeface="Microsoft YaHei"/>
+                <a:ea typeface="Microsoft YaHei"/>
+                <a:cs typeface="Microsoft YaHei"/>
+              </a:rPr>
+              <a:t>是低密度组的3.30倍</a:t>
             </a:r>
           </a:p>
         </p:txBody>
@@ -8851,7 +9591,7 @@
     </p:spTree>
     <p:extLst>
       <p:ext uri="{BB962C8B-B14F-4D97-AF65-F5344CB8AC3E}">
-        <p14:creationId xmlns:p14="http://schemas.microsoft.com/office/powerpoint/2010/main" val="2839432"/>
+        <p14:creationId xmlns:p14="http://schemas.microsoft.com/office/powerpoint/2010/main" val="1712765183"/>
       </p:ext>
     </p:extLst>
   </p:cSld>

</xml_diff>